<commit_message>
updates to thurstone blog. Getting close to code section.
</commit_message>
<xml_diff>
--- a/_site/assets/images/thurstone_blog/densities_editable.pptx
+++ b/_site/assets/images/thurstone_blog/densities_editable.pptx
@@ -6,6 +6,7 @@
   </p:sldMasterIdLst>
   <p:sldIdLst>
     <p:sldId id="256" r:id="rId2"/>
+    <p:sldId id="257" r:id="rId3"/>
   </p:sldIdLst>
   <p:sldSz cx="12192000" cy="6858000"/>
   <p:notesSz cx="6858000" cy="9144000"/>
@@ -107,12 +108,12 @@
   <p:extLst>
     <p:ext uri="{EFAFB233-063F-42B5-8137-9DF3F51BA10A}">
       <p15:sldGuideLst xmlns:p15="http://schemas.microsoft.com/office/powerpoint/2012/main">
-        <p15:guide id="1" orient="horz" pos="2160" userDrawn="1">
+        <p15:guide id="1" orient="horz" pos="3216" userDrawn="1">
           <p15:clr>
             <a:srgbClr val="A4A3A4"/>
           </p15:clr>
         </p15:guide>
-        <p15:guide id="2" pos="3840" userDrawn="1">
+        <p15:guide id="2" pos="3816" userDrawn="1">
           <p15:clr>
             <a:srgbClr val="A4A3A4"/>
           </p15:clr>
@@ -270,7 +271,7 @@
           <a:p>
             <a:fld id="{E6F6D8E5-6BA1-2B4B-963D-F2E25306724E}" type="datetimeFigureOut">
               <a:rPr lang="en-US" smtClean="0"/>
-              <a:t>7/31/24</a:t>
+              <a:t>8/6/24</a:t>
             </a:fld>
             <a:endParaRPr lang="en-US"/>
           </a:p>
@@ -468,7 +469,7 @@
           <a:p>
             <a:fld id="{E6F6D8E5-6BA1-2B4B-963D-F2E25306724E}" type="datetimeFigureOut">
               <a:rPr lang="en-US" smtClean="0"/>
-              <a:t>7/31/24</a:t>
+              <a:t>8/6/24</a:t>
             </a:fld>
             <a:endParaRPr lang="en-US"/>
           </a:p>
@@ -676,7 +677,7 @@
           <a:p>
             <a:fld id="{E6F6D8E5-6BA1-2B4B-963D-F2E25306724E}" type="datetimeFigureOut">
               <a:rPr lang="en-US" smtClean="0"/>
-              <a:t>7/31/24</a:t>
+              <a:t>8/6/24</a:t>
             </a:fld>
             <a:endParaRPr lang="en-US"/>
           </a:p>
@@ -874,7 +875,7 @@
           <a:p>
             <a:fld id="{E6F6D8E5-6BA1-2B4B-963D-F2E25306724E}" type="datetimeFigureOut">
               <a:rPr lang="en-US" smtClean="0"/>
-              <a:t>7/31/24</a:t>
+              <a:t>8/6/24</a:t>
             </a:fld>
             <a:endParaRPr lang="en-US"/>
           </a:p>
@@ -1149,7 +1150,7 @@
           <a:p>
             <a:fld id="{E6F6D8E5-6BA1-2B4B-963D-F2E25306724E}" type="datetimeFigureOut">
               <a:rPr lang="en-US" smtClean="0"/>
-              <a:t>7/31/24</a:t>
+              <a:t>8/6/24</a:t>
             </a:fld>
             <a:endParaRPr lang="en-US"/>
           </a:p>
@@ -1414,7 +1415,7 @@
           <a:p>
             <a:fld id="{E6F6D8E5-6BA1-2B4B-963D-F2E25306724E}" type="datetimeFigureOut">
               <a:rPr lang="en-US" smtClean="0"/>
-              <a:t>7/31/24</a:t>
+              <a:t>8/6/24</a:t>
             </a:fld>
             <a:endParaRPr lang="en-US"/>
           </a:p>
@@ -1826,7 +1827,7 @@
           <a:p>
             <a:fld id="{E6F6D8E5-6BA1-2B4B-963D-F2E25306724E}" type="datetimeFigureOut">
               <a:rPr lang="en-US" smtClean="0"/>
-              <a:t>7/31/24</a:t>
+              <a:t>8/6/24</a:t>
             </a:fld>
             <a:endParaRPr lang="en-US"/>
           </a:p>
@@ -1967,7 +1968,7 @@
           <a:p>
             <a:fld id="{E6F6D8E5-6BA1-2B4B-963D-F2E25306724E}" type="datetimeFigureOut">
               <a:rPr lang="en-US" smtClean="0"/>
-              <a:t>7/31/24</a:t>
+              <a:t>8/6/24</a:t>
             </a:fld>
             <a:endParaRPr lang="en-US"/>
           </a:p>
@@ -2080,7 +2081,7 @@
           <a:p>
             <a:fld id="{E6F6D8E5-6BA1-2B4B-963D-F2E25306724E}" type="datetimeFigureOut">
               <a:rPr lang="en-US" smtClean="0"/>
-              <a:t>7/31/24</a:t>
+              <a:t>8/6/24</a:t>
             </a:fld>
             <a:endParaRPr lang="en-US"/>
           </a:p>
@@ -2391,7 +2392,7 @@
           <a:p>
             <a:fld id="{E6F6D8E5-6BA1-2B4B-963D-F2E25306724E}" type="datetimeFigureOut">
               <a:rPr lang="en-US" smtClean="0"/>
-              <a:t>7/31/24</a:t>
+              <a:t>8/6/24</a:t>
             </a:fld>
             <a:endParaRPr lang="en-US"/>
           </a:p>
@@ -2679,7 +2680,7 @@
           <a:p>
             <a:fld id="{E6F6D8E5-6BA1-2B4B-963D-F2E25306724E}" type="datetimeFigureOut">
               <a:rPr lang="en-US" smtClean="0"/>
-              <a:t>7/31/24</a:t>
+              <a:t>8/6/24</a:t>
             </a:fld>
             <a:endParaRPr lang="en-US"/>
           </a:p>
@@ -2920,7 +2921,7 @@
           <a:p>
             <a:fld id="{E6F6D8E5-6BA1-2B4B-963D-F2E25306724E}" type="datetimeFigureOut">
               <a:rPr lang="en-US" smtClean="0"/>
-              <a:t>7/31/24</a:t>
+              <a:t>8/6/24</a:t>
             </a:fld>
             <a:endParaRPr lang="en-US"/>
           </a:p>
@@ -3387,8 +3388,8 @@
             </a:prstGeom>
           </p:spPr>
         </p:pic>
-        <mc:AlternateContent xmlns:mc="http://schemas.openxmlformats.org/markup-compatibility/2006">
-          <mc:Choice xmlns:a14="http://schemas.microsoft.com/office/drawing/2010/main" Requires="a14">
+        <mc:AlternateContent xmlns:mc="http://schemas.openxmlformats.org/markup-compatibility/2006" xmlns:a14="http://schemas.microsoft.com/office/drawing/2010/main">
+          <mc:Choice Requires="a14">
             <p:sp>
               <p:nvSpPr>
                 <p:cNvPr id="6" name="TextBox 5">
@@ -3417,6 +3418,7 @@
                 </a:bodyPr>
                 <a:lstStyle/>
                 <a:p>
+                  <a:pPr/>
                   <a14:m>
                     <m:oMathPara xmlns:m="http://schemas.openxmlformats.org/officeDocument/2006/math">
                       <m:oMathParaPr>
@@ -3492,7 +3494,7 @@
               </p:txBody>
             </p:sp>
           </mc:Choice>
-          <mc:Fallback>
+          <mc:Fallback xmlns="">
             <p:sp>
               <p:nvSpPr>
                 <p:cNvPr id="6" name="TextBox 5">
@@ -3537,8 +3539,8 @@
             </p:sp>
           </mc:Fallback>
         </mc:AlternateContent>
-        <mc:AlternateContent xmlns:mc="http://schemas.openxmlformats.org/markup-compatibility/2006">
-          <mc:Choice xmlns:a14="http://schemas.microsoft.com/office/drawing/2010/main" Requires="a14">
+        <mc:AlternateContent xmlns:mc="http://schemas.openxmlformats.org/markup-compatibility/2006" xmlns:a14="http://schemas.microsoft.com/office/drawing/2010/main">
+          <mc:Choice Requires="a14">
             <p:sp>
               <p:nvSpPr>
                 <p:cNvPr id="7" name="TextBox 6">
@@ -3567,6 +3569,7 @@
                 </a:bodyPr>
                 <a:lstStyle/>
                 <a:p>
+                  <a:pPr/>
                   <a14:m>
                     <m:oMathPara xmlns:m="http://schemas.openxmlformats.org/officeDocument/2006/math">
                       <m:oMathParaPr>
@@ -3642,7 +3645,7 @@
               </p:txBody>
             </p:sp>
           </mc:Choice>
-          <mc:Fallback>
+          <mc:Fallback xmlns="">
             <p:sp>
               <p:nvSpPr>
                 <p:cNvPr id="7" name="TextBox 6">
@@ -3687,8 +3690,8 @@
             </p:sp>
           </mc:Fallback>
         </mc:AlternateContent>
-        <mc:AlternateContent xmlns:mc="http://schemas.openxmlformats.org/markup-compatibility/2006">
-          <mc:Choice xmlns:a14="http://schemas.microsoft.com/office/drawing/2010/main" Requires="a14">
+        <mc:AlternateContent xmlns:mc="http://schemas.openxmlformats.org/markup-compatibility/2006" xmlns:a14="http://schemas.microsoft.com/office/drawing/2010/main">
+          <mc:Choice Requires="a14">
             <p:sp>
               <p:nvSpPr>
                 <p:cNvPr id="8" name="TextBox 7">
@@ -3717,6 +3720,7 @@
                 </a:bodyPr>
                 <a:lstStyle/>
                 <a:p>
+                  <a:pPr/>
                   <a14:m>
                     <m:oMathPara xmlns:m="http://schemas.openxmlformats.org/officeDocument/2006/math">
                       <m:oMathParaPr>
@@ -3792,7 +3796,7 @@
               </p:txBody>
             </p:sp>
           </mc:Choice>
-          <mc:Fallback>
+          <mc:Fallback xmlns="">
             <p:sp>
               <p:nvSpPr>
                 <p:cNvPr id="8" name="TextBox 7">
@@ -3837,8 +3841,8 @@
             </p:sp>
           </mc:Fallback>
         </mc:AlternateContent>
-        <mc:AlternateContent xmlns:mc="http://schemas.openxmlformats.org/markup-compatibility/2006">
-          <mc:Choice xmlns:a14="http://schemas.microsoft.com/office/drawing/2010/main" Requires="a14">
+        <mc:AlternateContent xmlns:mc="http://schemas.openxmlformats.org/markup-compatibility/2006" xmlns:a14="http://schemas.microsoft.com/office/drawing/2010/main">
+          <mc:Choice Requires="a14">
             <p:sp>
               <p:nvSpPr>
                 <p:cNvPr id="9" name="TextBox 8">
@@ -3867,6 +3871,7 @@
                 </a:bodyPr>
                 <a:lstStyle/>
                 <a:p>
+                  <a:pPr/>
                   <a14:m>
                     <m:oMathPara xmlns:m="http://schemas.openxmlformats.org/officeDocument/2006/math">
                       <m:oMathParaPr>
@@ -3942,7 +3947,7 @@
               </p:txBody>
             </p:sp>
           </mc:Choice>
-          <mc:Fallback>
+          <mc:Fallback xmlns="">
             <p:sp>
               <p:nvSpPr>
                 <p:cNvPr id="9" name="TextBox 8">
@@ -4155,8 +4160,8 @@
             </a:fontRef>
           </p:style>
         </p:cxnSp>
-        <mc:AlternateContent xmlns:mc="http://schemas.openxmlformats.org/markup-compatibility/2006">
-          <mc:Choice xmlns:a14="http://schemas.microsoft.com/office/drawing/2010/main" Requires="a14">
+        <mc:AlternateContent xmlns:mc="http://schemas.openxmlformats.org/markup-compatibility/2006" xmlns:a14="http://schemas.microsoft.com/office/drawing/2010/main">
+          <mc:Choice Requires="a14">
             <p:sp>
               <p:nvSpPr>
                 <p:cNvPr id="15" name="TextBox 14">
@@ -4185,6 +4190,7 @@
                 </a:bodyPr>
                 <a:lstStyle/>
                 <a:p>
+                  <a:pPr/>
                   <a14:m>
                     <m:oMathPara xmlns:m="http://schemas.openxmlformats.org/officeDocument/2006/math">
                       <m:oMathParaPr>
@@ -4237,7 +4243,7 @@
               </p:txBody>
             </p:sp>
           </mc:Choice>
-          <mc:Fallback>
+          <mc:Fallback xmlns="">
             <p:sp>
               <p:nvSpPr>
                 <p:cNvPr id="15" name="TextBox 14">
@@ -4282,8 +4288,8 @@
             </p:sp>
           </mc:Fallback>
         </mc:AlternateContent>
-        <mc:AlternateContent xmlns:mc="http://schemas.openxmlformats.org/markup-compatibility/2006">
-          <mc:Choice xmlns:a14="http://schemas.microsoft.com/office/drawing/2010/main" Requires="a14">
+        <mc:AlternateContent xmlns:mc="http://schemas.openxmlformats.org/markup-compatibility/2006" xmlns:a14="http://schemas.microsoft.com/office/drawing/2010/main">
+          <mc:Choice Requires="a14">
             <p:sp>
               <p:nvSpPr>
                 <p:cNvPr id="16" name="TextBox 15">
@@ -4312,6 +4318,7 @@
                 </a:bodyPr>
                 <a:lstStyle/>
                 <a:p>
+                  <a:pPr/>
                   <a14:m>
                     <m:oMathPara xmlns:m="http://schemas.openxmlformats.org/officeDocument/2006/math">
                       <m:oMathParaPr>
@@ -4364,7 +4371,7 @@
               </p:txBody>
             </p:sp>
           </mc:Choice>
-          <mc:Fallback>
+          <mc:Fallback xmlns="">
             <p:sp>
               <p:nvSpPr>
                 <p:cNvPr id="16" name="TextBox 15">
@@ -4409,8 +4416,8 @@
             </p:sp>
           </mc:Fallback>
         </mc:AlternateContent>
-        <mc:AlternateContent xmlns:mc="http://schemas.openxmlformats.org/markup-compatibility/2006">
-          <mc:Choice xmlns:a14="http://schemas.microsoft.com/office/drawing/2010/main" Requires="a14">
+        <mc:AlternateContent xmlns:mc="http://schemas.openxmlformats.org/markup-compatibility/2006" xmlns:a14="http://schemas.microsoft.com/office/drawing/2010/main">
+          <mc:Choice Requires="a14">
             <p:sp>
               <p:nvSpPr>
                 <p:cNvPr id="17" name="TextBox 16">
@@ -4439,6 +4446,7 @@
                 </a:bodyPr>
                 <a:lstStyle/>
                 <a:p>
+                  <a:pPr/>
                   <a14:m>
                     <m:oMathPara xmlns:m="http://schemas.openxmlformats.org/officeDocument/2006/math">
                       <m:oMathParaPr>
@@ -4491,7 +4499,7 @@
               </p:txBody>
             </p:sp>
           </mc:Choice>
-          <mc:Fallback>
+          <mc:Fallback xmlns="">
             <p:sp>
               <p:nvSpPr>
                 <p:cNvPr id="17" name="TextBox 16">
@@ -4536,8 +4544,8 @@
             </p:sp>
           </mc:Fallback>
         </mc:AlternateContent>
-        <mc:AlternateContent xmlns:mc="http://schemas.openxmlformats.org/markup-compatibility/2006">
-          <mc:Choice xmlns:a14="http://schemas.microsoft.com/office/drawing/2010/main" Requires="a14">
+        <mc:AlternateContent xmlns:mc="http://schemas.openxmlformats.org/markup-compatibility/2006" xmlns:a14="http://schemas.microsoft.com/office/drawing/2010/main">
+          <mc:Choice Requires="a14">
             <p:sp>
               <p:nvSpPr>
                 <p:cNvPr id="18" name="TextBox 17">
@@ -4566,6 +4574,7 @@
                 </a:bodyPr>
                 <a:lstStyle/>
                 <a:p>
+                  <a:pPr/>
                   <a14:m>
                     <m:oMathPara xmlns:m="http://schemas.openxmlformats.org/officeDocument/2006/math">
                       <m:oMathParaPr>
@@ -4618,7 +4627,7 @@
               </p:txBody>
             </p:sp>
           </mc:Choice>
-          <mc:Fallback>
+          <mc:Fallback xmlns="">
             <p:sp>
               <p:nvSpPr>
                 <p:cNvPr id="18" name="TextBox 17">
@@ -4668,6 +4677,4516 @@
     <p:extLst>
       <p:ext uri="{BB962C8B-B14F-4D97-AF65-F5344CB8AC3E}">
         <p14:creationId xmlns:p14="http://schemas.microsoft.com/office/powerpoint/2010/main" val="3178758554"/>
+      </p:ext>
+    </p:extLst>
+  </p:cSld>
+  <p:clrMapOvr>
+    <a:masterClrMapping/>
+  </p:clrMapOvr>
+</p:sld>
+</file>
+
+<file path=ppt/slides/slide2.xml><?xml version="1.0" encoding="utf-8"?>
+<p:sld xmlns:a="http://schemas.openxmlformats.org/drawingml/2006/main" xmlns:r="http://schemas.openxmlformats.org/officeDocument/2006/relationships" xmlns:p="http://schemas.openxmlformats.org/presentationml/2006/main">
+  <p:cSld>
+    <p:bg>
+      <p:bgPr>
+        <a:solidFill>
+          <a:schemeClr val="bg1"/>
+        </a:solidFill>
+        <a:effectLst/>
+      </p:bgPr>
+    </p:bg>
+    <p:spTree>
+      <p:nvGrpSpPr>
+        <p:cNvPr id="1" name=""/>
+        <p:cNvGrpSpPr/>
+        <p:nvPr/>
+      </p:nvGrpSpPr>
+      <p:grpSpPr>
+        <a:xfrm>
+          <a:off x="0" y="0"/>
+          <a:ext cx="0" cy="0"/>
+          <a:chOff x="0" y="0"/>
+          <a:chExt cx="0" cy="0"/>
+        </a:xfrm>
+      </p:grpSpPr>
+      <p:grpSp>
+        <p:nvGrpSpPr>
+          <p:cNvPr id="168" name="Group 167">
+            <a:extLst>
+              <a:ext uri="{FF2B5EF4-FFF2-40B4-BE49-F238E27FC236}">
+                <a16:creationId xmlns:a16="http://schemas.microsoft.com/office/drawing/2014/main" id="{898E96EC-3174-00AA-50F2-EC09EA039EE4}"/>
+              </a:ext>
+            </a:extLst>
+          </p:cNvPr>
+          <p:cNvGrpSpPr/>
+          <p:nvPr/>
+        </p:nvGrpSpPr>
+        <p:grpSpPr>
+          <a:xfrm>
+            <a:off x="1238842" y="27776"/>
+            <a:ext cx="9618294" cy="6541742"/>
+            <a:chOff x="1238842" y="27776"/>
+            <a:chExt cx="9618294" cy="6541742"/>
+          </a:xfrm>
+        </p:grpSpPr>
+        <p:grpSp>
+          <p:nvGrpSpPr>
+            <p:cNvPr id="6" name="Group 5">
+              <a:extLst>
+                <a:ext uri="{FF2B5EF4-FFF2-40B4-BE49-F238E27FC236}">
+                  <a16:creationId xmlns:a16="http://schemas.microsoft.com/office/drawing/2014/main" id="{7758C0EA-AB7E-1234-D608-95F3096CEFD8}"/>
+                </a:ext>
+              </a:extLst>
+            </p:cNvPr>
+            <p:cNvGrpSpPr/>
+            <p:nvPr/>
+          </p:nvGrpSpPr>
+          <p:grpSpPr>
+            <a:xfrm>
+              <a:off x="3823489" y="794634"/>
+              <a:ext cx="914400" cy="914400"/>
+              <a:chOff x="2060003" y="1104900"/>
+              <a:chExt cx="914400" cy="914400"/>
+            </a:xfrm>
+          </p:grpSpPr>
+          <mc:AlternateContent xmlns:mc="http://schemas.openxmlformats.org/markup-compatibility/2006">
+            <mc:Choice xmlns:a14="http://schemas.microsoft.com/office/drawing/2010/main" Requires="a14">
+              <p:sp>
+                <p:nvSpPr>
+                  <p:cNvPr id="4" name="TextBox 3">
+                    <a:extLst>
+                      <a:ext uri="{FF2B5EF4-FFF2-40B4-BE49-F238E27FC236}">
+                        <a16:creationId xmlns:a16="http://schemas.microsoft.com/office/drawing/2014/main" id="{FD310A9A-29EE-97A1-2D84-D5C51E36E171}"/>
+                      </a:ext>
+                    </a:extLst>
+                  </p:cNvPr>
+                  <p:cNvSpPr txBox="1"/>
+                  <p:nvPr/>
+                </p:nvSpPr>
+                <p:spPr>
+                  <a:xfrm>
+                    <a:off x="2202700" y="1213757"/>
+                    <a:ext cx="771703" cy="646331"/>
+                  </a:xfrm>
+                  <a:prstGeom prst="rect">
+                    <a:avLst/>
+                  </a:prstGeom>
+                  <a:noFill/>
+                </p:spPr>
+                <p:txBody>
+                  <a:bodyPr wrap="square" rtlCol="0" anchor="ctr">
+                    <a:spAutoFit/>
+                  </a:bodyPr>
+                  <a:lstStyle/>
+                  <a:p>
+                    <a:pPr/>
+                    <a14:m>
+                      <m:oMathPara xmlns:m="http://schemas.openxmlformats.org/officeDocument/2006/math">
+                        <m:oMathParaPr>
+                          <m:jc m:val="center"/>
+                        </m:oMathParaPr>
+                        <m:oMath xmlns:m="http://schemas.openxmlformats.org/officeDocument/2006/math">
+                          <m:sSub>
+                            <m:sSubPr>
+                              <m:ctrlPr>
+                                <a:rPr lang="en-US" sz="3600" i="1" smtClean="0">
+                                  <a:latin typeface="Cambria Math" panose="02040503050406030204" pitchFamily="18" charset="0"/>
+                                </a:rPr>
+                              </m:ctrlPr>
+                            </m:sSubPr>
+                            <m:e>
+                              <m:r>
+                                <a:rPr lang="en-US" sz="3600" i="1" smtClean="0">
+                                  <a:latin typeface="Cambria Math" panose="02040503050406030204" pitchFamily="18" charset="0"/>
+                                </a:rPr>
+                                <m:t>𝜇</m:t>
+                              </m:r>
+                            </m:e>
+                            <m:sub>
+                              <m:r>
+                                <a:rPr lang="en-US" sz="3600" b="0" i="1" smtClean="0">
+                                  <a:latin typeface="Cambria Math" panose="02040503050406030204" pitchFamily="18" charset="0"/>
+                                </a:rPr>
+                                <m:t>1</m:t>
+                              </m:r>
+                            </m:sub>
+                          </m:sSub>
+                        </m:oMath>
+                      </m:oMathPara>
+                    </a14:m>
+                    <a:endParaRPr lang="en-US" sz="3600" dirty="0"/>
+                  </a:p>
+                </p:txBody>
+              </p:sp>
+            </mc:Choice>
+            <mc:Fallback>
+              <p:sp>
+                <p:nvSpPr>
+                  <p:cNvPr id="4" name="TextBox 3">
+                    <a:extLst>
+                      <a:ext uri="{FF2B5EF4-FFF2-40B4-BE49-F238E27FC236}">
+                        <a16:creationId xmlns:a16="http://schemas.microsoft.com/office/drawing/2014/main" id="{FD310A9A-29EE-97A1-2D84-D5C51E36E171}"/>
+                      </a:ext>
+                    </a:extLst>
+                  </p:cNvPr>
+                  <p:cNvSpPr txBox="1">
+                    <a:spLocks noRot="1" noChangeAspect="1" noMove="1" noResize="1" noEditPoints="1" noAdjustHandles="1" noChangeArrowheads="1" noChangeShapeType="1" noTextEdit="1"/>
+                  </p:cNvSpPr>
+                  <p:nvPr/>
+                </p:nvSpPr>
+                <p:spPr>
+                  <a:xfrm>
+                    <a:off x="2202700" y="1213757"/>
+                    <a:ext cx="771703" cy="646331"/>
+                  </a:xfrm>
+                  <a:prstGeom prst="rect">
+                    <a:avLst/>
+                  </a:prstGeom>
+                  <a:blipFill>
+                    <a:blip r:embed="rId2"/>
+                    <a:stretch>
+                      <a:fillRect b="-11765"/>
+                    </a:stretch>
+                  </a:blipFill>
+                </p:spPr>
+                <p:txBody>
+                  <a:bodyPr/>
+                  <a:lstStyle/>
+                  <a:p>
+                    <a:r>
+                      <a:rPr lang="en-US">
+                        <a:noFill/>
+                      </a:rPr>
+                      <a:t> </a:t>
+                    </a:r>
+                  </a:p>
+                </p:txBody>
+              </p:sp>
+            </mc:Fallback>
+          </mc:AlternateContent>
+          <p:sp>
+            <p:nvSpPr>
+              <p:cNvPr id="5" name="Oval 4">
+                <a:extLst>
+                  <a:ext uri="{FF2B5EF4-FFF2-40B4-BE49-F238E27FC236}">
+                    <a16:creationId xmlns:a16="http://schemas.microsoft.com/office/drawing/2014/main" id="{00FC6FCC-662F-42B3-935C-49775E3C7576}"/>
+                  </a:ext>
+                </a:extLst>
+              </p:cNvPr>
+              <p:cNvSpPr/>
+              <p:nvPr/>
+            </p:nvSpPr>
+            <p:spPr>
+              <a:xfrm>
+                <a:off x="2060003" y="1104900"/>
+                <a:ext cx="914400" cy="914400"/>
+              </a:xfrm>
+              <a:prstGeom prst="ellipse">
+                <a:avLst/>
+              </a:prstGeom>
+              <a:noFill/>
+              <a:ln>
+                <a:solidFill>
+                  <a:schemeClr val="tx1"/>
+                </a:solidFill>
+              </a:ln>
+            </p:spPr>
+            <p:style>
+              <a:lnRef idx="2">
+                <a:schemeClr val="accent1">
+                  <a:shade val="15000"/>
+                </a:schemeClr>
+              </a:lnRef>
+              <a:fillRef idx="1">
+                <a:schemeClr val="accent1"/>
+              </a:fillRef>
+              <a:effectRef idx="0">
+                <a:schemeClr val="accent1"/>
+              </a:effectRef>
+              <a:fontRef idx="minor">
+                <a:schemeClr val="lt1"/>
+              </a:fontRef>
+            </p:style>
+            <p:txBody>
+              <a:bodyPr rtlCol="0" anchor="ctr"/>
+              <a:lstStyle/>
+              <a:p>
+                <a:pPr algn="ctr"/>
+                <a:endParaRPr lang="en-US"/>
+              </a:p>
+            </p:txBody>
+          </p:sp>
+        </p:grpSp>
+        <p:grpSp>
+          <p:nvGrpSpPr>
+            <p:cNvPr id="7" name="Group 6">
+              <a:extLst>
+                <a:ext uri="{FF2B5EF4-FFF2-40B4-BE49-F238E27FC236}">
+                  <a16:creationId xmlns:a16="http://schemas.microsoft.com/office/drawing/2014/main" id="{BB72C787-538F-0FD7-9E97-7D94C3FF4C1D}"/>
+                </a:ext>
+              </a:extLst>
+            </p:cNvPr>
+            <p:cNvGrpSpPr/>
+            <p:nvPr/>
+          </p:nvGrpSpPr>
+          <p:grpSpPr>
+            <a:xfrm>
+              <a:off x="5012753" y="794634"/>
+              <a:ext cx="914400" cy="914400"/>
+              <a:chOff x="2060003" y="1104900"/>
+              <a:chExt cx="914400" cy="914400"/>
+            </a:xfrm>
+          </p:grpSpPr>
+          <mc:AlternateContent xmlns:mc="http://schemas.openxmlformats.org/markup-compatibility/2006">
+            <mc:Choice xmlns:a14="http://schemas.microsoft.com/office/drawing/2010/main" Requires="a14">
+              <p:sp>
+                <p:nvSpPr>
+                  <p:cNvPr id="8" name="TextBox 7">
+                    <a:extLst>
+                      <a:ext uri="{FF2B5EF4-FFF2-40B4-BE49-F238E27FC236}">
+                        <a16:creationId xmlns:a16="http://schemas.microsoft.com/office/drawing/2014/main" id="{9983170D-9BE2-6E0A-3A5A-926D2257903C}"/>
+                      </a:ext>
+                    </a:extLst>
+                  </p:cNvPr>
+                  <p:cNvSpPr txBox="1"/>
+                  <p:nvPr/>
+                </p:nvSpPr>
+                <p:spPr>
+                  <a:xfrm>
+                    <a:off x="2202700" y="1213757"/>
+                    <a:ext cx="771703" cy="646331"/>
+                  </a:xfrm>
+                  <a:prstGeom prst="rect">
+                    <a:avLst/>
+                  </a:prstGeom>
+                  <a:noFill/>
+                </p:spPr>
+                <p:txBody>
+                  <a:bodyPr wrap="square" rtlCol="0" anchor="ctr">
+                    <a:spAutoFit/>
+                  </a:bodyPr>
+                  <a:lstStyle/>
+                  <a:p>
+                    <a:pPr/>
+                    <a14:m>
+                      <m:oMathPara xmlns:m="http://schemas.openxmlformats.org/officeDocument/2006/math">
+                        <m:oMathParaPr>
+                          <m:jc m:val="center"/>
+                        </m:oMathParaPr>
+                        <m:oMath xmlns:m="http://schemas.openxmlformats.org/officeDocument/2006/math">
+                          <m:sSub>
+                            <m:sSubPr>
+                              <m:ctrlPr>
+                                <a:rPr lang="en-US" sz="3600" i="1" smtClean="0">
+                                  <a:latin typeface="Cambria Math" panose="02040503050406030204" pitchFamily="18" charset="0"/>
+                                </a:rPr>
+                              </m:ctrlPr>
+                            </m:sSubPr>
+                            <m:e>
+                              <m:r>
+                                <a:rPr lang="en-US" sz="3600" i="1" smtClean="0">
+                                  <a:latin typeface="Cambria Math" panose="02040503050406030204" pitchFamily="18" charset="0"/>
+                                </a:rPr>
+                                <m:t>𝜇</m:t>
+                              </m:r>
+                            </m:e>
+                            <m:sub>
+                              <m:r>
+                                <a:rPr lang="en-US" sz="3600" b="0" i="1" smtClean="0">
+                                  <a:latin typeface="Cambria Math" panose="02040503050406030204" pitchFamily="18" charset="0"/>
+                                </a:rPr>
+                                <m:t>2</m:t>
+                              </m:r>
+                            </m:sub>
+                          </m:sSub>
+                        </m:oMath>
+                      </m:oMathPara>
+                    </a14:m>
+                    <a:endParaRPr lang="en-US" sz="3600" dirty="0"/>
+                  </a:p>
+                </p:txBody>
+              </p:sp>
+            </mc:Choice>
+            <mc:Fallback>
+              <p:sp>
+                <p:nvSpPr>
+                  <p:cNvPr id="8" name="TextBox 7">
+                    <a:extLst>
+                      <a:ext uri="{FF2B5EF4-FFF2-40B4-BE49-F238E27FC236}">
+                        <a16:creationId xmlns:a16="http://schemas.microsoft.com/office/drawing/2014/main" id="{9983170D-9BE2-6E0A-3A5A-926D2257903C}"/>
+                      </a:ext>
+                    </a:extLst>
+                  </p:cNvPr>
+                  <p:cNvSpPr txBox="1">
+                    <a:spLocks noRot="1" noChangeAspect="1" noMove="1" noResize="1" noEditPoints="1" noAdjustHandles="1" noChangeArrowheads="1" noChangeShapeType="1" noTextEdit="1"/>
+                  </p:cNvSpPr>
+                  <p:nvPr/>
+                </p:nvSpPr>
+                <p:spPr>
+                  <a:xfrm>
+                    <a:off x="2202700" y="1213757"/>
+                    <a:ext cx="771703" cy="646331"/>
+                  </a:xfrm>
+                  <a:prstGeom prst="rect">
+                    <a:avLst/>
+                  </a:prstGeom>
+                  <a:blipFill>
+                    <a:blip r:embed="rId3"/>
+                    <a:stretch>
+                      <a:fillRect l="-1639" b="-11765"/>
+                    </a:stretch>
+                  </a:blipFill>
+                </p:spPr>
+                <p:txBody>
+                  <a:bodyPr/>
+                  <a:lstStyle/>
+                  <a:p>
+                    <a:r>
+                      <a:rPr lang="en-US">
+                        <a:noFill/>
+                      </a:rPr>
+                      <a:t> </a:t>
+                    </a:r>
+                  </a:p>
+                </p:txBody>
+              </p:sp>
+            </mc:Fallback>
+          </mc:AlternateContent>
+          <p:sp>
+            <p:nvSpPr>
+              <p:cNvPr id="9" name="Oval 8">
+                <a:extLst>
+                  <a:ext uri="{FF2B5EF4-FFF2-40B4-BE49-F238E27FC236}">
+                    <a16:creationId xmlns:a16="http://schemas.microsoft.com/office/drawing/2014/main" id="{D278BB83-CCB9-7EF0-29A1-EA8674B42F84}"/>
+                  </a:ext>
+                </a:extLst>
+              </p:cNvPr>
+              <p:cNvSpPr/>
+              <p:nvPr/>
+            </p:nvSpPr>
+            <p:spPr>
+              <a:xfrm>
+                <a:off x="2060003" y="1104900"/>
+                <a:ext cx="914400" cy="914400"/>
+              </a:xfrm>
+              <a:prstGeom prst="ellipse">
+                <a:avLst/>
+              </a:prstGeom>
+              <a:noFill/>
+              <a:ln>
+                <a:solidFill>
+                  <a:schemeClr val="tx1"/>
+                </a:solidFill>
+              </a:ln>
+            </p:spPr>
+            <p:style>
+              <a:lnRef idx="2">
+                <a:schemeClr val="accent1">
+                  <a:shade val="15000"/>
+                </a:schemeClr>
+              </a:lnRef>
+              <a:fillRef idx="1">
+                <a:schemeClr val="accent1"/>
+              </a:fillRef>
+              <a:effectRef idx="0">
+                <a:schemeClr val="accent1"/>
+              </a:effectRef>
+              <a:fontRef idx="minor">
+                <a:schemeClr val="lt1"/>
+              </a:fontRef>
+            </p:style>
+            <p:txBody>
+              <a:bodyPr rtlCol="0" anchor="ctr"/>
+              <a:lstStyle/>
+              <a:p>
+                <a:pPr algn="ctr"/>
+                <a:endParaRPr lang="en-US"/>
+              </a:p>
+            </p:txBody>
+          </p:sp>
+        </p:grpSp>
+        <p:grpSp>
+          <p:nvGrpSpPr>
+            <p:cNvPr id="10" name="Group 9">
+              <a:extLst>
+                <a:ext uri="{FF2B5EF4-FFF2-40B4-BE49-F238E27FC236}">
+                  <a16:creationId xmlns:a16="http://schemas.microsoft.com/office/drawing/2014/main" id="{A22E1F12-3910-2362-885B-A969917FCD9A}"/>
+                </a:ext>
+              </a:extLst>
+            </p:cNvPr>
+            <p:cNvGrpSpPr/>
+            <p:nvPr/>
+          </p:nvGrpSpPr>
+          <p:grpSpPr>
+            <a:xfrm>
+              <a:off x="6202017" y="769456"/>
+              <a:ext cx="914400" cy="914400"/>
+              <a:chOff x="2060003" y="1104900"/>
+              <a:chExt cx="914400" cy="914400"/>
+            </a:xfrm>
+          </p:grpSpPr>
+          <mc:AlternateContent xmlns:mc="http://schemas.openxmlformats.org/markup-compatibility/2006">
+            <mc:Choice xmlns:a14="http://schemas.microsoft.com/office/drawing/2010/main" Requires="a14">
+              <p:sp>
+                <p:nvSpPr>
+                  <p:cNvPr id="11" name="TextBox 10">
+                    <a:extLst>
+                      <a:ext uri="{FF2B5EF4-FFF2-40B4-BE49-F238E27FC236}">
+                        <a16:creationId xmlns:a16="http://schemas.microsoft.com/office/drawing/2014/main" id="{C3AFA91E-E9C9-BB8C-8D32-DF90FDFEF447}"/>
+                      </a:ext>
+                    </a:extLst>
+                  </p:cNvPr>
+                  <p:cNvSpPr txBox="1"/>
+                  <p:nvPr/>
+                </p:nvSpPr>
+                <p:spPr>
+                  <a:xfrm>
+                    <a:off x="2202700" y="1213757"/>
+                    <a:ext cx="771703" cy="646331"/>
+                  </a:xfrm>
+                  <a:prstGeom prst="rect">
+                    <a:avLst/>
+                  </a:prstGeom>
+                  <a:noFill/>
+                </p:spPr>
+                <p:txBody>
+                  <a:bodyPr wrap="square" rtlCol="0" anchor="ctr">
+                    <a:spAutoFit/>
+                  </a:bodyPr>
+                  <a:lstStyle/>
+                  <a:p>
+                    <a:pPr/>
+                    <a14:m>
+                      <m:oMathPara xmlns:m="http://schemas.openxmlformats.org/officeDocument/2006/math">
+                        <m:oMathParaPr>
+                          <m:jc m:val="center"/>
+                        </m:oMathParaPr>
+                        <m:oMath xmlns:m="http://schemas.openxmlformats.org/officeDocument/2006/math">
+                          <m:sSub>
+                            <m:sSubPr>
+                              <m:ctrlPr>
+                                <a:rPr lang="en-US" sz="3600" i="1" smtClean="0">
+                                  <a:latin typeface="Cambria Math" panose="02040503050406030204" pitchFamily="18" charset="0"/>
+                                </a:rPr>
+                              </m:ctrlPr>
+                            </m:sSubPr>
+                            <m:e>
+                              <m:r>
+                                <a:rPr lang="en-US" sz="3600" i="1" smtClean="0">
+                                  <a:latin typeface="Cambria Math" panose="02040503050406030204" pitchFamily="18" charset="0"/>
+                                </a:rPr>
+                                <m:t>𝜇</m:t>
+                              </m:r>
+                            </m:e>
+                            <m:sub>
+                              <m:r>
+                                <a:rPr lang="en-US" sz="3600" b="0" i="1" smtClean="0">
+                                  <a:latin typeface="Cambria Math" panose="02040503050406030204" pitchFamily="18" charset="0"/>
+                                </a:rPr>
+                                <m:t>3</m:t>
+                              </m:r>
+                            </m:sub>
+                          </m:sSub>
+                        </m:oMath>
+                      </m:oMathPara>
+                    </a14:m>
+                    <a:endParaRPr lang="en-US" sz="3600" dirty="0"/>
+                  </a:p>
+                </p:txBody>
+              </p:sp>
+            </mc:Choice>
+            <mc:Fallback>
+              <p:sp>
+                <p:nvSpPr>
+                  <p:cNvPr id="11" name="TextBox 10">
+                    <a:extLst>
+                      <a:ext uri="{FF2B5EF4-FFF2-40B4-BE49-F238E27FC236}">
+                        <a16:creationId xmlns:a16="http://schemas.microsoft.com/office/drawing/2014/main" id="{C3AFA91E-E9C9-BB8C-8D32-DF90FDFEF447}"/>
+                      </a:ext>
+                    </a:extLst>
+                  </p:cNvPr>
+                  <p:cNvSpPr txBox="1">
+                    <a:spLocks noRot="1" noChangeAspect="1" noMove="1" noResize="1" noEditPoints="1" noAdjustHandles="1" noChangeArrowheads="1" noChangeShapeType="1" noTextEdit="1"/>
+                  </p:cNvSpPr>
+                  <p:nvPr/>
+                </p:nvSpPr>
+                <p:spPr>
+                  <a:xfrm>
+                    <a:off x="2202700" y="1213757"/>
+                    <a:ext cx="771703" cy="646331"/>
+                  </a:xfrm>
+                  <a:prstGeom prst="rect">
+                    <a:avLst/>
+                  </a:prstGeom>
+                  <a:blipFill>
+                    <a:blip r:embed="rId4"/>
+                    <a:stretch>
+                      <a:fillRect b="-9615"/>
+                    </a:stretch>
+                  </a:blipFill>
+                </p:spPr>
+                <p:txBody>
+                  <a:bodyPr/>
+                  <a:lstStyle/>
+                  <a:p>
+                    <a:r>
+                      <a:rPr lang="en-US">
+                        <a:noFill/>
+                      </a:rPr>
+                      <a:t> </a:t>
+                    </a:r>
+                  </a:p>
+                </p:txBody>
+              </p:sp>
+            </mc:Fallback>
+          </mc:AlternateContent>
+          <p:sp>
+            <p:nvSpPr>
+              <p:cNvPr id="12" name="Oval 11">
+                <a:extLst>
+                  <a:ext uri="{FF2B5EF4-FFF2-40B4-BE49-F238E27FC236}">
+                    <a16:creationId xmlns:a16="http://schemas.microsoft.com/office/drawing/2014/main" id="{902C431B-8264-348E-CAEE-58E52F2DE4DA}"/>
+                  </a:ext>
+                </a:extLst>
+              </p:cNvPr>
+              <p:cNvSpPr/>
+              <p:nvPr/>
+            </p:nvSpPr>
+            <p:spPr>
+              <a:xfrm>
+                <a:off x="2060003" y="1104900"/>
+                <a:ext cx="914400" cy="914400"/>
+              </a:xfrm>
+              <a:prstGeom prst="ellipse">
+                <a:avLst/>
+              </a:prstGeom>
+              <a:noFill/>
+              <a:ln>
+                <a:solidFill>
+                  <a:schemeClr val="tx1"/>
+                </a:solidFill>
+              </a:ln>
+            </p:spPr>
+            <p:style>
+              <a:lnRef idx="2">
+                <a:schemeClr val="accent1">
+                  <a:shade val="15000"/>
+                </a:schemeClr>
+              </a:lnRef>
+              <a:fillRef idx="1">
+                <a:schemeClr val="accent1"/>
+              </a:fillRef>
+              <a:effectRef idx="0">
+                <a:schemeClr val="accent1"/>
+              </a:effectRef>
+              <a:fontRef idx="minor">
+                <a:schemeClr val="lt1"/>
+              </a:fontRef>
+            </p:style>
+            <p:txBody>
+              <a:bodyPr rtlCol="0" anchor="ctr"/>
+              <a:lstStyle/>
+              <a:p>
+                <a:pPr algn="ctr"/>
+                <a:endParaRPr lang="en-US"/>
+              </a:p>
+            </p:txBody>
+          </p:sp>
+        </p:grpSp>
+        <p:grpSp>
+          <p:nvGrpSpPr>
+            <p:cNvPr id="13" name="Group 12">
+              <a:extLst>
+                <a:ext uri="{FF2B5EF4-FFF2-40B4-BE49-F238E27FC236}">
+                  <a16:creationId xmlns:a16="http://schemas.microsoft.com/office/drawing/2014/main" id="{ACF48B86-5D14-39D0-F9EC-54490678B1B0}"/>
+                </a:ext>
+              </a:extLst>
+            </p:cNvPr>
+            <p:cNvGrpSpPr/>
+            <p:nvPr/>
+          </p:nvGrpSpPr>
+          <p:grpSpPr>
+            <a:xfrm>
+              <a:off x="7391281" y="769456"/>
+              <a:ext cx="914400" cy="914400"/>
+              <a:chOff x="2060003" y="1104900"/>
+              <a:chExt cx="914400" cy="914400"/>
+            </a:xfrm>
+          </p:grpSpPr>
+          <mc:AlternateContent xmlns:mc="http://schemas.openxmlformats.org/markup-compatibility/2006">
+            <mc:Choice xmlns:a14="http://schemas.microsoft.com/office/drawing/2010/main" Requires="a14">
+              <p:sp>
+                <p:nvSpPr>
+                  <p:cNvPr id="14" name="TextBox 13">
+                    <a:extLst>
+                      <a:ext uri="{FF2B5EF4-FFF2-40B4-BE49-F238E27FC236}">
+                        <a16:creationId xmlns:a16="http://schemas.microsoft.com/office/drawing/2014/main" id="{34B06E88-A75B-88F4-CB0F-6204CC5D9D9A}"/>
+                      </a:ext>
+                    </a:extLst>
+                  </p:cNvPr>
+                  <p:cNvSpPr txBox="1"/>
+                  <p:nvPr/>
+                </p:nvSpPr>
+                <p:spPr>
+                  <a:xfrm>
+                    <a:off x="2202700" y="1213757"/>
+                    <a:ext cx="771703" cy="646331"/>
+                  </a:xfrm>
+                  <a:prstGeom prst="rect">
+                    <a:avLst/>
+                  </a:prstGeom>
+                  <a:noFill/>
+                </p:spPr>
+                <p:txBody>
+                  <a:bodyPr wrap="square" rtlCol="0" anchor="ctr">
+                    <a:spAutoFit/>
+                  </a:bodyPr>
+                  <a:lstStyle/>
+                  <a:p>
+                    <a:pPr/>
+                    <a14:m>
+                      <m:oMathPara xmlns:m="http://schemas.openxmlformats.org/officeDocument/2006/math">
+                        <m:oMathParaPr>
+                          <m:jc m:val="center"/>
+                        </m:oMathParaPr>
+                        <m:oMath xmlns:m="http://schemas.openxmlformats.org/officeDocument/2006/math">
+                          <m:sSub>
+                            <m:sSubPr>
+                              <m:ctrlPr>
+                                <a:rPr lang="en-US" sz="3600" i="1" smtClean="0">
+                                  <a:latin typeface="Cambria Math" panose="02040503050406030204" pitchFamily="18" charset="0"/>
+                                </a:rPr>
+                              </m:ctrlPr>
+                            </m:sSubPr>
+                            <m:e>
+                              <m:r>
+                                <a:rPr lang="en-US" sz="3600" i="1" smtClean="0">
+                                  <a:latin typeface="Cambria Math" panose="02040503050406030204" pitchFamily="18" charset="0"/>
+                                </a:rPr>
+                                <m:t>𝜇</m:t>
+                              </m:r>
+                            </m:e>
+                            <m:sub>
+                              <m:r>
+                                <a:rPr lang="en-US" sz="3600" b="0" i="1" smtClean="0">
+                                  <a:latin typeface="Cambria Math" panose="02040503050406030204" pitchFamily="18" charset="0"/>
+                                </a:rPr>
+                                <m:t>4</m:t>
+                              </m:r>
+                            </m:sub>
+                          </m:sSub>
+                        </m:oMath>
+                      </m:oMathPara>
+                    </a14:m>
+                    <a:endParaRPr lang="en-US" sz="3600" dirty="0"/>
+                  </a:p>
+                </p:txBody>
+              </p:sp>
+            </mc:Choice>
+            <mc:Fallback>
+              <p:sp>
+                <p:nvSpPr>
+                  <p:cNvPr id="14" name="TextBox 13">
+                    <a:extLst>
+                      <a:ext uri="{FF2B5EF4-FFF2-40B4-BE49-F238E27FC236}">
+                        <a16:creationId xmlns:a16="http://schemas.microsoft.com/office/drawing/2014/main" id="{34B06E88-A75B-88F4-CB0F-6204CC5D9D9A}"/>
+                      </a:ext>
+                    </a:extLst>
+                  </p:cNvPr>
+                  <p:cNvSpPr txBox="1">
+                    <a:spLocks noRot="1" noChangeAspect="1" noMove="1" noResize="1" noEditPoints="1" noAdjustHandles="1" noChangeArrowheads="1" noChangeShapeType="1" noTextEdit="1"/>
+                  </p:cNvSpPr>
+                  <p:nvPr/>
+                </p:nvSpPr>
+                <p:spPr>
+                  <a:xfrm>
+                    <a:off x="2202700" y="1213757"/>
+                    <a:ext cx="771703" cy="646331"/>
+                  </a:xfrm>
+                  <a:prstGeom prst="rect">
+                    <a:avLst/>
+                  </a:prstGeom>
+                  <a:blipFill>
+                    <a:blip r:embed="rId5"/>
+                    <a:stretch>
+                      <a:fillRect b="-9615"/>
+                    </a:stretch>
+                  </a:blipFill>
+                </p:spPr>
+                <p:txBody>
+                  <a:bodyPr/>
+                  <a:lstStyle/>
+                  <a:p>
+                    <a:r>
+                      <a:rPr lang="en-US">
+                        <a:noFill/>
+                      </a:rPr>
+                      <a:t> </a:t>
+                    </a:r>
+                  </a:p>
+                </p:txBody>
+              </p:sp>
+            </mc:Fallback>
+          </mc:AlternateContent>
+          <p:sp>
+            <p:nvSpPr>
+              <p:cNvPr id="15" name="Oval 14">
+                <a:extLst>
+                  <a:ext uri="{FF2B5EF4-FFF2-40B4-BE49-F238E27FC236}">
+                    <a16:creationId xmlns:a16="http://schemas.microsoft.com/office/drawing/2014/main" id="{D5EDA59E-8AA1-9F8F-B013-0938F53E0D38}"/>
+                  </a:ext>
+                </a:extLst>
+              </p:cNvPr>
+              <p:cNvSpPr/>
+              <p:nvPr/>
+            </p:nvSpPr>
+            <p:spPr>
+              <a:xfrm>
+                <a:off x="2060003" y="1104900"/>
+                <a:ext cx="914400" cy="914400"/>
+              </a:xfrm>
+              <a:prstGeom prst="ellipse">
+                <a:avLst/>
+              </a:prstGeom>
+              <a:noFill/>
+              <a:ln>
+                <a:solidFill>
+                  <a:schemeClr val="tx1"/>
+                </a:solidFill>
+              </a:ln>
+            </p:spPr>
+            <p:style>
+              <a:lnRef idx="2">
+                <a:schemeClr val="accent1">
+                  <a:shade val="15000"/>
+                </a:schemeClr>
+              </a:lnRef>
+              <a:fillRef idx="1">
+                <a:schemeClr val="accent1"/>
+              </a:fillRef>
+              <a:effectRef idx="0">
+                <a:schemeClr val="accent1"/>
+              </a:effectRef>
+              <a:fontRef idx="minor">
+                <a:schemeClr val="lt1"/>
+              </a:fontRef>
+            </p:style>
+            <p:txBody>
+              <a:bodyPr rtlCol="0" anchor="ctr"/>
+              <a:lstStyle/>
+              <a:p>
+                <a:pPr algn="ctr"/>
+                <a:endParaRPr lang="en-US"/>
+              </a:p>
+            </p:txBody>
+          </p:sp>
+        </p:grpSp>
+        <p:grpSp>
+          <p:nvGrpSpPr>
+            <p:cNvPr id="16" name="Group 15">
+              <a:extLst>
+                <a:ext uri="{FF2B5EF4-FFF2-40B4-BE49-F238E27FC236}">
+                  <a16:creationId xmlns:a16="http://schemas.microsoft.com/office/drawing/2014/main" id="{9DD64FF9-8933-3FAE-08C0-4F9B3274B630}"/>
+                </a:ext>
+              </a:extLst>
+            </p:cNvPr>
+            <p:cNvGrpSpPr/>
+            <p:nvPr/>
+          </p:nvGrpSpPr>
+          <p:grpSpPr>
+            <a:xfrm>
+              <a:off x="1238842" y="3120105"/>
+              <a:ext cx="914400" cy="914400"/>
+              <a:chOff x="2060003" y="1104900"/>
+              <a:chExt cx="914400" cy="914400"/>
+            </a:xfrm>
+          </p:grpSpPr>
+          <mc:AlternateContent xmlns:mc="http://schemas.openxmlformats.org/markup-compatibility/2006">
+            <mc:Choice xmlns:a14="http://schemas.microsoft.com/office/drawing/2010/main" Requires="a14">
+              <p:sp>
+                <p:nvSpPr>
+                  <p:cNvPr id="17" name="TextBox 16">
+                    <a:extLst>
+                      <a:ext uri="{FF2B5EF4-FFF2-40B4-BE49-F238E27FC236}">
+                        <a16:creationId xmlns:a16="http://schemas.microsoft.com/office/drawing/2014/main" id="{2F6D1DB0-1BB0-E7FD-2572-F22C4FBC824A}"/>
+                      </a:ext>
+                    </a:extLst>
+                  </p:cNvPr>
+                  <p:cNvSpPr txBox="1"/>
+                  <p:nvPr/>
+                </p:nvSpPr>
+                <p:spPr>
+                  <a:xfrm>
+                    <a:off x="2170042" y="1213757"/>
+                    <a:ext cx="771703" cy="646331"/>
+                  </a:xfrm>
+                  <a:prstGeom prst="rect">
+                    <a:avLst/>
+                  </a:prstGeom>
+                  <a:noFill/>
+                </p:spPr>
+                <p:txBody>
+                  <a:bodyPr wrap="square" rtlCol="0" anchor="ctr">
+                    <a:spAutoFit/>
+                  </a:bodyPr>
+                  <a:lstStyle/>
+                  <a:p>
+                    <a:pPr/>
+                    <a14:m>
+                      <m:oMathPara xmlns:m="http://schemas.openxmlformats.org/officeDocument/2006/math">
+                        <m:oMathParaPr>
+                          <m:jc m:val="center"/>
+                        </m:oMathParaPr>
+                        <m:oMath xmlns:m="http://schemas.openxmlformats.org/officeDocument/2006/math">
+                          <m:sSub>
+                            <m:sSubPr>
+                              <m:ctrlPr>
+                                <a:rPr lang="en-US" sz="3600" i="1" smtClean="0">
+                                  <a:latin typeface="Cambria Math" panose="02040503050406030204" pitchFamily="18" charset="0"/>
+                                </a:rPr>
+                              </m:ctrlPr>
+                            </m:sSubPr>
+                            <m:e>
+                              <m:r>
+                                <a:rPr lang="en-US" sz="3600" b="0" i="1" smtClean="0">
+                                  <a:latin typeface="Cambria Math" panose="02040503050406030204" pitchFamily="18" charset="0"/>
+                                </a:rPr>
+                                <m:t>𝑑</m:t>
+                              </m:r>
+                            </m:e>
+                            <m:sub>
+                              <m:r>
+                                <a:rPr lang="en-US" sz="3600" b="0" i="1" smtClean="0">
+                                  <a:latin typeface="Cambria Math" panose="02040503050406030204" pitchFamily="18" charset="0"/>
+                                </a:rPr>
+                                <m:t>12</m:t>
+                              </m:r>
+                            </m:sub>
+                          </m:sSub>
+                        </m:oMath>
+                      </m:oMathPara>
+                    </a14:m>
+                    <a:endParaRPr lang="en-US" sz="3600" dirty="0"/>
+                  </a:p>
+                </p:txBody>
+              </p:sp>
+            </mc:Choice>
+            <mc:Fallback>
+              <p:sp>
+                <p:nvSpPr>
+                  <p:cNvPr id="17" name="TextBox 16">
+                    <a:extLst>
+                      <a:ext uri="{FF2B5EF4-FFF2-40B4-BE49-F238E27FC236}">
+                        <a16:creationId xmlns:a16="http://schemas.microsoft.com/office/drawing/2014/main" id="{2F6D1DB0-1BB0-E7FD-2572-F22C4FBC824A}"/>
+                      </a:ext>
+                    </a:extLst>
+                  </p:cNvPr>
+                  <p:cNvSpPr txBox="1">
+                    <a:spLocks noRot="1" noChangeAspect="1" noMove="1" noResize="1" noEditPoints="1" noAdjustHandles="1" noChangeArrowheads="1" noChangeShapeType="1" noTextEdit="1"/>
+                  </p:cNvSpPr>
+                  <p:nvPr/>
+                </p:nvSpPr>
+                <p:spPr>
+                  <a:xfrm>
+                    <a:off x="2170042" y="1213757"/>
+                    <a:ext cx="771703" cy="646331"/>
+                  </a:xfrm>
+                  <a:prstGeom prst="rect">
+                    <a:avLst/>
+                  </a:prstGeom>
+                  <a:blipFill>
+                    <a:blip r:embed="rId6"/>
+                    <a:stretch>
+                      <a:fillRect l="-9677" r="-8065" b="-3846"/>
+                    </a:stretch>
+                  </a:blipFill>
+                </p:spPr>
+                <p:txBody>
+                  <a:bodyPr/>
+                  <a:lstStyle/>
+                  <a:p>
+                    <a:r>
+                      <a:rPr lang="en-US">
+                        <a:noFill/>
+                      </a:rPr>
+                      <a:t> </a:t>
+                    </a:r>
+                  </a:p>
+                </p:txBody>
+              </p:sp>
+            </mc:Fallback>
+          </mc:AlternateContent>
+          <p:sp>
+            <p:nvSpPr>
+              <p:cNvPr id="18" name="Oval 17">
+                <a:extLst>
+                  <a:ext uri="{FF2B5EF4-FFF2-40B4-BE49-F238E27FC236}">
+                    <a16:creationId xmlns:a16="http://schemas.microsoft.com/office/drawing/2014/main" id="{88519E99-6106-D38A-9862-08C821B41C05}"/>
+                  </a:ext>
+                </a:extLst>
+              </p:cNvPr>
+              <p:cNvSpPr/>
+              <p:nvPr/>
+            </p:nvSpPr>
+            <p:spPr>
+              <a:xfrm>
+                <a:off x="2060003" y="1104900"/>
+                <a:ext cx="914400" cy="914400"/>
+              </a:xfrm>
+              <a:prstGeom prst="ellipse">
+                <a:avLst/>
+              </a:prstGeom>
+              <a:noFill/>
+              <a:ln>
+                <a:solidFill>
+                  <a:schemeClr val="tx1"/>
+                </a:solidFill>
+              </a:ln>
+            </p:spPr>
+            <p:style>
+              <a:lnRef idx="2">
+                <a:schemeClr val="accent1">
+                  <a:shade val="15000"/>
+                </a:schemeClr>
+              </a:lnRef>
+              <a:fillRef idx="1">
+                <a:schemeClr val="accent1"/>
+              </a:fillRef>
+              <a:effectRef idx="0">
+                <a:schemeClr val="accent1"/>
+              </a:effectRef>
+              <a:fontRef idx="minor">
+                <a:schemeClr val="lt1"/>
+              </a:fontRef>
+            </p:style>
+            <p:txBody>
+              <a:bodyPr rtlCol="0" anchor="ctr"/>
+              <a:lstStyle/>
+              <a:p>
+                <a:pPr algn="ctr"/>
+                <a:endParaRPr lang="en-US"/>
+              </a:p>
+            </p:txBody>
+          </p:sp>
+        </p:grpSp>
+        <p:grpSp>
+          <p:nvGrpSpPr>
+            <p:cNvPr id="19" name="Group 18">
+              <a:extLst>
+                <a:ext uri="{FF2B5EF4-FFF2-40B4-BE49-F238E27FC236}">
+                  <a16:creationId xmlns:a16="http://schemas.microsoft.com/office/drawing/2014/main" id="{48C55AF6-88D7-576B-EDC3-B9ECD87328F1}"/>
+                </a:ext>
+              </a:extLst>
+            </p:cNvPr>
+            <p:cNvGrpSpPr/>
+            <p:nvPr/>
+          </p:nvGrpSpPr>
+          <p:grpSpPr>
+            <a:xfrm>
+              <a:off x="2977479" y="3120105"/>
+              <a:ext cx="914400" cy="914400"/>
+              <a:chOff x="2060003" y="1104900"/>
+              <a:chExt cx="914400" cy="914400"/>
+            </a:xfrm>
+          </p:grpSpPr>
+          <mc:AlternateContent xmlns:mc="http://schemas.openxmlformats.org/markup-compatibility/2006">
+            <mc:Choice xmlns:a14="http://schemas.microsoft.com/office/drawing/2010/main" Requires="a14">
+              <p:sp>
+                <p:nvSpPr>
+                  <p:cNvPr id="20" name="TextBox 19">
+                    <a:extLst>
+                      <a:ext uri="{FF2B5EF4-FFF2-40B4-BE49-F238E27FC236}">
+                        <a16:creationId xmlns:a16="http://schemas.microsoft.com/office/drawing/2014/main" id="{69EAE026-CDE0-F644-9230-882CDA7635FF}"/>
+                      </a:ext>
+                    </a:extLst>
+                  </p:cNvPr>
+                  <p:cNvSpPr txBox="1"/>
+                  <p:nvPr/>
+                </p:nvSpPr>
+                <p:spPr>
+                  <a:xfrm>
+                    <a:off x="2170042" y="1213757"/>
+                    <a:ext cx="771703" cy="646331"/>
+                  </a:xfrm>
+                  <a:prstGeom prst="rect">
+                    <a:avLst/>
+                  </a:prstGeom>
+                  <a:noFill/>
+                </p:spPr>
+                <p:txBody>
+                  <a:bodyPr wrap="square" rtlCol="0" anchor="ctr">
+                    <a:spAutoFit/>
+                  </a:bodyPr>
+                  <a:lstStyle/>
+                  <a:p>
+                    <a:pPr/>
+                    <a14:m>
+                      <m:oMathPara xmlns:m="http://schemas.openxmlformats.org/officeDocument/2006/math">
+                        <m:oMathParaPr>
+                          <m:jc m:val="center"/>
+                        </m:oMathParaPr>
+                        <m:oMath xmlns:m="http://schemas.openxmlformats.org/officeDocument/2006/math">
+                          <m:sSub>
+                            <m:sSubPr>
+                              <m:ctrlPr>
+                                <a:rPr lang="en-US" sz="3600" i="1" smtClean="0">
+                                  <a:latin typeface="Cambria Math" panose="02040503050406030204" pitchFamily="18" charset="0"/>
+                                </a:rPr>
+                              </m:ctrlPr>
+                            </m:sSubPr>
+                            <m:e>
+                              <m:r>
+                                <a:rPr lang="en-US" sz="3600" b="0" i="1" smtClean="0">
+                                  <a:latin typeface="Cambria Math" panose="02040503050406030204" pitchFamily="18" charset="0"/>
+                                </a:rPr>
+                                <m:t>𝑑</m:t>
+                              </m:r>
+                            </m:e>
+                            <m:sub>
+                              <m:r>
+                                <a:rPr lang="en-US" sz="3600" b="0" i="1" smtClean="0">
+                                  <a:latin typeface="Cambria Math" panose="02040503050406030204" pitchFamily="18" charset="0"/>
+                                </a:rPr>
+                                <m:t>13</m:t>
+                              </m:r>
+                            </m:sub>
+                          </m:sSub>
+                        </m:oMath>
+                      </m:oMathPara>
+                    </a14:m>
+                    <a:endParaRPr lang="en-US" sz="3600" dirty="0"/>
+                  </a:p>
+                </p:txBody>
+              </p:sp>
+            </mc:Choice>
+            <mc:Fallback>
+              <p:sp>
+                <p:nvSpPr>
+                  <p:cNvPr id="20" name="TextBox 19">
+                    <a:extLst>
+                      <a:ext uri="{FF2B5EF4-FFF2-40B4-BE49-F238E27FC236}">
+                        <a16:creationId xmlns:a16="http://schemas.microsoft.com/office/drawing/2014/main" id="{69EAE026-CDE0-F644-9230-882CDA7635FF}"/>
+                      </a:ext>
+                    </a:extLst>
+                  </p:cNvPr>
+                  <p:cNvSpPr txBox="1">
+                    <a:spLocks noRot="1" noChangeAspect="1" noMove="1" noResize="1" noEditPoints="1" noAdjustHandles="1" noChangeArrowheads="1" noChangeShapeType="1" noTextEdit="1"/>
+                  </p:cNvSpPr>
+                  <p:nvPr/>
+                </p:nvSpPr>
+                <p:spPr>
+                  <a:xfrm>
+                    <a:off x="2170042" y="1213757"/>
+                    <a:ext cx="771703" cy="646331"/>
+                  </a:xfrm>
+                  <a:prstGeom prst="rect">
+                    <a:avLst/>
+                  </a:prstGeom>
+                  <a:blipFill>
+                    <a:blip r:embed="rId7"/>
+                    <a:stretch>
+                      <a:fillRect l="-8065" r="-9677" b="-3846"/>
+                    </a:stretch>
+                  </a:blipFill>
+                </p:spPr>
+                <p:txBody>
+                  <a:bodyPr/>
+                  <a:lstStyle/>
+                  <a:p>
+                    <a:r>
+                      <a:rPr lang="en-US">
+                        <a:noFill/>
+                      </a:rPr>
+                      <a:t> </a:t>
+                    </a:r>
+                  </a:p>
+                </p:txBody>
+              </p:sp>
+            </mc:Fallback>
+          </mc:AlternateContent>
+          <p:sp>
+            <p:nvSpPr>
+              <p:cNvPr id="21" name="Oval 20">
+                <a:extLst>
+                  <a:ext uri="{FF2B5EF4-FFF2-40B4-BE49-F238E27FC236}">
+                    <a16:creationId xmlns:a16="http://schemas.microsoft.com/office/drawing/2014/main" id="{752F16A9-C791-2DD8-7DC4-E249431AFCD8}"/>
+                  </a:ext>
+                </a:extLst>
+              </p:cNvPr>
+              <p:cNvSpPr/>
+              <p:nvPr/>
+            </p:nvSpPr>
+            <p:spPr>
+              <a:xfrm>
+                <a:off x="2060003" y="1104900"/>
+                <a:ext cx="914400" cy="914400"/>
+              </a:xfrm>
+              <a:prstGeom prst="ellipse">
+                <a:avLst/>
+              </a:prstGeom>
+              <a:noFill/>
+              <a:ln>
+                <a:solidFill>
+                  <a:schemeClr val="tx1"/>
+                </a:solidFill>
+              </a:ln>
+            </p:spPr>
+            <p:style>
+              <a:lnRef idx="2">
+                <a:schemeClr val="accent1">
+                  <a:shade val="15000"/>
+                </a:schemeClr>
+              </a:lnRef>
+              <a:fillRef idx="1">
+                <a:schemeClr val="accent1"/>
+              </a:fillRef>
+              <a:effectRef idx="0">
+                <a:schemeClr val="accent1"/>
+              </a:effectRef>
+              <a:fontRef idx="minor">
+                <a:schemeClr val="lt1"/>
+              </a:fontRef>
+            </p:style>
+            <p:txBody>
+              <a:bodyPr rtlCol="0" anchor="ctr"/>
+              <a:lstStyle/>
+              <a:p>
+                <a:pPr algn="ctr"/>
+                <a:endParaRPr lang="en-US"/>
+              </a:p>
+            </p:txBody>
+          </p:sp>
+        </p:grpSp>
+        <p:grpSp>
+          <p:nvGrpSpPr>
+            <p:cNvPr id="22" name="Group 21">
+              <a:extLst>
+                <a:ext uri="{FF2B5EF4-FFF2-40B4-BE49-F238E27FC236}">
+                  <a16:creationId xmlns:a16="http://schemas.microsoft.com/office/drawing/2014/main" id="{CE24AF7C-C571-48BF-005A-A57C2FBC9EA7}"/>
+                </a:ext>
+              </a:extLst>
+            </p:cNvPr>
+            <p:cNvGrpSpPr/>
+            <p:nvPr/>
+          </p:nvGrpSpPr>
+          <p:grpSpPr>
+            <a:xfrm>
+              <a:off x="4716116" y="3120105"/>
+              <a:ext cx="914400" cy="914400"/>
+              <a:chOff x="2060003" y="1104900"/>
+              <a:chExt cx="914400" cy="914400"/>
+            </a:xfrm>
+          </p:grpSpPr>
+          <mc:AlternateContent xmlns:mc="http://schemas.openxmlformats.org/markup-compatibility/2006">
+            <mc:Choice xmlns:a14="http://schemas.microsoft.com/office/drawing/2010/main" Requires="a14">
+              <p:sp>
+                <p:nvSpPr>
+                  <p:cNvPr id="23" name="TextBox 22">
+                    <a:extLst>
+                      <a:ext uri="{FF2B5EF4-FFF2-40B4-BE49-F238E27FC236}">
+                        <a16:creationId xmlns:a16="http://schemas.microsoft.com/office/drawing/2014/main" id="{E6B87E28-FBEF-A182-B0FB-592024FE502E}"/>
+                      </a:ext>
+                    </a:extLst>
+                  </p:cNvPr>
+                  <p:cNvSpPr txBox="1"/>
+                  <p:nvPr/>
+                </p:nvSpPr>
+                <p:spPr>
+                  <a:xfrm>
+                    <a:off x="2170042" y="1213757"/>
+                    <a:ext cx="771703" cy="646331"/>
+                  </a:xfrm>
+                  <a:prstGeom prst="rect">
+                    <a:avLst/>
+                  </a:prstGeom>
+                  <a:noFill/>
+                </p:spPr>
+                <p:txBody>
+                  <a:bodyPr wrap="square" rtlCol="0" anchor="ctr">
+                    <a:spAutoFit/>
+                  </a:bodyPr>
+                  <a:lstStyle/>
+                  <a:p>
+                    <a:pPr/>
+                    <a14:m>
+                      <m:oMathPara xmlns:m="http://schemas.openxmlformats.org/officeDocument/2006/math">
+                        <m:oMathParaPr>
+                          <m:jc m:val="center"/>
+                        </m:oMathParaPr>
+                        <m:oMath xmlns:m="http://schemas.openxmlformats.org/officeDocument/2006/math">
+                          <m:sSub>
+                            <m:sSubPr>
+                              <m:ctrlPr>
+                                <a:rPr lang="en-US" sz="3600" i="1" smtClean="0">
+                                  <a:latin typeface="Cambria Math" panose="02040503050406030204" pitchFamily="18" charset="0"/>
+                                </a:rPr>
+                              </m:ctrlPr>
+                            </m:sSubPr>
+                            <m:e>
+                              <m:r>
+                                <a:rPr lang="en-US" sz="3600" b="0" i="1" smtClean="0">
+                                  <a:latin typeface="Cambria Math" panose="02040503050406030204" pitchFamily="18" charset="0"/>
+                                </a:rPr>
+                                <m:t>𝑑</m:t>
+                              </m:r>
+                            </m:e>
+                            <m:sub>
+                              <m:r>
+                                <a:rPr lang="en-US" sz="3600" b="0" i="1" smtClean="0">
+                                  <a:latin typeface="Cambria Math" panose="02040503050406030204" pitchFamily="18" charset="0"/>
+                                </a:rPr>
+                                <m:t>14</m:t>
+                              </m:r>
+                            </m:sub>
+                          </m:sSub>
+                        </m:oMath>
+                      </m:oMathPara>
+                    </a14:m>
+                    <a:endParaRPr lang="en-US" sz="3600" dirty="0"/>
+                  </a:p>
+                </p:txBody>
+              </p:sp>
+            </mc:Choice>
+            <mc:Fallback>
+              <p:sp>
+                <p:nvSpPr>
+                  <p:cNvPr id="23" name="TextBox 22">
+                    <a:extLst>
+                      <a:ext uri="{FF2B5EF4-FFF2-40B4-BE49-F238E27FC236}">
+                        <a16:creationId xmlns:a16="http://schemas.microsoft.com/office/drawing/2014/main" id="{E6B87E28-FBEF-A182-B0FB-592024FE502E}"/>
+                      </a:ext>
+                    </a:extLst>
+                  </p:cNvPr>
+                  <p:cNvSpPr txBox="1">
+                    <a:spLocks noRot="1" noChangeAspect="1" noMove="1" noResize="1" noEditPoints="1" noAdjustHandles="1" noChangeArrowheads="1" noChangeShapeType="1" noTextEdit="1"/>
+                  </p:cNvSpPr>
+                  <p:nvPr/>
+                </p:nvSpPr>
+                <p:spPr>
+                  <a:xfrm>
+                    <a:off x="2170042" y="1213757"/>
+                    <a:ext cx="771703" cy="646331"/>
+                  </a:xfrm>
+                  <a:prstGeom prst="rect">
+                    <a:avLst/>
+                  </a:prstGeom>
+                  <a:blipFill>
+                    <a:blip r:embed="rId8"/>
+                    <a:stretch>
+                      <a:fillRect l="-9836" r="-9836" b="-3846"/>
+                    </a:stretch>
+                  </a:blipFill>
+                </p:spPr>
+                <p:txBody>
+                  <a:bodyPr/>
+                  <a:lstStyle/>
+                  <a:p>
+                    <a:r>
+                      <a:rPr lang="en-US">
+                        <a:noFill/>
+                      </a:rPr>
+                      <a:t> </a:t>
+                    </a:r>
+                  </a:p>
+                </p:txBody>
+              </p:sp>
+            </mc:Fallback>
+          </mc:AlternateContent>
+          <p:sp>
+            <p:nvSpPr>
+              <p:cNvPr id="24" name="Oval 23">
+                <a:extLst>
+                  <a:ext uri="{FF2B5EF4-FFF2-40B4-BE49-F238E27FC236}">
+                    <a16:creationId xmlns:a16="http://schemas.microsoft.com/office/drawing/2014/main" id="{E0A3C090-8DFE-E1DE-17DB-B419240E0FF0}"/>
+                  </a:ext>
+                </a:extLst>
+              </p:cNvPr>
+              <p:cNvSpPr/>
+              <p:nvPr/>
+            </p:nvSpPr>
+            <p:spPr>
+              <a:xfrm>
+                <a:off x="2060003" y="1104900"/>
+                <a:ext cx="914400" cy="914400"/>
+              </a:xfrm>
+              <a:prstGeom prst="ellipse">
+                <a:avLst/>
+              </a:prstGeom>
+              <a:noFill/>
+              <a:ln>
+                <a:solidFill>
+                  <a:schemeClr val="tx1"/>
+                </a:solidFill>
+              </a:ln>
+            </p:spPr>
+            <p:style>
+              <a:lnRef idx="2">
+                <a:schemeClr val="accent1">
+                  <a:shade val="15000"/>
+                </a:schemeClr>
+              </a:lnRef>
+              <a:fillRef idx="1">
+                <a:schemeClr val="accent1"/>
+              </a:fillRef>
+              <a:effectRef idx="0">
+                <a:schemeClr val="accent1"/>
+              </a:effectRef>
+              <a:fontRef idx="minor">
+                <a:schemeClr val="lt1"/>
+              </a:fontRef>
+            </p:style>
+            <p:txBody>
+              <a:bodyPr rtlCol="0" anchor="ctr"/>
+              <a:lstStyle/>
+              <a:p>
+                <a:pPr algn="ctr"/>
+                <a:endParaRPr lang="en-US"/>
+              </a:p>
+            </p:txBody>
+          </p:sp>
+        </p:grpSp>
+        <p:grpSp>
+          <p:nvGrpSpPr>
+            <p:cNvPr id="25" name="Group 24">
+              <a:extLst>
+                <a:ext uri="{FF2B5EF4-FFF2-40B4-BE49-F238E27FC236}">
+                  <a16:creationId xmlns:a16="http://schemas.microsoft.com/office/drawing/2014/main" id="{61FA1CC4-40C0-AFA5-03A0-581663E39E25}"/>
+                </a:ext>
+              </a:extLst>
+            </p:cNvPr>
+            <p:cNvGrpSpPr/>
+            <p:nvPr/>
+          </p:nvGrpSpPr>
+          <p:grpSpPr>
+            <a:xfrm>
+              <a:off x="6454753" y="3094927"/>
+              <a:ext cx="914400" cy="914400"/>
+              <a:chOff x="2060003" y="1104900"/>
+              <a:chExt cx="914400" cy="914400"/>
+            </a:xfrm>
+          </p:grpSpPr>
+          <mc:AlternateContent xmlns:mc="http://schemas.openxmlformats.org/markup-compatibility/2006">
+            <mc:Choice xmlns:a14="http://schemas.microsoft.com/office/drawing/2010/main" Requires="a14">
+              <p:sp>
+                <p:nvSpPr>
+                  <p:cNvPr id="26" name="TextBox 25">
+                    <a:extLst>
+                      <a:ext uri="{FF2B5EF4-FFF2-40B4-BE49-F238E27FC236}">
+                        <a16:creationId xmlns:a16="http://schemas.microsoft.com/office/drawing/2014/main" id="{2E3E0A30-8CA5-DCDF-EDFD-F56C8008E13D}"/>
+                      </a:ext>
+                    </a:extLst>
+                  </p:cNvPr>
+                  <p:cNvSpPr txBox="1"/>
+                  <p:nvPr/>
+                </p:nvSpPr>
+                <p:spPr>
+                  <a:xfrm>
+                    <a:off x="2170042" y="1213757"/>
+                    <a:ext cx="771703" cy="646331"/>
+                  </a:xfrm>
+                  <a:prstGeom prst="rect">
+                    <a:avLst/>
+                  </a:prstGeom>
+                  <a:noFill/>
+                </p:spPr>
+                <p:txBody>
+                  <a:bodyPr wrap="square" rtlCol="0" anchor="ctr">
+                    <a:spAutoFit/>
+                  </a:bodyPr>
+                  <a:lstStyle/>
+                  <a:p>
+                    <a:pPr/>
+                    <a14:m>
+                      <m:oMathPara xmlns:m="http://schemas.openxmlformats.org/officeDocument/2006/math">
+                        <m:oMathParaPr>
+                          <m:jc m:val="center"/>
+                        </m:oMathParaPr>
+                        <m:oMath xmlns:m="http://schemas.openxmlformats.org/officeDocument/2006/math">
+                          <m:sSub>
+                            <m:sSubPr>
+                              <m:ctrlPr>
+                                <a:rPr lang="en-US" sz="3600" i="1" smtClean="0">
+                                  <a:latin typeface="Cambria Math" panose="02040503050406030204" pitchFamily="18" charset="0"/>
+                                </a:rPr>
+                              </m:ctrlPr>
+                            </m:sSubPr>
+                            <m:e>
+                              <m:r>
+                                <a:rPr lang="en-US" sz="3600" b="0" i="1" smtClean="0">
+                                  <a:latin typeface="Cambria Math" panose="02040503050406030204" pitchFamily="18" charset="0"/>
+                                </a:rPr>
+                                <m:t>𝑑</m:t>
+                              </m:r>
+                            </m:e>
+                            <m:sub>
+                              <m:r>
+                                <a:rPr lang="en-US" sz="3600" b="0" i="1" smtClean="0">
+                                  <a:latin typeface="Cambria Math" panose="02040503050406030204" pitchFamily="18" charset="0"/>
+                                </a:rPr>
+                                <m:t>23</m:t>
+                              </m:r>
+                            </m:sub>
+                          </m:sSub>
+                        </m:oMath>
+                      </m:oMathPara>
+                    </a14:m>
+                    <a:endParaRPr lang="en-US" sz="3600" dirty="0"/>
+                  </a:p>
+                </p:txBody>
+              </p:sp>
+            </mc:Choice>
+            <mc:Fallback>
+              <p:sp>
+                <p:nvSpPr>
+                  <p:cNvPr id="26" name="TextBox 25">
+                    <a:extLst>
+                      <a:ext uri="{FF2B5EF4-FFF2-40B4-BE49-F238E27FC236}">
+                        <a16:creationId xmlns:a16="http://schemas.microsoft.com/office/drawing/2014/main" id="{2E3E0A30-8CA5-DCDF-EDFD-F56C8008E13D}"/>
+                      </a:ext>
+                    </a:extLst>
+                  </p:cNvPr>
+                  <p:cNvSpPr txBox="1">
+                    <a:spLocks noRot="1" noChangeAspect="1" noMove="1" noResize="1" noEditPoints="1" noAdjustHandles="1" noChangeArrowheads="1" noChangeShapeType="1" noTextEdit="1"/>
+                  </p:cNvSpPr>
+                  <p:nvPr/>
+                </p:nvSpPr>
+                <p:spPr>
+                  <a:xfrm>
+                    <a:off x="2170042" y="1213757"/>
+                    <a:ext cx="771703" cy="646331"/>
+                  </a:xfrm>
+                  <a:prstGeom prst="rect">
+                    <a:avLst/>
+                  </a:prstGeom>
+                  <a:blipFill>
+                    <a:blip r:embed="rId9"/>
+                    <a:stretch>
+                      <a:fillRect l="-8065" r="-11290" b="-3846"/>
+                    </a:stretch>
+                  </a:blipFill>
+                </p:spPr>
+                <p:txBody>
+                  <a:bodyPr/>
+                  <a:lstStyle/>
+                  <a:p>
+                    <a:r>
+                      <a:rPr lang="en-US">
+                        <a:noFill/>
+                      </a:rPr>
+                      <a:t> </a:t>
+                    </a:r>
+                  </a:p>
+                </p:txBody>
+              </p:sp>
+            </mc:Fallback>
+          </mc:AlternateContent>
+          <p:sp>
+            <p:nvSpPr>
+              <p:cNvPr id="27" name="Oval 26">
+                <a:extLst>
+                  <a:ext uri="{FF2B5EF4-FFF2-40B4-BE49-F238E27FC236}">
+                    <a16:creationId xmlns:a16="http://schemas.microsoft.com/office/drawing/2014/main" id="{C5EC1043-5E70-76A4-7CFE-59398246EB82}"/>
+                  </a:ext>
+                </a:extLst>
+              </p:cNvPr>
+              <p:cNvSpPr/>
+              <p:nvPr/>
+            </p:nvSpPr>
+            <p:spPr>
+              <a:xfrm>
+                <a:off x="2060003" y="1104900"/>
+                <a:ext cx="914400" cy="914400"/>
+              </a:xfrm>
+              <a:prstGeom prst="ellipse">
+                <a:avLst/>
+              </a:prstGeom>
+              <a:noFill/>
+              <a:ln>
+                <a:solidFill>
+                  <a:schemeClr val="tx1"/>
+                </a:solidFill>
+              </a:ln>
+            </p:spPr>
+            <p:style>
+              <a:lnRef idx="2">
+                <a:schemeClr val="accent1">
+                  <a:shade val="15000"/>
+                </a:schemeClr>
+              </a:lnRef>
+              <a:fillRef idx="1">
+                <a:schemeClr val="accent1"/>
+              </a:fillRef>
+              <a:effectRef idx="0">
+                <a:schemeClr val="accent1"/>
+              </a:effectRef>
+              <a:fontRef idx="minor">
+                <a:schemeClr val="lt1"/>
+              </a:fontRef>
+            </p:style>
+            <p:txBody>
+              <a:bodyPr rtlCol="0" anchor="ctr"/>
+              <a:lstStyle/>
+              <a:p>
+                <a:pPr algn="ctr"/>
+                <a:endParaRPr lang="en-US"/>
+              </a:p>
+            </p:txBody>
+          </p:sp>
+        </p:grpSp>
+        <p:grpSp>
+          <p:nvGrpSpPr>
+            <p:cNvPr id="28" name="Group 27">
+              <a:extLst>
+                <a:ext uri="{FF2B5EF4-FFF2-40B4-BE49-F238E27FC236}">
+                  <a16:creationId xmlns:a16="http://schemas.microsoft.com/office/drawing/2014/main" id="{550877CC-88E5-86C4-19FF-D5F73DC73EA8}"/>
+                </a:ext>
+              </a:extLst>
+            </p:cNvPr>
+            <p:cNvGrpSpPr/>
+            <p:nvPr/>
+          </p:nvGrpSpPr>
+          <p:grpSpPr>
+            <a:xfrm>
+              <a:off x="8193390" y="3120105"/>
+              <a:ext cx="914400" cy="914400"/>
+              <a:chOff x="2060003" y="1104900"/>
+              <a:chExt cx="914400" cy="914400"/>
+            </a:xfrm>
+          </p:grpSpPr>
+          <mc:AlternateContent xmlns:mc="http://schemas.openxmlformats.org/markup-compatibility/2006">
+            <mc:Choice xmlns:a14="http://schemas.microsoft.com/office/drawing/2010/main" Requires="a14">
+              <p:sp>
+                <p:nvSpPr>
+                  <p:cNvPr id="29" name="TextBox 28">
+                    <a:extLst>
+                      <a:ext uri="{FF2B5EF4-FFF2-40B4-BE49-F238E27FC236}">
+                        <a16:creationId xmlns:a16="http://schemas.microsoft.com/office/drawing/2014/main" id="{F64D724E-A5D6-E7D4-919F-D213792CA9D9}"/>
+                      </a:ext>
+                    </a:extLst>
+                  </p:cNvPr>
+                  <p:cNvSpPr txBox="1"/>
+                  <p:nvPr/>
+                </p:nvSpPr>
+                <p:spPr>
+                  <a:xfrm>
+                    <a:off x="2170042" y="1213757"/>
+                    <a:ext cx="771703" cy="646331"/>
+                  </a:xfrm>
+                  <a:prstGeom prst="rect">
+                    <a:avLst/>
+                  </a:prstGeom>
+                  <a:noFill/>
+                </p:spPr>
+                <p:txBody>
+                  <a:bodyPr wrap="square" rtlCol="0" anchor="ctr">
+                    <a:spAutoFit/>
+                  </a:bodyPr>
+                  <a:lstStyle/>
+                  <a:p>
+                    <a:pPr/>
+                    <a14:m>
+                      <m:oMathPara xmlns:m="http://schemas.openxmlformats.org/officeDocument/2006/math">
+                        <m:oMathParaPr>
+                          <m:jc m:val="center"/>
+                        </m:oMathParaPr>
+                        <m:oMath xmlns:m="http://schemas.openxmlformats.org/officeDocument/2006/math">
+                          <m:sSub>
+                            <m:sSubPr>
+                              <m:ctrlPr>
+                                <a:rPr lang="en-US" sz="3600" i="1" smtClean="0">
+                                  <a:latin typeface="Cambria Math" panose="02040503050406030204" pitchFamily="18" charset="0"/>
+                                </a:rPr>
+                              </m:ctrlPr>
+                            </m:sSubPr>
+                            <m:e>
+                              <m:r>
+                                <a:rPr lang="en-US" sz="3600" b="0" i="1" smtClean="0">
+                                  <a:latin typeface="Cambria Math" panose="02040503050406030204" pitchFamily="18" charset="0"/>
+                                </a:rPr>
+                                <m:t>𝑑</m:t>
+                              </m:r>
+                            </m:e>
+                            <m:sub>
+                              <m:r>
+                                <a:rPr lang="en-US" sz="3600" b="0" i="1" smtClean="0">
+                                  <a:latin typeface="Cambria Math" panose="02040503050406030204" pitchFamily="18" charset="0"/>
+                                </a:rPr>
+                                <m:t>24</m:t>
+                              </m:r>
+                            </m:sub>
+                          </m:sSub>
+                        </m:oMath>
+                      </m:oMathPara>
+                    </a14:m>
+                    <a:endParaRPr lang="en-US" sz="3600" dirty="0"/>
+                  </a:p>
+                </p:txBody>
+              </p:sp>
+            </mc:Choice>
+            <mc:Fallback>
+              <p:sp>
+                <p:nvSpPr>
+                  <p:cNvPr id="29" name="TextBox 28">
+                    <a:extLst>
+                      <a:ext uri="{FF2B5EF4-FFF2-40B4-BE49-F238E27FC236}">
+                        <a16:creationId xmlns:a16="http://schemas.microsoft.com/office/drawing/2014/main" id="{F64D724E-A5D6-E7D4-919F-D213792CA9D9}"/>
+                      </a:ext>
+                    </a:extLst>
+                  </p:cNvPr>
+                  <p:cNvSpPr txBox="1">
+                    <a:spLocks noRot="1" noChangeAspect="1" noMove="1" noResize="1" noEditPoints="1" noAdjustHandles="1" noChangeArrowheads="1" noChangeShapeType="1" noTextEdit="1"/>
+                  </p:cNvSpPr>
+                  <p:nvPr/>
+                </p:nvSpPr>
+                <p:spPr>
+                  <a:xfrm>
+                    <a:off x="2170042" y="1213757"/>
+                    <a:ext cx="771703" cy="646331"/>
+                  </a:xfrm>
+                  <a:prstGeom prst="rect">
+                    <a:avLst/>
+                  </a:prstGeom>
+                  <a:blipFill>
+                    <a:blip r:embed="rId10"/>
+                    <a:stretch>
+                      <a:fillRect l="-8065" r="-9677" b="-3846"/>
+                    </a:stretch>
+                  </a:blipFill>
+                </p:spPr>
+                <p:txBody>
+                  <a:bodyPr/>
+                  <a:lstStyle/>
+                  <a:p>
+                    <a:r>
+                      <a:rPr lang="en-US">
+                        <a:noFill/>
+                      </a:rPr>
+                      <a:t> </a:t>
+                    </a:r>
+                  </a:p>
+                </p:txBody>
+              </p:sp>
+            </mc:Fallback>
+          </mc:AlternateContent>
+          <p:sp>
+            <p:nvSpPr>
+              <p:cNvPr id="30" name="Oval 29">
+                <a:extLst>
+                  <a:ext uri="{FF2B5EF4-FFF2-40B4-BE49-F238E27FC236}">
+                    <a16:creationId xmlns:a16="http://schemas.microsoft.com/office/drawing/2014/main" id="{4CCAFCD2-924A-57F7-53E2-30E0B81B6E62}"/>
+                  </a:ext>
+                </a:extLst>
+              </p:cNvPr>
+              <p:cNvSpPr/>
+              <p:nvPr/>
+            </p:nvSpPr>
+            <p:spPr>
+              <a:xfrm>
+                <a:off x="2060003" y="1104900"/>
+                <a:ext cx="914400" cy="914400"/>
+              </a:xfrm>
+              <a:prstGeom prst="ellipse">
+                <a:avLst/>
+              </a:prstGeom>
+              <a:noFill/>
+              <a:ln>
+                <a:solidFill>
+                  <a:schemeClr val="tx1"/>
+                </a:solidFill>
+              </a:ln>
+            </p:spPr>
+            <p:style>
+              <a:lnRef idx="2">
+                <a:schemeClr val="accent1">
+                  <a:shade val="15000"/>
+                </a:schemeClr>
+              </a:lnRef>
+              <a:fillRef idx="1">
+                <a:schemeClr val="accent1"/>
+              </a:fillRef>
+              <a:effectRef idx="0">
+                <a:schemeClr val="accent1"/>
+              </a:effectRef>
+              <a:fontRef idx="minor">
+                <a:schemeClr val="lt1"/>
+              </a:fontRef>
+            </p:style>
+            <p:txBody>
+              <a:bodyPr rtlCol="0" anchor="ctr"/>
+              <a:lstStyle/>
+              <a:p>
+                <a:pPr algn="ctr"/>
+                <a:endParaRPr lang="en-US"/>
+              </a:p>
+            </p:txBody>
+          </p:sp>
+        </p:grpSp>
+        <p:grpSp>
+          <p:nvGrpSpPr>
+            <p:cNvPr id="31" name="Group 30">
+              <a:extLst>
+                <a:ext uri="{FF2B5EF4-FFF2-40B4-BE49-F238E27FC236}">
+                  <a16:creationId xmlns:a16="http://schemas.microsoft.com/office/drawing/2014/main" id="{8EAFC870-EFAF-DD4B-E0ED-4DC7070754BC}"/>
+                </a:ext>
+              </a:extLst>
+            </p:cNvPr>
+            <p:cNvGrpSpPr/>
+            <p:nvPr/>
+          </p:nvGrpSpPr>
+          <p:grpSpPr>
+            <a:xfrm>
+              <a:off x="9932027" y="3120105"/>
+              <a:ext cx="914400" cy="914400"/>
+              <a:chOff x="2060003" y="1104900"/>
+              <a:chExt cx="914400" cy="914400"/>
+            </a:xfrm>
+          </p:grpSpPr>
+          <mc:AlternateContent xmlns:mc="http://schemas.openxmlformats.org/markup-compatibility/2006">
+            <mc:Choice xmlns:a14="http://schemas.microsoft.com/office/drawing/2010/main" Requires="a14">
+              <p:sp>
+                <p:nvSpPr>
+                  <p:cNvPr id="32" name="TextBox 31">
+                    <a:extLst>
+                      <a:ext uri="{FF2B5EF4-FFF2-40B4-BE49-F238E27FC236}">
+                        <a16:creationId xmlns:a16="http://schemas.microsoft.com/office/drawing/2014/main" id="{F730693B-9554-6E88-7FDF-5D5438AA7EFC}"/>
+                      </a:ext>
+                    </a:extLst>
+                  </p:cNvPr>
+                  <p:cNvSpPr txBox="1"/>
+                  <p:nvPr/>
+                </p:nvSpPr>
+                <p:spPr>
+                  <a:xfrm>
+                    <a:off x="2170042" y="1213757"/>
+                    <a:ext cx="771703" cy="646331"/>
+                  </a:xfrm>
+                  <a:prstGeom prst="rect">
+                    <a:avLst/>
+                  </a:prstGeom>
+                  <a:noFill/>
+                </p:spPr>
+                <p:txBody>
+                  <a:bodyPr wrap="square" rtlCol="0" anchor="ctr">
+                    <a:spAutoFit/>
+                  </a:bodyPr>
+                  <a:lstStyle/>
+                  <a:p>
+                    <a:pPr/>
+                    <a14:m>
+                      <m:oMathPara xmlns:m="http://schemas.openxmlformats.org/officeDocument/2006/math">
+                        <m:oMathParaPr>
+                          <m:jc m:val="center"/>
+                        </m:oMathParaPr>
+                        <m:oMath xmlns:m="http://schemas.openxmlformats.org/officeDocument/2006/math">
+                          <m:sSub>
+                            <m:sSubPr>
+                              <m:ctrlPr>
+                                <a:rPr lang="en-US" sz="3600" i="1" smtClean="0">
+                                  <a:latin typeface="Cambria Math" panose="02040503050406030204" pitchFamily="18" charset="0"/>
+                                </a:rPr>
+                              </m:ctrlPr>
+                            </m:sSubPr>
+                            <m:e>
+                              <m:r>
+                                <a:rPr lang="en-US" sz="3600" b="0" i="1" smtClean="0">
+                                  <a:latin typeface="Cambria Math" panose="02040503050406030204" pitchFamily="18" charset="0"/>
+                                </a:rPr>
+                                <m:t>𝑑</m:t>
+                              </m:r>
+                            </m:e>
+                            <m:sub>
+                              <m:r>
+                                <a:rPr lang="en-US" sz="3600" b="0" i="1" smtClean="0">
+                                  <a:latin typeface="Cambria Math" panose="02040503050406030204" pitchFamily="18" charset="0"/>
+                                </a:rPr>
+                                <m:t>34</m:t>
+                              </m:r>
+                            </m:sub>
+                          </m:sSub>
+                        </m:oMath>
+                      </m:oMathPara>
+                    </a14:m>
+                    <a:endParaRPr lang="en-US" sz="3600" dirty="0"/>
+                  </a:p>
+                </p:txBody>
+              </p:sp>
+            </mc:Choice>
+            <mc:Fallback>
+              <p:sp>
+                <p:nvSpPr>
+                  <p:cNvPr id="32" name="TextBox 31">
+                    <a:extLst>
+                      <a:ext uri="{FF2B5EF4-FFF2-40B4-BE49-F238E27FC236}">
+                        <a16:creationId xmlns:a16="http://schemas.microsoft.com/office/drawing/2014/main" id="{F730693B-9554-6E88-7FDF-5D5438AA7EFC}"/>
+                      </a:ext>
+                    </a:extLst>
+                  </p:cNvPr>
+                  <p:cNvSpPr txBox="1">
+                    <a:spLocks noRot="1" noChangeAspect="1" noMove="1" noResize="1" noEditPoints="1" noAdjustHandles="1" noChangeArrowheads="1" noChangeShapeType="1" noTextEdit="1"/>
+                  </p:cNvSpPr>
+                  <p:nvPr/>
+                </p:nvSpPr>
+                <p:spPr>
+                  <a:xfrm>
+                    <a:off x="2170042" y="1213757"/>
+                    <a:ext cx="771703" cy="646331"/>
+                  </a:xfrm>
+                  <a:prstGeom prst="rect">
+                    <a:avLst/>
+                  </a:prstGeom>
+                  <a:blipFill>
+                    <a:blip r:embed="rId11"/>
+                    <a:stretch>
+                      <a:fillRect l="-8065" r="-11290" b="-3846"/>
+                    </a:stretch>
+                  </a:blipFill>
+                </p:spPr>
+                <p:txBody>
+                  <a:bodyPr/>
+                  <a:lstStyle/>
+                  <a:p>
+                    <a:r>
+                      <a:rPr lang="en-US">
+                        <a:noFill/>
+                      </a:rPr>
+                      <a:t> </a:t>
+                    </a:r>
+                  </a:p>
+                </p:txBody>
+              </p:sp>
+            </mc:Fallback>
+          </mc:AlternateContent>
+          <p:sp>
+            <p:nvSpPr>
+              <p:cNvPr id="33" name="Oval 32">
+                <a:extLst>
+                  <a:ext uri="{FF2B5EF4-FFF2-40B4-BE49-F238E27FC236}">
+                    <a16:creationId xmlns:a16="http://schemas.microsoft.com/office/drawing/2014/main" id="{94B467D3-A5B9-0FBA-5518-F9A604B40827}"/>
+                  </a:ext>
+                </a:extLst>
+              </p:cNvPr>
+              <p:cNvSpPr/>
+              <p:nvPr/>
+            </p:nvSpPr>
+            <p:spPr>
+              <a:xfrm>
+                <a:off x="2060003" y="1104900"/>
+                <a:ext cx="914400" cy="914400"/>
+              </a:xfrm>
+              <a:prstGeom prst="ellipse">
+                <a:avLst/>
+              </a:prstGeom>
+              <a:noFill/>
+              <a:ln>
+                <a:solidFill>
+                  <a:schemeClr val="tx1"/>
+                </a:solidFill>
+              </a:ln>
+            </p:spPr>
+            <p:style>
+              <a:lnRef idx="2">
+                <a:schemeClr val="accent1">
+                  <a:shade val="15000"/>
+                </a:schemeClr>
+              </a:lnRef>
+              <a:fillRef idx="1">
+                <a:schemeClr val="accent1"/>
+              </a:fillRef>
+              <a:effectRef idx="0">
+                <a:schemeClr val="accent1"/>
+              </a:effectRef>
+              <a:fontRef idx="minor">
+                <a:schemeClr val="lt1"/>
+              </a:fontRef>
+            </p:style>
+            <p:txBody>
+              <a:bodyPr rtlCol="0" anchor="ctr"/>
+              <a:lstStyle/>
+              <a:p>
+                <a:pPr algn="ctr"/>
+                <a:endParaRPr lang="en-US"/>
+              </a:p>
+            </p:txBody>
+          </p:sp>
+        </p:grpSp>
+        <p:cxnSp>
+          <p:nvCxnSpPr>
+            <p:cNvPr id="35" name="Straight Arrow Connector 34">
+              <a:extLst>
+                <a:ext uri="{FF2B5EF4-FFF2-40B4-BE49-F238E27FC236}">
+                  <a16:creationId xmlns:a16="http://schemas.microsoft.com/office/drawing/2014/main" id="{2D365E2D-A8C0-1BAB-CE8D-7BF9AD3FB9FE}"/>
+                </a:ext>
+              </a:extLst>
+            </p:cNvPr>
+            <p:cNvCxnSpPr>
+              <a:cxnSpLocks/>
+              <a:stCxn id="5" idx="3"/>
+              <a:endCxn id="18" idx="7"/>
+            </p:cNvCxnSpPr>
+            <p:nvPr/>
+          </p:nvCxnSpPr>
+          <p:spPr>
+            <a:xfrm flipH="1">
+              <a:off x="2019331" y="1575123"/>
+              <a:ext cx="1938069" cy="1678893"/>
+            </a:xfrm>
+            <a:prstGeom prst="straightConnector1">
+              <a:avLst/>
+            </a:prstGeom>
+            <a:ln>
+              <a:solidFill>
+                <a:schemeClr val="tx1"/>
+              </a:solidFill>
+              <a:headEnd w="lg" len="lg"/>
+              <a:tailEnd type="triangle" w="lg" len="lg"/>
+            </a:ln>
+          </p:spPr>
+          <p:style>
+            <a:lnRef idx="2">
+              <a:schemeClr val="accent1"/>
+            </a:lnRef>
+            <a:fillRef idx="0">
+              <a:schemeClr val="accent1"/>
+            </a:fillRef>
+            <a:effectRef idx="1">
+              <a:schemeClr val="accent1"/>
+            </a:effectRef>
+            <a:fontRef idx="minor">
+              <a:schemeClr val="tx1"/>
+            </a:fontRef>
+          </p:style>
+        </p:cxnSp>
+        <p:cxnSp>
+          <p:nvCxnSpPr>
+            <p:cNvPr id="36" name="Straight Arrow Connector 35">
+              <a:extLst>
+                <a:ext uri="{FF2B5EF4-FFF2-40B4-BE49-F238E27FC236}">
+                  <a16:creationId xmlns:a16="http://schemas.microsoft.com/office/drawing/2014/main" id="{30924B2B-F4B5-C278-3C50-A4DD3EB46283}"/>
+                </a:ext>
+              </a:extLst>
+            </p:cNvPr>
+            <p:cNvCxnSpPr>
+              <a:cxnSpLocks/>
+              <a:stCxn id="9" idx="3"/>
+              <a:endCxn id="18" idx="7"/>
+            </p:cNvCxnSpPr>
+            <p:nvPr/>
+          </p:nvCxnSpPr>
+          <p:spPr>
+            <a:xfrm flipH="1">
+              <a:off x="2019331" y="1575123"/>
+              <a:ext cx="3127333" cy="1678893"/>
+            </a:xfrm>
+            <a:prstGeom prst="straightConnector1">
+              <a:avLst/>
+            </a:prstGeom>
+            <a:ln>
+              <a:solidFill>
+                <a:srgbClr val="DD4124"/>
+              </a:solidFill>
+              <a:headEnd w="lg" len="lg"/>
+              <a:tailEnd type="triangle" w="lg" len="lg"/>
+            </a:ln>
+          </p:spPr>
+          <p:style>
+            <a:lnRef idx="2">
+              <a:schemeClr val="accent1"/>
+            </a:lnRef>
+            <a:fillRef idx="0">
+              <a:schemeClr val="accent1"/>
+            </a:fillRef>
+            <a:effectRef idx="1">
+              <a:schemeClr val="accent1"/>
+            </a:effectRef>
+            <a:fontRef idx="minor">
+              <a:schemeClr val="tx1"/>
+            </a:fontRef>
+          </p:style>
+        </p:cxnSp>
+        <p:cxnSp>
+          <p:nvCxnSpPr>
+            <p:cNvPr id="40" name="Straight Arrow Connector 39">
+              <a:extLst>
+                <a:ext uri="{FF2B5EF4-FFF2-40B4-BE49-F238E27FC236}">
+                  <a16:creationId xmlns:a16="http://schemas.microsoft.com/office/drawing/2014/main" id="{BD5959B2-08A2-78D4-5599-8181246969FC}"/>
+                </a:ext>
+              </a:extLst>
+            </p:cNvPr>
+            <p:cNvCxnSpPr>
+              <a:cxnSpLocks/>
+              <a:stCxn id="5" idx="4"/>
+              <a:endCxn id="21" idx="0"/>
+            </p:cNvCxnSpPr>
+            <p:nvPr/>
+          </p:nvCxnSpPr>
+          <p:spPr>
+            <a:xfrm flipH="1">
+              <a:off x="3434679" y="1709034"/>
+              <a:ext cx="846010" cy="1411071"/>
+            </a:xfrm>
+            <a:prstGeom prst="straightConnector1">
+              <a:avLst/>
+            </a:prstGeom>
+            <a:ln>
+              <a:solidFill>
+                <a:schemeClr val="tx1"/>
+              </a:solidFill>
+              <a:headEnd w="lg" len="lg"/>
+              <a:tailEnd type="triangle" w="lg" len="lg"/>
+            </a:ln>
+          </p:spPr>
+          <p:style>
+            <a:lnRef idx="2">
+              <a:schemeClr val="accent1"/>
+            </a:lnRef>
+            <a:fillRef idx="0">
+              <a:schemeClr val="accent1"/>
+            </a:fillRef>
+            <a:effectRef idx="1">
+              <a:schemeClr val="accent1"/>
+            </a:effectRef>
+            <a:fontRef idx="minor">
+              <a:schemeClr val="tx1"/>
+            </a:fontRef>
+          </p:style>
+        </p:cxnSp>
+        <p:cxnSp>
+          <p:nvCxnSpPr>
+            <p:cNvPr id="43" name="Straight Arrow Connector 42">
+              <a:extLst>
+                <a:ext uri="{FF2B5EF4-FFF2-40B4-BE49-F238E27FC236}">
+                  <a16:creationId xmlns:a16="http://schemas.microsoft.com/office/drawing/2014/main" id="{F4A35B08-A38D-64A4-5650-A7B037A21DB5}"/>
+                </a:ext>
+              </a:extLst>
+            </p:cNvPr>
+            <p:cNvCxnSpPr>
+              <a:cxnSpLocks/>
+              <a:stCxn id="12" idx="3"/>
+              <a:endCxn id="21" idx="0"/>
+            </p:cNvCxnSpPr>
+            <p:nvPr/>
+          </p:nvCxnSpPr>
+          <p:spPr>
+            <a:xfrm flipH="1">
+              <a:off x="3434679" y="1549945"/>
+              <a:ext cx="2901249" cy="1570160"/>
+            </a:xfrm>
+            <a:prstGeom prst="straightConnector1">
+              <a:avLst/>
+            </a:prstGeom>
+            <a:ln>
+              <a:solidFill>
+                <a:srgbClr val="DD4124"/>
+              </a:solidFill>
+              <a:headEnd w="lg" len="lg"/>
+              <a:tailEnd type="triangle" w="lg" len="lg"/>
+            </a:ln>
+          </p:spPr>
+          <p:style>
+            <a:lnRef idx="2">
+              <a:schemeClr val="accent1"/>
+            </a:lnRef>
+            <a:fillRef idx="0">
+              <a:schemeClr val="accent1"/>
+            </a:fillRef>
+            <a:effectRef idx="1">
+              <a:schemeClr val="accent1"/>
+            </a:effectRef>
+            <a:fontRef idx="minor">
+              <a:schemeClr val="tx1"/>
+            </a:fontRef>
+          </p:style>
+        </p:cxnSp>
+        <p:cxnSp>
+          <p:nvCxnSpPr>
+            <p:cNvPr id="46" name="Straight Arrow Connector 45">
+              <a:extLst>
+                <a:ext uri="{FF2B5EF4-FFF2-40B4-BE49-F238E27FC236}">
+                  <a16:creationId xmlns:a16="http://schemas.microsoft.com/office/drawing/2014/main" id="{6887DB67-C749-91DE-6330-12DA80BF1EF4}"/>
+                </a:ext>
+              </a:extLst>
+            </p:cNvPr>
+            <p:cNvCxnSpPr>
+              <a:cxnSpLocks/>
+              <a:stCxn id="5" idx="5"/>
+              <a:endCxn id="24" idx="0"/>
+            </p:cNvCxnSpPr>
+            <p:nvPr/>
+          </p:nvCxnSpPr>
+          <p:spPr>
+            <a:xfrm>
+              <a:off x="4603978" y="1575123"/>
+              <a:ext cx="569338" cy="1544982"/>
+            </a:xfrm>
+            <a:prstGeom prst="straightConnector1">
+              <a:avLst/>
+            </a:prstGeom>
+            <a:ln>
+              <a:solidFill>
+                <a:schemeClr val="tx1"/>
+              </a:solidFill>
+              <a:headEnd w="lg" len="lg"/>
+              <a:tailEnd type="triangle" w="lg" len="lg"/>
+            </a:ln>
+          </p:spPr>
+          <p:style>
+            <a:lnRef idx="2">
+              <a:schemeClr val="accent1"/>
+            </a:lnRef>
+            <a:fillRef idx="0">
+              <a:schemeClr val="accent1"/>
+            </a:fillRef>
+            <a:effectRef idx="1">
+              <a:schemeClr val="accent1"/>
+            </a:effectRef>
+            <a:fontRef idx="minor">
+              <a:schemeClr val="tx1"/>
+            </a:fontRef>
+          </p:style>
+        </p:cxnSp>
+        <p:cxnSp>
+          <p:nvCxnSpPr>
+            <p:cNvPr id="49" name="Straight Arrow Connector 48">
+              <a:extLst>
+                <a:ext uri="{FF2B5EF4-FFF2-40B4-BE49-F238E27FC236}">
+                  <a16:creationId xmlns:a16="http://schemas.microsoft.com/office/drawing/2014/main" id="{01480B6F-5881-B1AF-16F1-6B59B79C1FCB}"/>
+                </a:ext>
+              </a:extLst>
+            </p:cNvPr>
+            <p:cNvCxnSpPr>
+              <a:cxnSpLocks/>
+              <a:stCxn id="15" idx="3"/>
+              <a:endCxn id="24" idx="0"/>
+            </p:cNvCxnSpPr>
+            <p:nvPr/>
+          </p:nvCxnSpPr>
+          <p:spPr>
+            <a:xfrm flipH="1">
+              <a:off x="5173316" y="1549945"/>
+              <a:ext cx="2351876" cy="1570160"/>
+            </a:xfrm>
+            <a:prstGeom prst="straightConnector1">
+              <a:avLst/>
+            </a:prstGeom>
+            <a:ln>
+              <a:solidFill>
+                <a:srgbClr val="DD4124"/>
+              </a:solidFill>
+              <a:headEnd w="lg" len="lg"/>
+              <a:tailEnd type="triangle" w="lg" len="lg"/>
+            </a:ln>
+          </p:spPr>
+          <p:style>
+            <a:lnRef idx="2">
+              <a:schemeClr val="accent1"/>
+            </a:lnRef>
+            <a:fillRef idx="0">
+              <a:schemeClr val="accent1"/>
+            </a:fillRef>
+            <a:effectRef idx="1">
+              <a:schemeClr val="accent1"/>
+            </a:effectRef>
+            <a:fontRef idx="minor">
+              <a:schemeClr val="tx1"/>
+            </a:fontRef>
+          </p:style>
+        </p:cxnSp>
+        <p:cxnSp>
+          <p:nvCxnSpPr>
+            <p:cNvPr id="54" name="Straight Arrow Connector 53">
+              <a:extLst>
+                <a:ext uri="{FF2B5EF4-FFF2-40B4-BE49-F238E27FC236}">
+                  <a16:creationId xmlns:a16="http://schemas.microsoft.com/office/drawing/2014/main" id="{C093238E-DC00-2A24-7A82-C40947F20D64}"/>
+                </a:ext>
+              </a:extLst>
+            </p:cNvPr>
+            <p:cNvCxnSpPr>
+              <a:cxnSpLocks/>
+              <a:stCxn id="9" idx="4"/>
+              <a:endCxn id="27" idx="0"/>
+            </p:cNvCxnSpPr>
+            <p:nvPr/>
+          </p:nvCxnSpPr>
+          <p:spPr>
+            <a:xfrm>
+              <a:off x="5469953" y="1709034"/>
+              <a:ext cx="1442000" cy="1385893"/>
+            </a:xfrm>
+            <a:prstGeom prst="straightConnector1">
+              <a:avLst/>
+            </a:prstGeom>
+            <a:ln>
+              <a:solidFill>
+                <a:schemeClr val="tx1"/>
+              </a:solidFill>
+              <a:headEnd w="lg" len="lg"/>
+              <a:tailEnd type="triangle" w="lg" len="lg"/>
+            </a:ln>
+          </p:spPr>
+          <p:style>
+            <a:lnRef idx="2">
+              <a:schemeClr val="accent1"/>
+            </a:lnRef>
+            <a:fillRef idx="0">
+              <a:schemeClr val="accent1"/>
+            </a:fillRef>
+            <a:effectRef idx="1">
+              <a:schemeClr val="accent1"/>
+            </a:effectRef>
+            <a:fontRef idx="minor">
+              <a:schemeClr val="tx1"/>
+            </a:fontRef>
+          </p:style>
+        </p:cxnSp>
+        <p:cxnSp>
+          <p:nvCxnSpPr>
+            <p:cNvPr id="57" name="Straight Arrow Connector 56">
+              <a:extLst>
+                <a:ext uri="{FF2B5EF4-FFF2-40B4-BE49-F238E27FC236}">
+                  <a16:creationId xmlns:a16="http://schemas.microsoft.com/office/drawing/2014/main" id="{14C257AF-9767-DBDC-F839-5DDA352725D5}"/>
+                </a:ext>
+              </a:extLst>
+            </p:cNvPr>
+            <p:cNvCxnSpPr>
+              <a:cxnSpLocks/>
+              <a:stCxn id="12" idx="4"/>
+              <a:endCxn id="27" idx="0"/>
+            </p:cNvCxnSpPr>
+            <p:nvPr/>
+          </p:nvCxnSpPr>
+          <p:spPr>
+            <a:xfrm>
+              <a:off x="6659217" y="1683856"/>
+              <a:ext cx="252736" cy="1411071"/>
+            </a:xfrm>
+            <a:prstGeom prst="straightConnector1">
+              <a:avLst/>
+            </a:prstGeom>
+            <a:ln>
+              <a:solidFill>
+                <a:srgbClr val="DD4124"/>
+              </a:solidFill>
+              <a:headEnd w="lg" len="lg"/>
+              <a:tailEnd type="triangle" w="lg" len="lg"/>
+            </a:ln>
+          </p:spPr>
+          <p:style>
+            <a:lnRef idx="2">
+              <a:schemeClr val="accent1"/>
+            </a:lnRef>
+            <a:fillRef idx="0">
+              <a:schemeClr val="accent1"/>
+            </a:fillRef>
+            <a:effectRef idx="1">
+              <a:schemeClr val="accent1"/>
+            </a:effectRef>
+            <a:fontRef idx="minor">
+              <a:schemeClr val="tx1"/>
+            </a:fontRef>
+          </p:style>
+        </p:cxnSp>
+        <p:cxnSp>
+          <p:nvCxnSpPr>
+            <p:cNvPr id="60" name="Straight Arrow Connector 59">
+              <a:extLst>
+                <a:ext uri="{FF2B5EF4-FFF2-40B4-BE49-F238E27FC236}">
+                  <a16:creationId xmlns:a16="http://schemas.microsoft.com/office/drawing/2014/main" id="{4A53B2AF-C939-E5A5-15B6-48DE0CBBC0C0}"/>
+                </a:ext>
+              </a:extLst>
+            </p:cNvPr>
+            <p:cNvCxnSpPr>
+              <a:cxnSpLocks/>
+              <a:stCxn id="9" idx="5"/>
+              <a:endCxn id="30" idx="1"/>
+            </p:cNvCxnSpPr>
+            <p:nvPr/>
+          </p:nvCxnSpPr>
+          <p:spPr>
+            <a:xfrm>
+              <a:off x="5793242" y="1575123"/>
+              <a:ext cx="2534059" cy="1678893"/>
+            </a:xfrm>
+            <a:prstGeom prst="straightConnector1">
+              <a:avLst/>
+            </a:prstGeom>
+            <a:ln>
+              <a:solidFill>
+                <a:schemeClr val="tx1"/>
+              </a:solidFill>
+              <a:headEnd w="lg" len="lg"/>
+              <a:tailEnd type="triangle" w="lg" len="lg"/>
+            </a:ln>
+          </p:spPr>
+          <p:style>
+            <a:lnRef idx="2">
+              <a:schemeClr val="accent1"/>
+            </a:lnRef>
+            <a:fillRef idx="0">
+              <a:schemeClr val="accent1"/>
+            </a:fillRef>
+            <a:effectRef idx="1">
+              <a:schemeClr val="accent1"/>
+            </a:effectRef>
+            <a:fontRef idx="minor">
+              <a:schemeClr val="tx1"/>
+            </a:fontRef>
+          </p:style>
+        </p:cxnSp>
+        <p:cxnSp>
+          <p:nvCxnSpPr>
+            <p:cNvPr id="63" name="Straight Arrow Connector 62">
+              <a:extLst>
+                <a:ext uri="{FF2B5EF4-FFF2-40B4-BE49-F238E27FC236}">
+                  <a16:creationId xmlns:a16="http://schemas.microsoft.com/office/drawing/2014/main" id="{167D497F-15BB-0891-39FC-548CCF117773}"/>
+                </a:ext>
+              </a:extLst>
+            </p:cNvPr>
+            <p:cNvCxnSpPr>
+              <a:cxnSpLocks/>
+              <a:stCxn id="15" idx="4"/>
+              <a:endCxn id="30" idx="1"/>
+            </p:cNvCxnSpPr>
+            <p:nvPr/>
+          </p:nvCxnSpPr>
+          <p:spPr>
+            <a:xfrm>
+              <a:off x="7848481" y="1683856"/>
+              <a:ext cx="478820" cy="1570160"/>
+            </a:xfrm>
+            <a:prstGeom prst="straightConnector1">
+              <a:avLst/>
+            </a:prstGeom>
+            <a:ln>
+              <a:solidFill>
+                <a:srgbClr val="DD4124"/>
+              </a:solidFill>
+              <a:headEnd w="lg" len="lg"/>
+              <a:tailEnd type="triangle" w="lg" len="lg"/>
+            </a:ln>
+          </p:spPr>
+          <p:style>
+            <a:lnRef idx="2">
+              <a:schemeClr val="accent1"/>
+            </a:lnRef>
+            <a:fillRef idx="0">
+              <a:schemeClr val="accent1"/>
+            </a:fillRef>
+            <a:effectRef idx="1">
+              <a:schemeClr val="accent1"/>
+            </a:effectRef>
+            <a:fontRef idx="minor">
+              <a:schemeClr val="tx1"/>
+            </a:fontRef>
+          </p:style>
+        </p:cxnSp>
+        <p:cxnSp>
+          <p:nvCxnSpPr>
+            <p:cNvPr id="66" name="Straight Arrow Connector 65">
+              <a:extLst>
+                <a:ext uri="{FF2B5EF4-FFF2-40B4-BE49-F238E27FC236}">
+                  <a16:creationId xmlns:a16="http://schemas.microsoft.com/office/drawing/2014/main" id="{22CED125-DF2F-1EE5-1458-0BB9E02B9967}"/>
+                </a:ext>
+              </a:extLst>
+            </p:cNvPr>
+            <p:cNvCxnSpPr>
+              <a:cxnSpLocks/>
+              <a:stCxn id="12" idx="5"/>
+              <a:endCxn id="33" idx="1"/>
+            </p:cNvCxnSpPr>
+            <p:nvPr/>
+          </p:nvCxnSpPr>
+          <p:spPr>
+            <a:xfrm>
+              <a:off x="6982506" y="1549945"/>
+              <a:ext cx="3083432" cy="1704071"/>
+            </a:xfrm>
+            <a:prstGeom prst="straightConnector1">
+              <a:avLst/>
+            </a:prstGeom>
+            <a:ln>
+              <a:solidFill>
+                <a:schemeClr val="tx1"/>
+              </a:solidFill>
+              <a:headEnd w="lg" len="lg"/>
+              <a:tailEnd type="triangle" w="lg" len="lg"/>
+            </a:ln>
+          </p:spPr>
+          <p:style>
+            <a:lnRef idx="2">
+              <a:schemeClr val="accent1"/>
+            </a:lnRef>
+            <a:fillRef idx="0">
+              <a:schemeClr val="accent1"/>
+            </a:fillRef>
+            <a:effectRef idx="1">
+              <a:schemeClr val="accent1"/>
+            </a:effectRef>
+            <a:fontRef idx="minor">
+              <a:schemeClr val="tx1"/>
+            </a:fontRef>
+          </p:style>
+        </p:cxnSp>
+        <p:cxnSp>
+          <p:nvCxnSpPr>
+            <p:cNvPr id="69" name="Straight Arrow Connector 68">
+              <a:extLst>
+                <a:ext uri="{FF2B5EF4-FFF2-40B4-BE49-F238E27FC236}">
+                  <a16:creationId xmlns:a16="http://schemas.microsoft.com/office/drawing/2014/main" id="{3CB04611-A2DE-E93F-26AC-E96DAAFD702C}"/>
+                </a:ext>
+              </a:extLst>
+            </p:cNvPr>
+            <p:cNvCxnSpPr>
+              <a:cxnSpLocks/>
+              <a:stCxn id="15" idx="5"/>
+              <a:endCxn id="33" idx="1"/>
+            </p:cNvCxnSpPr>
+            <p:nvPr/>
+          </p:nvCxnSpPr>
+          <p:spPr>
+            <a:xfrm>
+              <a:off x="8171770" y="1549945"/>
+              <a:ext cx="1894168" cy="1704071"/>
+            </a:xfrm>
+            <a:prstGeom prst="straightConnector1">
+              <a:avLst/>
+            </a:prstGeom>
+            <a:ln>
+              <a:solidFill>
+                <a:srgbClr val="DD4124"/>
+              </a:solidFill>
+              <a:headEnd w="lg" len="lg"/>
+              <a:tailEnd type="triangle" w="lg" len="lg"/>
+            </a:ln>
+          </p:spPr>
+          <p:style>
+            <a:lnRef idx="2">
+              <a:schemeClr val="accent1"/>
+            </a:lnRef>
+            <a:fillRef idx="0">
+              <a:schemeClr val="accent1"/>
+            </a:fillRef>
+            <a:effectRef idx="1">
+              <a:schemeClr val="accent1"/>
+            </a:effectRef>
+            <a:fontRef idx="minor">
+              <a:schemeClr val="tx1"/>
+            </a:fontRef>
+          </p:style>
+        </p:cxnSp>
+        <p:cxnSp>
+          <p:nvCxnSpPr>
+            <p:cNvPr id="79" name="Curved Connector 78">
+              <a:extLst>
+                <a:ext uri="{FF2B5EF4-FFF2-40B4-BE49-F238E27FC236}">
+                  <a16:creationId xmlns:a16="http://schemas.microsoft.com/office/drawing/2014/main" id="{A448694E-21FB-6E36-E59E-2E761ABF8ADD}"/>
+                </a:ext>
+              </a:extLst>
+            </p:cNvPr>
+            <p:cNvCxnSpPr>
+              <a:cxnSpLocks/>
+              <a:stCxn id="5" idx="1"/>
+              <a:endCxn id="5" idx="0"/>
+            </p:cNvCxnSpPr>
+            <p:nvPr/>
+          </p:nvCxnSpPr>
+          <p:spPr>
+            <a:xfrm rot="5400000" flipH="1" flipV="1">
+              <a:off x="4052089" y="699946"/>
+              <a:ext cx="133911" cy="323289"/>
+            </a:xfrm>
+            <a:prstGeom prst="curvedConnector3">
+              <a:avLst>
+                <a:gd name="adj1" fmla="val 356066"/>
+              </a:avLst>
+            </a:prstGeom>
+            <a:ln>
+              <a:solidFill>
+                <a:schemeClr val="tx1"/>
+              </a:solidFill>
+              <a:tailEnd type="triangle"/>
+            </a:ln>
+          </p:spPr>
+          <p:style>
+            <a:lnRef idx="2">
+              <a:schemeClr val="accent1"/>
+            </a:lnRef>
+            <a:fillRef idx="0">
+              <a:schemeClr val="accent1"/>
+            </a:fillRef>
+            <a:effectRef idx="1">
+              <a:schemeClr val="accent1"/>
+            </a:effectRef>
+            <a:fontRef idx="minor">
+              <a:schemeClr val="tx1"/>
+            </a:fontRef>
+          </p:style>
+        </p:cxnSp>
+        <p:cxnSp>
+          <p:nvCxnSpPr>
+            <p:cNvPr id="85" name="Curved Connector 84">
+              <a:extLst>
+                <a:ext uri="{FF2B5EF4-FFF2-40B4-BE49-F238E27FC236}">
+                  <a16:creationId xmlns:a16="http://schemas.microsoft.com/office/drawing/2014/main" id="{17307BF7-52AF-4C8F-27A5-3FB6B55592AD}"/>
+                </a:ext>
+              </a:extLst>
+            </p:cNvPr>
+            <p:cNvCxnSpPr>
+              <a:cxnSpLocks/>
+            </p:cNvCxnSpPr>
+            <p:nvPr/>
+          </p:nvCxnSpPr>
+          <p:spPr>
+            <a:xfrm rot="5400000" flipH="1" flipV="1">
+              <a:off x="5250139" y="707943"/>
+              <a:ext cx="133911" cy="323289"/>
+            </a:xfrm>
+            <a:prstGeom prst="curvedConnector3">
+              <a:avLst>
+                <a:gd name="adj1" fmla="val 356066"/>
+              </a:avLst>
+            </a:prstGeom>
+            <a:ln>
+              <a:solidFill>
+                <a:schemeClr val="tx1"/>
+              </a:solidFill>
+              <a:tailEnd type="triangle"/>
+            </a:ln>
+          </p:spPr>
+          <p:style>
+            <a:lnRef idx="2">
+              <a:schemeClr val="accent1"/>
+            </a:lnRef>
+            <a:fillRef idx="0">
+              <a:schemeClr val="accent1"/>
+            </a:fillRef>
+            <a:effectRef idx="1">
+              <a:schemeClr val="accent1"/>
+            </a:effectRef>
+            <a:fontRef idx="minor">
+              <a:schemeClr val="tx1"/>
+            </a:fontRef>
+          </p:style>
+        </p:cxnSp>
+        <p:cxnSp>
+          <p:nvCxnSpPr>
+            <p:cNvPr id="86" name="Curved Connector 85">
+              <a:extLst>
+                <a:ext uri="{FF2B5EF4-FFF2-40B4-BE49-F238E27FC236}">
+                  <a16:creationId xmlns:a16="http://schemas.microsoft.com/office/drawing/2014/main" id="{58E2F422-415B-EE6D-0921-1447842D67D5}"/>
+                </a:ext>
+              </a:extLst>
+            </p:cNvPr>
+            <p:cNvCxnSpPr>
+              <a:cxnSpLocks/>
+              <a:stCxn id="12" idx="1"/>
+              <a:endCxn id="12" idx="0"/>
+            </p:cNvCxnSpPr>
+            <p:nvPr/>
+          </p:nvCxnSpPr>
+          <p:spPr>
+            <a:xfrm rot="5400000" flipH="1" flipV="1">
+              <a:off x="6430617" y="674768"/>
+              <a:ext cx="133911" cy="323289"/>
+            </a:xfrm>
+            <a:prstGeom prst="curvedConnector3">
+              <a:avLst>
+                <a:gd name="adj1" fmla="val 270710"/>
+              </a:avLst>
+            </a:prstGeom>
+            <a:ln>
+              <a:solidFill>
+                <a:schemeClr val="tx1"/>
+              </a:solidFill>
+              <a:tailEnd type="triangle"/>
+            </a:ln>
+          </p:spPr>
+          <p:style>
+            <a:lnRef idx="2">
+              <a:schemeClr val="accent1"/>
+            </a:lnRef>
+            <a:fillRef idx="0">
+              <a:schemeClr val="accent1"/>
+            </a:fillRef>
+            <a:effectRef idx="1">
+              <a:schemeClr val="accent1"/>
+            </a:effectRef>
+            <a:fontRef idx="minor">
+              <a:schemeClr val="tx1"/>
+            </a:fontRef>
+          </p:style>
+        </p:cxnSp>
+        <mc:AlternateContent xmlns:mc="http://schemas.openxmlformats.org/markup-compatibility/2006">
+          <mc:Choice xmlns:a14="http://schemas.microsoft.com/office/drawing/2010/main" Requires="a14">
+            <p:sp>
+              <p:nvSpPr>
+                <p:cNvPr id="93" name="TextBox 92">
+                  <a:extLst>
+                    <a:ext uri="{FF2B5EF4-FFF2-40B4-BE49-F238E27FC236}">
+                      <a16:creationId xmlns:a16="http://schemas.microsoft.com/office/drawing/2014/main" id="{86B7B176-EC4A-A456-5E02-91D7555AEE51}"/>
+                    </a:ext>
+                  </a:extLst>
+                </p:cNvPr>
+                <p:cNvSpPr txBox="1"/>
+                <p:nvPr/>
+              </p:nvSpPr>
+              <p:spPr>
+                <a:xfrm>
+                  <a:off x="3893180" y="47708"/>
+                  <a:ext cx="587340" cy="461665"/>
+                </a:xfrm>
+                <a:prstGeom prst="rect">
+                  <a:avLst/>
+                </a:prstGeom>
+                <a:noFill/>
+              </p:spPr>
+              <p:txBody>
+                <a:bodyPr wrap="none" rtlCol="0">
+                  <a:spAutoFit/>
+                </a:bodyPr>
+                <a:lstStyle/>
+                <a:p>
+                  <a14:m>
+                    <m:oMathPara xmlns:m="http://schemas.openxmlformats.org/officeDocument/2006/math">
+                      <m:oMathParaPr>
+                        <m:jc m:val="centerGroup"/>
+                      </m:oMathParaPr>
+                      <m:oMath xmlns:m="http://schemas.openxmlformats.org/officeDocument/2006/math">
+                        <m:sSup>
+                          <m:sSupPr>
+                            <m:ctrlPr>
+                              <a:rPr lang="en-US" sz="2400" i="1" smtClean="0">
+                                <a:latin typeface="Cambria Math" panose="02040503050406030204" pitchFamily="18" charset="0"/>
+                              </a:rPr>
+                            </m:ctrlPr>
+                          </m:sSupPr>
+                          <m:e>
+                            <m:r>
+                              <a:rPr lang="en-US" sz="2400" i="1" smtClean="0">
+                                <a:latin typeface="Cambria Math" panose="02040503050406030204" pitchFamily="18" charset="0"/>
+                              </a:rPr>
+                              <m:t>𝜎</m:t>
+                            </m:r>
+                          </m:e>
+                          <m:sup>
+                            <m:r>
+                              <a:rPr lang="en-US" sz="2400" i="1" smtClean="0">
+                                <a:latin typeface="Cambria Math" panose="02040503050406030204" pitchFamily="18" charset="0"/>
+                              </a:rPr>
+                              <m:t>2</m:t>
+                            </m:r>
+                          </m:sup>
+                        </m:sSup>
+                      </m:oMath>
+                    </m:oMathPara>
+                  </a14:m>
+                  <a:endParaRPr lang="en-US" sz="2400" dirty="0"/>
+                </a:p>
+              </p:txBody>
+            </p:sp>
+          </mc:Choice>
+          <mc:Fallback>
+            <p:sp>
+              <p:nvSpPr>
+                <p:cNvPr id="93" name="TextBox 92">
+                  <a:extLst>
+                    <a:ext uri="{FF2B5EF4-FFF2-40B4-BE49-F238E27FC236}">
+                      <a16:creationId xmlns:a16="http://schemas.microsoft.com/office/drawing/2014/main" id="{86B7B176-EC4A-A456-5E02-91D7555AEE51}"/>
+                    </a:ext>
+                  </a:extLst>
+                </p:cNvPr>
+                <p:cNvSpPr txBox="1">
+                  <a:spLocks noRot="1" noChangeAspect="1" noMove="1" noResize="1" noEditPoints="1" noAdjustHandles="1" noChangeArrowheads="1" noChangeShapeType="1" noTextEdit="1"/>
+                </p:cNvSpPr>
+                <p:nvPr/>
+              </p:nvSpPr>
+              <p:spPr>
+                <a:xfrm>
+                  <a:off x="3893180" y="47708"/>
+                  <a:ext cx="587340" cy="461665"/>
+                </a:xfrm>
+                <a:prstGeom prst="rect">
+                  <a:avLst/>
+                </a:prstGeom>
+                <a:blipFill>
+                  <a:blip r:embed="rId12"/>
+                  <a:stretch>
+                    <a:fillRect/>
+                  </a:stretch>
+                </a:blipFill>
+              </p:spPr>
+              <p:txBody>
+                <a:bodyPr/>
+                <a:lstStyle/>
+                <a:p>
+                  <a:r>
+                    <a:rPr lang="en-US">
+                      <a:noFill/>
+                    </a:rPr>
+                    <a:t> </a:t>
+                  </a:r>
+                </a:p>
+              </p:txBody>
+            </p:sp>
+          </mc:Fallback>
+        </mc:AlternateContent>
+        <mc:AlternateContent xmlns:mc="http://schemas.openxmlformats.org/markup-compatibility/2006">
+          <mc:Choice xmlns:a14="http://schemas.microsoft.com/office/drawing/2010/main" Requires="a14">
+            <p:sp>
+              <p:nvSpPr>
+                <p:cNvPr id="94" name="TextBox 93">
+                  <a:extLst>
+                    <a:ext uri="{FF2B5EF4-FFF2-40B4-BE49-F238E27FC236}">
+                      <a16:creationId xmlns:a16="http://schemas.microsoft.com/office/drawing/2014/main" id="{978203F1-88AC-DCE8-10CE-624418E4E9E5}"/>
+                    </a:ext>
+                  </a:extLst>
+                </p:cNvPr>
+                <p:cNvSpPr txBox="1"/>
+                <p:nvPr/>
+              </p:nvSpPr>
+              <p:spPr>
+                <a:xfrm>
+                  <a:off x="5146664" y="34266"/>
+                  <a:ext cx="587340" cy="461665"/>
+                </a:xfrm>
+                <a:prstGeom prst="rect">
+                  <a:avLst/>
+                </a:prstGeom>
+                <a:noFill/>
+              </p:spPr>
+              <p:txBody>
+                <a:bodyPr wrap="none" rtlCol="0">
+                  <a:spAutoFit/>
+                </a:bodyPr>
+                <a:lstStyle/>
+                <a:p>
+                  <a14:m>
+                    <m:oMathPara xmlns:m="http://schemas.openxmlformats.org/officeDocument/2006/math">
+                      <m:oMathParaPr>
+                        <m:jc m:val="centerGroup"/>
+                      </m:oMathParaPr>
+                      <m:oMath xmlns:m="http://schemas.openxmlformats.org/officeDocument/2006/math">
+                        <m:sSup>
+                          <m:sSupPr>
+                            <m:ctrlPr>
+                              <a:rPr lang="en-US" sz="2400" i="1" smtClean="0">
+                                <a:latin typeface="Cambria Math" panose="02040503050406030204" pitchFamily="18" charset="0"/>
+                              </a:rPr>
+                            </m:ctrlPr>
+                          </m:sSupPr>
+                          <m:e>
+                            <m:r>
+                              <a:rPr lang="en-US" sz="2400" i="1" smtClean="0">
+                                <a:latin typeface="Cambria Math" panose="02040503050406030204" pitchFamily="18" charset="0"/>
+                              </a:rPr>
+                              <m:t>𝜎</m:t>
+                            </m:r>
+                          </m:e>
+                          <m:sup>
+                            <m:r>
+                              <a:rPr lang="en-US" sz="2400" i="1" smtClean="0">
+                                <a:latin typeface="Cambria Math" panose="02040503050406030204" pitchFamily="18" charset="0"/>
+                              </a:rPr>
+                              <m:t>2</m:t>
+                            </m:r>
+                          </m:sup>
+                        </m:sSup>
+                      </m:oMath>
+                    </m:oMathPara>
+                  </a14:m>
+                  <a:endParaRPr lang="en-US" sz="2400" dirty="0"/>
+                </a:p>
+              </p:txBody>
+            </p:sp>
+          </mc:Choice>
+          <mc:Fallback>
+            <p:sp>
+              <p:nvSpPr>
+                <p:cNvPr id="94" name="TextBox 93">
+                  <a:extLst>
+                    <a:ext uri="{FF2B5EF4-FFF2-40B4-BE49-F238E27FC236}">
+                      <a16:creationId xmlns:a16="http://schemas.microsoft.com/office/drawing/2014/main" id="{978203F1-88AC-DCE8-10CE-624418E4E9E5}"/>
+                    </a:ext>
+                  </a:extLst>
+                </p:cNvPr>
+                <p:cNvSpPr txBox="1">
+                  <a:spLocks noRot="1" noChangeAspect="1" noMove="1" noResize="1" noEditPoints="1" noAdjustHandles="1" noChangeArrowheads="1" noChangeShapeType="1" noTextEdit="1"/>
+                </p:cNvSpPr>
+                <p:nvPr/>
+              </p:nvSpPr>
+              <p:spPr>
+                <a:xfrm>
+                  <a:off x="5146664" y="34266"/>
+                  <a:ext cx="587340" cy="461665"/>
+                </a:xfrm>
+                <a:prstGeom prst="rect">
+                  <a:avLst/>
+                </a:prstGeom>
+                <a:blipFill>
+                  <a:blip r:embed="rId13"/>
+                  <a:stretch>
+                    <a:fillRect/>
+                  </a:stretch>
+                </a:blipFill>
+              </p:spPr>
+              <p:txBody>
+                <a:bodyPr/>
+                <a:lstStyle/>
+                <a:p>
+                  <a:r>
+                    <a:rPr lang="en-US">
+                      <a:noFill/>
+                    </a:rPr>
+                    <a:t> </a:t>
+                  </a:r>
+                </a:p>
+              </p:txBody>
+            </p:sp>
+          </mc:Fallback>
+        </mc:AlternateContent>
+        <mc:AlternateContent xmlns:mc="http://schemas.openxmlformats.org/markup-compatibility/2006">
+          <mc:Choice xmlns:a14="http://schemas.microsoft.com/office/drawing/2010/main" Requires="a14">
+            <p:sp>
+              <p:nvSpPr>
+                <p:cNvPr id="95" name="TextBox 94">
+                  <a:extLst>
+                    <a:ext uri="{FF2B5EF4-FFF2-40B4-BE49-F238E27FC236}">
+                      <a16:creationId xmlns:a16="http://schemas.microsoft.com/office/drawing/2014/main" id="{EACA3885-DD94-917A-9BB2-B53D95912CEA}"/>
+                    </a:ext>
+                  </a:extLst>
+                </p:cNvPr>
+                <p:cNvSpPr txBox="1"/>
+                <p:nvPr/>
+              </p:nvSpPr>
+              <p:spPr>
+                <a:xfrm>
+                  <a:off x="6271122" y="27776"/>
+                  <a:ext cx="587340" cy="461665"/>
+                </a:xfrm>
+                <a:prstGeom prst="rect">
+                  <a:avLst/>
+                </a:prstGeom>
+                <a:noFill/>
+              </p:spPr>
+              <p:txBody>
+                <a:bodyPr wrap="none" rtlCol="0">
+                  <a:spAutoFit/>
+                </a:bodyPr>
+                <a:lstStyle/>
+                <a:p>
+                  <a14:m>
+                    <m:oMathPara xmlns:m="http://schemas.openxmlformats.org/officeDocument/2006/math">
+                      <m:oMathParaPr>
+                        <m:jc m:val="centerGroup"/>
+                      </m:oMathParaPr>
+                      <m:oMath xmlns:m="http://schemas.openxmlformats.org/officeDocument/2006/math">
+                        <m:sSup>
+                          <m:sSupPr>
+                            <m:ctrlPr>
+                              <a:rPr lang="en-US" sz="2400" i="1" smtClean="0">
+                                <a:latin typeface="Cambria Math" panose="02040503050406030204" pitchFamily="18" charset="0"/>
+                              </a:rPr>
+                            </m:ctrlPr>
+                          </m:sSupPr>
+                          <m:e>
+                            <m:r>
+                              <a:rPr lang="en-US" sz="2400" i="1" smtClean="0">
+                                <a:latin typeface="Cambria Math" panose="02040503050406030204" pitchFamily="18" charset="0"/>
+                              </a:rPr>
+                              <m:t>𝜎</m:t>
+                            </m:r>
+                          </m:e>
+                          <m:sup>
+                            <m:r>
+                              <a:rPr lang="en-US" sz="2400" i="1" smtClean="0">
+                                <a:latin typeface="Cambria Math" panose="02040503050406030204" pitchFamily="18" charset="0"/>
+                              </a:rPr>
+                              <m:t>2</m:t>
+                            </m:r>
+                          </m:sup>
+                        </m:sSup>
+                      </m:oMath>
+                    </m:oMathPara>
+                  </a14:m>
+                  <a:endParaRPr lang="en-US" sz="2400" dirty="0"/>
+                </a:p>
+              </p:txBody>
+            </p:sp>
+          </mc:Choice>
+          <mc:Fallback>
+            <p:sp>
+              <p:nvSpPr>
+                <p:cNvPr id="95" name="TextBox 94">
+                  <a:extLst>
+                    <a:ext uri="{FF2B5EF4-FFF2-40B4-BE49-F238E27FC236}">
+                      <a16:creationId xmlns:a16="http://schemas.microsoft.com/office/drawing/2014/main" id="{EACA3885-DD94-917A-9BB2-B53D95912CEA}"/>
+                    </a:ext>
+                  </a:extLst>
+                </p:cNvPr>
+                <p:cNvSpPr txBox="1">
+                  <a:spLocks noRot="1" noChangeAspect="1" noMove="1" noResize="1" noEditPoints="1" noAdjustHandles="1" noChangeArrowheads="1" noChangeShapeType="1" noTextEdit="1"/>
+                </p:cNvSpPr>
+                <p:nvPr/>
+              </p:nvSpPr>
+              <p:spPr>
+                <a:xfrm>
+                  <a:off x="6271122" y="27776"/>
+                  <a:ext cx="587340" cy="461665"/>
+                </a:xfrm>
+                <a:prstGeom prst="rect">
+                  <a:avLst/>
+                </a:prstGeom>
+                <a:blipFill>
+                  <a:blip r:embed="rId14"/>
+                  <a:stretch>
+                    <a:fillRect/>
+                  </a:stretch>
+                </a:blipFill>
+              </p:spPr>
+              <p:txBody>
+                <a:bodyPr/>
+                <a:lstStyle/>
+                <a:p>
+                  <a:r>
+                    <a:rPr lang="en-US">
+                      <a:noFill/>
+                    </a:rPr>
+                    <a:t> </a:t>
+                  </a:r>
+                </a:p>
+              </p:txBody>
+            </p:sp>
+          </mc:Fallback>
+        </mc:AlternateContent>
+        <mc:AlternateContent xmlns:mc="http://schemas.openxmlformats.org/markup-compatibility/2006">
+          <mc:Choice xmlns:a14="http://schemas.microsoft.com/office/drawing/2010/main" Requires="a14">
+            <p:sp>
+              <p:nvSpPr>
+                <p:cNvPr id="100" name="TextBox 99">
+                  <a:extLst>
+                    <a:ext uri="{FF2B5EF4-FFF2-40B4-BE49-F238E27FC236}">
+                      <a16:creationId xmlns:a16="http://schemas.microsoft.com/office/drawing/2014/main" id="{2E4D275A-8D14-6348-FD95-6FDFBB8B343C}"/>
+                    </a:ext>
+                  </a:extLst>
+                </p:cNvPr>
+                <p:cNvSpPr txBox="1"/>
+                <p:nvPr/>
+              </p:nvSpPr>
+              <p:spPr>
+                <a:xfrm>
+                  <a:off x="1273259" y="5923187"/>
+                  <a:ext cx="922945" cy="646331"/>
+                </a:xfrm>
+                <a:prstGeom prst="rect">
+                  <a:avLst/>
+                </a:prstGeom>
+                <a:noFill/>
+                <a:ln>
+                  <a:solidFill>
+                    <a:schemeClr val="tx1"/>
+                  </a:solidFill>
+                </a:ln>
+              </p:spPr>
+              <p:txBody>
+                <a:bodyPr wrap="none" rtlCol="0">
+                  <a:spAutoFit/>
+                </a:bodyPr>
+                <a:lstStyle/>
+                <a:p>
+                  <a14:m>
+                    <m:oMathPara xmlns:m="http://schemas.openxmlformats.org/officeDocument/2006/math">
+                      <m:oMathParaPr>
+                        <m:jc m:val="centerGroup"/>
+                      </m:oMathParaPr>
+                      <m:oMath xmlns:m="http://schemas.openxmlformats.org/officeDocument/2006/math">
+                        <m:sSub>
+                          <m:sSubPr>
+                            <m:ctrlPr>
+                              <a:rPr lang="en-US" sz="3600" i="1" smtClean="0">
+                                <a:latin typeface="Cambria Math" panose="02040503050406030204" pitchFamily="18" charset="0"/>
+                              </a:rPr>
+                            </m:ctrlPr>
+                          </m:sSubPr>
+                          <m:e>
+                            <m:r>
+                              <a:rPr lang="en-US" sz="3600" i="1" smtClean="0">
+                                <a:latin typeface="Cambria Math" panose="02040503050406030204" pitchFamily="18" charset="0"/>
+                              </a:rPr>
+                              <m:t>𝑦</m:t>
+                            </m:r>
+                          </m:e>
+                          <m:sub>
+                            <m:r>
+                              <a:rPr lang="en-US" sz="3600" i="1" smtClean="0">
+                                <a:latin typeface="Cambria Math" panose="02040503050406030204" pitchFamily="18" charset="0"/>
+                              </a:rPr>
+                              <m:t>12</m:t>
+                            </m:r>
+                          </m:sub>
+                        </m:sSub>
+                      </m:oMath>
+                    </m:oMathPara>
+                  </a14:m>
+                  <a:endParaRPr lang="en-US" sz="3600" dirty="0"/>
+                </a:p>
+              </p:txBody>
+            </p:sp>
+          </mc:Choice>
+          <mc:Fallback>
+            <p:sp>
+              <p:nvSpPr>
+                <p:cNvPr id="100" name="TextBox 99">
+                  <a:extLst>
+                    <a:ext uri="{FF2B5EF4-FFF2-40B4-BE49-F238E27FC236}">
+                      <a16:creationId xmlns:a16="http://schemas.microsoft.com/office/drawing/2014/main" id="{2E4D275A-8D14-6348-FD95-6FDFBB8B343C}"/>
+                    </a:ext>
+                  </a:extLst>
+                </p:cNvPr>
+                <p:cNvSpPr txBox="1">
+                  <a:spLocks noRot="1" noChangeAspect="1" noMove="1" noResize="1" noEditPoints="1" noAdjustHandles="1" noChangeArrowheads="1" noChangeShapeType="1" noTextEdit="1"/>
+                </p:cNvSpPr>
+                <p:nvPr/>
+              </p:nvSpPr>
+              <p:spPr>
+                <a:xfrm>
+                  <a:off x="1273259" y="5923187"/>
+                  <a:ext cx="922945" cy="646331"/>
+                </a:xfrm>
+                <a:prstGeom prst="rect">
+                  <a:avLst/>
+                </a:prstGeom>
+                <a:blipFill>
+                  <a:blip r:embed="rId15"/>
+                  <a:stretch>
+                    <a:fillRect l="-1333" b="-11538"/>
+                  </a:stretch>
+                </a:blipFill>
+                <a:ln>
+                  <a:solidFill>
+                    <a:schemeClr val="tx1"/>
+                  </a:solidFill>
+                </a:ln>
+              </p:spPr>
+              <p:txBody>
+                <a:bodyPr/>
+                <a:lstStyle/>
+                <a:p>
+                  <a:r>
+                    <a:rPr lang="en-US">
+                      <a:noFill/>
+                    </a:rPr>
+                    <a:t> </a:t>
+                  </a:r>
+                </a:p>
+              </p:txBody>
+            </p:sp>
+          </mc:Fallback>
+        </mc:AlternateContent>
+        <mc:AlternateContent xmlns:mc="http://schemas.openxmlformats.org/markup-compatibility/2006">
+          <mc:Choice xmlns:a14="http://schemas.microsoft.com/office/drawing/2010/main" Requires="a14">
+            <p:sp>
+              <p:nvSpPr>
+                <p:cNvPr id="117" name="TextBox 116">
+                  <a:extLst>
+                    <a:ext uri="{FF2B5EF4-FFF2-40B4-BE49-F238E27FC236}">
+                      <a16:creationId xmlns:a16="http://schemas.microsoft.com/office/drawing/2014/main" id="{A7FA7A38-308B-DA00-565E-6DC966DF1F86}"/>
+                    </a:ext>
+                  </a:extLst>
+                </p:cNvPr>
+                <p:cNvSpPr txBox="1"/>
+                <p:nvPr/>
+              </p:nvSpPr>
+              <p:spPr>
+                <a:xfrm>
+                  <a:off x="2977479" y="5922084"/>
+                  <a:ext cx="922945" cy="646331"/>
+                </a:xfrm>
+                <a:prstGeom prst="rect">
+                  <a:avLst/>
+                </a:prstGeom>
+                <a:noFill/>
+                <a:ln>
+                  <a:solidFill>
+                    <a:schemeClr val="tx1"/>
+                  </a:solidFill>
+                </a:ln>
+              </p:spPr>
+              <p:txBody>
+                <a:bodyPr wrap="none" rtlCol="0">
+                  <a:spAutoFit/>
+                </a:bodyPr>
+                <a:lstStyle/>
+                <a:p>
+                  <a14:m>
+                    <m:oMathPara xmlns:m="http://schemas.openxmlformats.org/officeDocument/2006/math">
+                      <m:oMathParaPr>
+                        <m:jc m:val="centerGroup"/>
+                      </m:oMathParaPr>
+                      <m:oMath xmlns:m="http://schemas.openxmlformats.org/officeDocument/2006/math">
+                        <m:sSub>
+                          <m:sSubPr>
+                            <m:ctrlPr>
+                              <a:rPr lang="en-US" sz="3600" i="1" smtClean="0">
+                                <a:latin typeface="Cambria Math" panose="02040503050406030204" pitchFamily="18" charset="0"/>
+                              </a:rPr>
+                            </m:ctrlPr>
+                          </m:sSubPr>
+                          <m:e>
+                            <m:r>
+                              <a:rPr lang="en-US" sz="3600" i="1" smtClean="0">
+                                <a:latin typeface="Cambria Math" panose="02040503050406030204" pitchFamily="18" charset="0"/>
+                              </a:rPr>
+                              <m:t>𝑦</m:t>
+                            </m:r>
+                          </m:e>
+                          <m:sub>
+                            <m:r>
+                              <a:rPr lang="en-US" sz="3600" i="1" smtClean="0">
+                                <a:latin typeface="Cambria Math" panose="02040503050406030204" pitchFamily="18" charset="0"/>
+                              </a:rPr>
+                              <m:t>1</m:t>
+                            </m:r>
+                            <m:r>
+                              <a:rPr lang="en-US" sz="3600" b="0" i="1" smtClean="0">
+                                <a:latin typeface="Cambria Math" panose="02040503050406030204" pitchFamily="18" charset="0"/>
+                              </a:rPr>
+                              <m:t>3</m:t>
+                            </m:r>
+                          </m:sub>
+                        </m:sSub>
+                      </m:oMath>
+                    </m:oMathPara>
+                  </a14:m>
+                  <a:endParaRPr lang="en-US" sz="3600" dirty="0"/>
+                </a:p>
+              </p:txBody>
+            </p:sp>
+          </mc:Choice>
+          <mc:Fallback>
+            <p:sp>
+              <p:nvSpPr>
+                <p:cNvPr id="117" name="TextBox 116">
+                  <a:extLst>
+                    <a:ext uri="{FF2B5EF4-FFF2-40B4-BE49-F238E27FC236}">
+                      <a16:creationId xmlns:a16="http://schemas.microsoft.com/office/drawing/2014/main" id="{A7FA7A38-308B-DA00-565E-6DC966DF1F86}"/>
+                    </a:ext>
+                  </a:extLst>
+                </p:cNvPr>
+                <p:cNvSpPr txBox="1">
+                  <a:spLocks noRot="1" noChangeAspect="1" noMove="1" noResize="1" noEditPoints="1" noAdjustHandles="1" noChangeArrowheads="1" noChangeShapeType="1" noTextEdit="1"/>
+                </p:cNvSpPr>
+                <p:nvPr/>
+              </p:nvSpPr>
+              <p:spPr>
+                <a:xfrm>
+                  <a:off x="2977479" y="5922084"/>
+                  <a:ext cx="922945" cy="646331"/>
+                </a:xfrm>
+                <a:prstGeom prst="rect">
+                  <a:avLst/>
+                </a:prstGeom>
+                <a:blipFill>
+                  <a:blip r:embed="rId16"/>
+                  <a:stretch>
+                    <a:fillRect l="-1333" b="-11321"/>
+                  </a:stretch>
+                </a:blipFill>
+                <a:ln>
+                  <a:solidFill>
+                    <a:schemeClr val="tx1"/>
+                  </a:solidFill>
+                </a:ln>
+              </p:spPr>
+              <p:txBody>
+                <a:bodyPr/>
+                <a:lstStyle/>
+                <a:p>
+                  <a:r>
+                    <a:rPr lang="en-US">
+                      <a:noFill/>
+                    </a:rPr>
+                    <a:t> </a:t>
+                  </a:r>
+                </a:p>
+              </p:txBody>
+            </p:sp>
+          </mc:Fallback>
+        </mc:AlternateContent>
+        <mc:AlternateContent xmlns:mc="http://schemas.openxmlformats.org/markup-compatibility/2006">
+          <mc:Choice xmlns:a14="http://schemas.microsoft.com/office/drawing/2010/main" Requires="a14">
+            <p:sp>
+              <p:nvSpPr>
+                <p:cNvPr id="118" name="TextBox 117">
+                  <a:extLst>
+                    <a:ext uri="{FF2B5EF4-FFF2-40B4-BE49-F238E27FC236}">
+                      <a16:creationId xmlns:a16="http://schemas.microsoft.com/office/drawing/2014/main" id="{DC10D376-FDB3-1B28-56AA-33FC9A0FE364}"/>
+                    </a:ext>
+                  </a:extLst>
+                </p:cNvPr>
+                <p:cNvSpPr txBox="1"/>
+                <p:nvPr/>
+              </p:nvSpPr>
+              <p:spPr>
+                <a:xfrm>
+                  <a:off x="4681699" y="5922084"/>
+                  <a:ext cx="922945" cy="646331"/>
+                </a:xfrm>
+                <a:prstGeom prst="rect">
+                  <a:avLst/>
+                </a:prstGeom>
+                <a:noFill/>
+                <a:ln>
+                  <a:solidFill>
+                    <a:schemeClr val="tx1"/>
+                  </a:solidFill>
+                </a:ln>
+              </p:spPr>
+              <p:txBody>
+                <a:bodyPr wrap="none" rtlCol="0">
+                  <a:spAutoFit/>
+                </a:bodyPr>
+                <a:lstStyle/>
+                <a:p>
+                  <a14:m>
+                    <m:oMathPara xmlns:m="http://schemas.openxmlformats.org/officeDocument/2006/math">
+                      <m:oMathParaPr>
+                        <m:jc m:val="centerGroup"/>
+                      </m:oMathParaPr>
+                      <m:oMath xmlns:m="http://schemas.openxmlformats.org/officeDocument/2006/math">
+                        <m:sSub>
+                          <m:sSubPr>
+                            <m:ctrlPr>
+                              <a:rPr lang="en-US" sz="3600" i="1" smtClean="0">
+                                <a:latin typeface="Cambria Math" panose="02040503050406030204" pitchFamily="18" charset="0"/>
+                              </a:rPr>
+                            </m:ctrlPr>
+                          </m:sSubPr>
+                          <m:e>
+                            <m:r>
+                              <a:rPr lang="en-US" sz="3600" i="1" smtClean="0">
+                                <a:latin typeface="Cambria Math" panose="02040503050406030204" pitchFamily="18" charset="0"/>
+                              </a:rPr>
+                              <m:t>𝑦</m:t>
+                            </m:r>
+                          </m:e>
+                          <m:sub>
+                            <m:r>
+                              <a:rPr lang="en-US" sz="3600" i="1" smtClean="0">
+                                <a:latin typeface="Cambria Math" panose="02040503050406030204" pitchFamily="18" charset="0"/>
+                              </a:rPr>
+                              <m:t>1</m:t>
+                            </m:r>
+                            <m:r>
+                              <a:rPr lang="en-US" sz="3600" b="0" i="1" smtClean="0">
+                                <a:latin typeface="Cambria Math" panose="02040503050406030204" pitchFamily="18" charset="0"/>
+                              </a:rPr>
+                              <m:t>4</m:t>
+                            </m:r>
+                          </m:sub>
+                        </m:sSub>
+                      </m:oMath>
+                    </m:oMathPara>
+                  </a14:m>
+                  <a:endParaRPr lang="en-US" sz="3600" dirty="0"/>
+                </a:p>
+              </p:txBody>
+            </p:sp>
+          </mc:Choice>
+          <mc:Fallback>
+            <p:sp>
+              <p:nvSpPr>
+                <p:cNvPr id="118" name="TextBox 117">
+                  <a:extLst>
+                    <a:ext uri="{FF2B5EF4-FFF2-40B4-BE49-F238E27FC236}">
+                      <a16:creationId xmlns:a16="http://schemas.microsoft.com/office/drawing/2014/main" id="{DC10D376-FDB3-1B28-56AA-33FC9A0FE364}"/>
+                    </a:ext>
+                  </a:extLst>
+                </p:cNvPr>
+                <p:cNvSpPr txBox="1">
+                  <a:spLocks noRot="1" noChangeAspect="1" noMove="1" noResize="1" noEditPoints="1" noAdjustHandles="1" noChangeArrowheads="1" noChangeShapeType="1" noTextEdit="1"/>
+                </p:cNvSpPr>
+                <p:nvPr/>
+              </p:nvSpPr>
+              <p:spPr>
+                <a:xfrm>
+                  <a:off x="4681699" y="5922084"/>
+                  <a:ext cx="922945" cy="646331"/>
+                </a:xfrm>
+                <a:prstGeom prst="rect">
+                  <a:avLst/>
+                </a:prstGeom>
+                <a:blipFill>
+                  <a:blip r:embed="rId17"/>
+                  <a:stretch>
+                    <a:fillRect l="-1351" b="-11321"/>
+                  </a:stretch>
+                </a:blipFill>
+                <a:ln>
+                  <a:solidFill>
+                    <a:schemeClr val="tx1"/>
+                  </a:solidFill>
+                </a:ln>
+              </p:spPr>
+              <p:txBody>
+                <a:bodyPr/>
+                <a:lstStyle/>
+                <a:p>
+                  <a:r>
+                    <a:rPr lang="en-US">
+                      <a:noFill/>
+                    </a:rPr>
+                    <a:t> </a:t>
+                  </a:r>
+                </a:p>
+              </p:txBody>
+            </p:sp>
+          </mc:Fallback>
+        </mc:AlternateContent>
+        <mc:AlternateContent xmlns:mc="http://schemas.openxmlformats.org/markup-compatibility/2006">
+          <mc:Choice xmlns:a14="http://schemas.microsoft.com/office/drawing/2010/main" Requires="a14">
+            <p:sp>
+              <p:nvSpPr>
+                <p:cNvPr id="119" name="TextBox 118">
+                  <a:extLst>
+                    <a:ext uri="{FF2B5EF4-FFF2-40B4-BE49-F238E27FC236}">
+                      <a16:creationId xmlns:a16="http://schemas.microsoft.com/office/drawing/2014/main" id="{0F766AEC-ABFF-84B9-5B3F-182BFAAC75F7}"/>
+                    </a:ext>
+                  </a:extLst>
+                </p:cNvPr>
+                <p:cNvSpPr txBox="1"/>
+                <p:nvPr/>
+              </p:nvSpPr>
+              <p:spPr>
+                <a:xfrm>
+                  <a:off x="6464017" y="5922084"/>
+                  <a:ext cx="933654" cy="646331"/>
+                </a:xfrm>
+                <a:prstGeom prst="rect">
+                  <a:avLst/>
+                </a:prstGeom>
+                <a:noFill/>
+                <a:ln>
+                  <a:solidFill>
+                    <a:schemeClr val="tx1"/>
+                  </a:solidFill>
+                </a:ln>
+              </p:spPr>
+              <p:txBody>
+                <a:bodyPr wrap="none" rtlCol="0">
+                  <a:spAutoFit/>
+                </a:bodyPr>
+                <a:lstStyle/>
+                <a:p>
+                  <a14:m>
+                    <m:oMathPara xmlns:m="http://schemas.openxmlformats.org/officeDocument/2006/math">
+                      <m:oMathParaPr>
+                        <m:jc m:val="centerGroup"/>
+                      </m:oMathParaPr>
+                      <m:oMath xmlns:m="http://schemas.openxmlformats.org/officeDocument/2006/math">
+                        <m:sSub>
+                          <m:sSubPr>
+                            <m:ctrlPr>
+                              <a:rPr lang="en-US" sz="3600" i="1" smtClean="0">
+                                <a:latin typeface="Cambria Math" panose="02040503050406030204" pitchFamily="18" charset="0"/>
+                              </a:rPr>
+                            </m:ctrlPr>
+                          </m:sSubPr>
+                          <m:e>
+                            <m:r>
+                              <a:rPr lang="en-US" sz="3600" i="1" smtClean="0">
+                                <a:latin typeface="Cambria Math" panose="02040503050406030204" pitchFamily="18" charset="0"/>
+                              </a:rPr>
+                              <m:t>𝑦</m:t>
+                            </m:r>
+                          </m:e>
+                          <m:sub>
+                            <m:r>
+                              <a:rPr lang="en-US" sz="3600" b="0" i="1" smtClean="0">
+                                <a:latin typeface="Cambria Math" panose="02040503050406030204" pitchFamily="18" charset="0"/>
+                              </a:rPr>
+                              <m:t>23</m:t>
+                            </m:r>
+                          </m:sub>
+                        </m:sSub>
+                      </m:oMath>
+                    </m:oMathPara>
+                  </a14:m>
+                  <a:endParaRPr lang="en-US" sz="3600" dirty="0"/>
+                </a:p>
+              </p:txBody>
+            </p:sp>
+          </mc:Choice>
+          <mc:Fallback>
+            <p:sp>
+              <p:nvSpPr>
+                <p:cNvPr id="119" name="TextBox 118">
+                  <a:extLst>
+                    <a:ext uri="{FF2B5EF4-FFF2-40B4-BE49-F238E27FC236}">
+                      <a16:creationId xmlns:a16="http://schemas.microsoft.com/office/drawing/2014/main" id="{0F766AEC-ABFF-84B9-5B3F-182BFAAC75F7}"/>
+                    </a:ext>
+                  </a:extLst>
+                </p:cNvPr>
+                <p:cNvSpPr txBox="1">
+                  <a:spLocks noRot="1" noChangeAspect="1" noMove="1" noResize="1" noEditPoints="1" noAdjustHandles="1" noChangeArrowheads="1" noChangeShapeType="1" noTextEdit="1"/>
+                </p:cNvSpPr>
+                <p:nvPr/>
+              </p:nvSpPr>
+              <p:spPr>
+                <a:xfrm>
+                  <a:off x="6464017" y="5922084"/>
+                  <a:ext cx="933654" cy="646331"/>
+                </a:xfrm>
+                <a:prstGeom prst="rect">
+                  <a:avLst/>
+                </a:prstGeom>
+                <a:blipFill>
+                  <a:blip r:embed="rId18"/>
+                  <a:stretch>
+                    <a:fillRect l="-1316" b="-11321"/>
+                  </a:stretch>
+                </a:blipFill>
+                <a:ln>
+                  <a:solidFill>
+                    <a:schemeClr val="tx1"/>
+                  </a:solidFill>
+                </a:ln>
+              </p:spPr>
+              <p:txBody>
+                <a:bodyPr/>
+                <a:lstStyle/>
+                <a:p>
+                  <a:r>
+                    <a:rPr lang="en-US">
+                      <a:noFill/>
+                    </a:rPr>
+                    <a:t> </a:t>
+                  </a:r>
+                </a:p>
+              </p:txBody>
+            </p:sp>
+          </mc:Fallback>
+        </mc:AlternateContent>
+        <mc:AlternateContent xmlns:mc="http://schemas.openxmlformats.org/markup-compatibility/2006">
+          <mc:Choice xmlns:a14="http://schemas.microsoft.com/office/drawing/2010/main" Requires="a14">
+            <p:sp>
+              <p:nvSpPr>
+                <p:cNvPr id="120" name="TextBox 119">
+                  <a:extLst>
+                    <a:ext uri="{FF2B5EF4-FFF2-40B4-BE49-F238E27FC236}">
+                      <a16:creationId xmlns:a16="http://schemas.microsoft.com/office/drawing/2014/main" id="{794F94BF-D7F5-3F73-4290-F70744E3B41C}"/>
+                    </a:ext>
+                  </a:extLst>
+                </p:cNvPr>
+                <p:cNvSpPr txBox="1"/>
+                <p:nvPr/>
+              </p:nvSpPr>
+              <p:spPr>
+                <a:xfrm>
+                  <a:off x="8171770" y="5891463"/>
+                  <a:ext cx="933654" cy="646331"/>
+                </a:xfrm>
+                <a:prstGeom prst="rect">
+                  <a:avLst/>
+                </a:prstGeom>
+                <a:noFill/>
+                <a:ln>
+                  <a:solidFill>
+                    <a:schemeClr val="tx1"/>
+                  </a:solidFill>
+                </a:ln>
+              </p:spPr>
+              <p:txBody>
+                <a:bodyPr wrap="none" rtlCol="0">
+                  <a:spAutoFit/>
+                </a:bodyPr>
+                <a:lstStyle/>
+                <a:p>
+                  <a14:m>
+                    <m:oMathPara xmlns:m="http://schemas.openxmlformats.org/officeDocument/2006/math">
+                      <m:oMathParaPr>
+                        <m:jc m:val="centerGroup"/>
+                      </m:oMathParaPr>
+                      <m:oMath xmlns:m="http://schemas.openxmlformats.org/officeDocument/2006/math">
+                        <m:sSub>
+                          <m:sSubPr>
+                            <m:ctrlPr>
+                              <a:rPr lang="en-US" sz="3600" i="1" smtClean="0">
+                                <a:latin typeface="Cambria Math" panose="02040503050406030204" pitchFamily="18" charset="0"/>
+                              </a:rPr>
+                            </m:ctrlPr>
+                          </m:sSubPr>
+                          <m:e>
+                            <m:r>
+                              <a:rPr lang="en-US" sz="3600" i="1" smtClean="0">
+                                <a:latin typeface="Cambria Math" panose="02040503050406030204" pitchFamily="18" charset="0"/>
+                              </a:rPr>
+                              <m:t>𝑦</m:t>
+                            </m:r>
+                          </m:e>
+                          <m:sub>
+                            <m:r>
+                              <a:rPr lang="en-US" sz="3600" b="0" i="1" smtClean="0">
+                                <a:latin typeface="Cambria Math" panose="02040503050406030204" pitchFamily="18" charset="0"/>
+                              </a:rPr>
+                              <m:t>24</m:t>
+                            </m:r>
+                          </m:sub>
+                        </m:sSub>
+                      </m:oMath>
+                    </m:oMathPara>
+                  </a14:m>
+                  <a:endParaRPr lang="en-US" sz="3600" dirty="0"/>
+                </a:p>
+              </p:txBody>
+            </p:sp>
+          </mc:Choice>
+          <mc:Fallback>
+            <p:sp>
+              <p:nvSpPr>
+                <p:cNvPr id="120" name="TextBox 119">
+                  <a:extLst>
+                    <a:ext uri="{FF2B5EF4-FFF2-40B4-BE49-F238E27FC236}">
+                      <a16:creationId xmlns:a16="http://schemas.microsoft.com/office/drawing/2014/main" id="{794F94BF-D7F5-3F73-4290-F70744E3B41C}"/>
+                    </a:ext>
+                  </a:extLst>
+                </p:cNvPr>
+                <p:cNvSpPr txBox="1">
+                  <a:spLocks noRot="1" noChangeAspect="1" noMove="1" noResize="1" noEditPoints="1" noAdjustHandles="1" noChangeArrowheads="1" noChangeShapeType="1" noTextEdit="1"/>
+                </p:cNvSpPr>
+                <p:nvPr/>
+              </p:nvSpPr>
+              <p:spPr>
+                <a:xfrm>
+                  <a:off x="8171770" y="5891463"/>
+                  <a:ext cx="933654" cy="646331"/>
+                </a:xfrm>
+                <a:prstGeom prst="rect">
+                  <a:avLst/>
+                </a:prstGeom>
+                <a:blipFill>
+                  <a:blip r:embed="rId19"/>
+                  <a:stretch>
+                    <a:fillRect l="-2667" b="-11321"/>
+                  </a:stretch>
+                </a:blipFill>
+                <a:ln>
+                  <a:solidFill>
+                    <a:schemeClr val="tx1"/>
+                  </a:solidFill>
+                </a:ln>
+              </p:spPr>
+              <p:txBody>
+                <a:bodyPr/>
+                <a:lstStyle/>
+                <a:p>
+                  <a:r>
+                    <a:rPr lang="en-US">
+                      <a:noFill/>
+                    </a:rPr>
+                    <a:t> </a:t>
+                  </a:r>
+                </a:p>
+              </p:txBody>
+            </p:sp>
+          </mc:Fallback>
+        </mc:AlternateContent>
+        <mc:AlternateContent xmlns:mc="http://schemas.openxmlformats.org/markup-compatibility/2006">
+          <mc:Choice xmlns:a14="http://schemas.microsoft.com/office/drawing/2010/main" Requires="a14">
+            <p:sp>
+              <p:nvSpPr>
+                <p:cNvPr id="121" name="TextBox 120">
+                  <a:extLst>
+                    <a:ext uri="{FF2B5EF4-FFF2-40B4-BE49-F238E27FC236}">
+                      <a16:creationId xmlns:a16="http://schemas.microsoft.com/office/drawing/2014/main" id="{CEF725D3-4936-54F0-FA7D-89D22E887980}"/>
+                    </a:ext>
+                  </a:extLst>
+                </p:cNvPr>
+                <p:cNvSpPr txBox="1"/>
+                <p:nvPr/>
+              </p:nvSpPr>
+              <p:spPr>
+                <a:xfrm>
+                  <a:off x="9923482" y="5904804"/>
+                  <a:ext cx="933654" cy="646331"/>
+                </a:xfrm>
+                <a:prstGeom prst="rect">
+                  <a:avLst/>
+                </a:prstGeom>
+                <a:noFill/>
+                <a:ln>
+                  <a:solidFill>
+                    <a:schemeClr val="tx1"/>
+                  </a:solidFill>
+                </a:ln>
+              </p:spPr>
+              <p:txBody>
+                <a:bodyPr wrap="none" rtlCol="0">
+                  <a:spAutoFit/>
+                </a:bodyPr>
+                <a:lstStyle/>
+                <a:p>
+                  <a14:m>
+                    <m:oMathPara xmlns:m="http://schemas.openxmlformats.org/officeDocument/2006/math">
+                      <m:oMathParaPr>
+                        <m:jc m:val="centerGroup"/>
+                      </m:oMathParaPr>
+                      <m:oMath xmlns:m="http://schemas.openxmlformats.org/officeDocument/2006/math">
+                        <m:sSub>
+                          <m:sSubPr>
+                            <m:ctrlPr>
+                              <a:rPr lang="en-US" sz="3600" i="1" smtClean="0">
+                                <a:latin typeface="Cambria Math" panose="02040503050406030204" pitchFamily="18" charset="0"/>
+                              </a:rPr>
+                            </m:ctrlPr>
+                          </m:sSubPr>
+                          <m:e>
+                            <m:r>
+                              <a:rPr lang="en-US" sz="3600" i="1" smtClean="0">
+                                <a:latin typeface="Cambria Math" panose="02040503050406030204" pitchFamily="18" charset="0"/>
+                              </a:rPr>
+                              <m:t>𝑦</m:t>
+                            </m:r>
+                          </m:e>
+                          <m:sub>
+                            <m:r>
+                              <a:rPr lang="en-US" sz="3600" b="0" i="1" smtClean="0">
+                                <a:latin typeface="Cambria Math" panose="02040503050406030204" pitchFamily="18" charset="0"/>
+                              </a:rPr>
+                              <m:t>34</m:t>
+                            </m:r>
+                          </m:sub>
+                        </m:sSub>
+                      </m:oMath>
+                    </m:oMathPara>
+                  </a14:m>
+                  <a:endParaRPr lang="en-US" sz="3600" dirty="0"/>
+                </a:p>
+              </p:txBody>
+            </p:sp>
+          </mc:Choice>
+          <mc:Fallback>
+            <p:sp>
+              <p:nvSpPr>
+                <p:cNvPr id="121" name="TextBox 120">
+                  <a:extLst>
+                    <a:ext uri="{FF2B5EF4-FFF2-40B4-BE49-F238E27FC236}">
+                      <a16:creationId xmlns:a16="http://schemas.microsoft.com/office/drawing/2014/main" id="{CEF725D3-4936-54F0-FA7D-89D22E887980}"/>
+                    </a:ext>
+                  </a:extLst>
+                </p:cNvPr>
+                <p:cNvSpPr txBox="1">
+                  <a:spLocks noRot="1" noChangeAspect="1" noMove="1" noResize="1" noEditPoints="1" noAdjustHandles="1" noChangeArrowheads="1" noChangeShapeType="1" noTextEdit="1"/>
+                </p:cNvSpPr>
+                <p:nvPr/>
+              </p:nvSpPr>
+              <p:spPr>
+                <a:xfrm>
+                  <a:off x="9923482" y="5904804"/>
+                  <a:ext cx="933654" cy="646331"/>
+                </a:xfrm>
+                <a:prstGeom prst="rect">
+                  <a:avLst/>
+                </a:prstGeom>
+                <a:blipFill>
+                  <a:blip r:embed="rId20"/>
+                  <a:stretch>
+                    <a:fillRect b="-11321"/>
+                  </a:stretch>
+                </a:blipFill>
+                <a:ln>
+                  <a:solidFill>
+                    <a:schemeClr val="tx1"/>
+                  </a:solidFill>
+                </a:ln>
+              </p:spPr>
+              <p:txBody>
+                <a:bodyPr/>
+                <a:lstStyle/>
+                <a:p>
+                  <a:r>
+                    <a:rPr lang="en-US">
+                      <a:noFill/>
+                    </a:rPr>
+                    <a:t> </a:t>
+                  </a:r>
+                </a:p>
+              </p:txBody>
+            </p:sp>
+          </mc:Fallback>
+        </mc:AlternateContent>
+        <mc:AlternateContent xmlns:mc="http://schemas.openxmlformats.org/markup-compatibility/2006">
+          <mc:Choice xmlns:a14="http://schemas.microsoft.com/office/drawing/2010/main" Requires="a14">
+            <p:sp>
+              <p:nvSpPr>
+                <p:cNvPr id="122" name="TextBox 121">
+                  <a:extLst>
+                    <a:ext uri="{FF2B5EF4-FFF2-40B4-BE49-F238E27FC236}">
+                      <a16:creationId xmlns:a16="http://schemas.microsoft.com/office/drawing/2014/main" id="{038151CC-C4D8-EF8A-333B-BF1A5A66236B}"/>
+                    </a:ext>
+                  </a:extLst>
+                </p:cNvPr>
+                <p:cNvSpPr txBox="1"/>
+                <p:nvPr/>
+              </p:nvSpPr>
+              <p:spPr>
+                <a:xfrm>
+                  <a:off x="5157936" y="4685365"/>
+                  <a:ext cx="1681356" cy="677878"/>
+                </a:xfrm>
+                <a:prstGeom prst="rect">
+                  <a:avLst/>
+                </a:prstGeom>
+                <a:solidFill>
+                  <a:schemeClr val="bg1"/>
+                </a:solidFill>
+                <a:effectLst>
+                  <a:softEdge rad="25400"/>
+                </a:effectLst>
+              </p:spPr>
+              <p:txBody>
+                <a:bodyPr wrap="square" rtlCol="0">
+                  <a:spAutoFit/>
+                </a:bodyPr>
+                <a:lstStyle/>
+                <a:p>
+                  <a14:m>
+                    <m:oMathPara xmlns:m="http://schemas.openxmlformats.org/officeDocument/2006/math">
+                      <m:oMathParaPr>
+                        <m:jc m:val="centerGroup"/>
+                      </m:oMathParaPr>
+                      <m:oMath xmlns:m="http://schemas.openxmlformats.org/officeDocument/2006/math">
+                        <m:r>
+                          <m:rPr>
+                            <m:sty m:val="p"/>
+                          </m:rPr>
+                          <a:rPr lang="el-GR" sz="3200" i="1" smtClean="0">
+                            <a:latin typeface="Cambria Math" panose="02040503050406030204" pitchFamily="18" charset="0"/>
+                            <a:ea typeface="Cambria Math" panose="02040503050406030204" pitchFamily="18" charset="0"/>
+                          </a:rPr>
+                          <m:t>Φ</m:t>
+                        </m:r>
+                        <m:d>
+                          <m:dPr>
+                            <m:ctrlPr>
+                              <a:rPr lang="en-US" sz="3200" i="1" smtClean="0">
+                                <a:latin typeface="Cambria Math" panose="02040503050406030204" pitchFamily="18" charset="0"/>
+                              </a:rPr>
+                            </m:ctrlPr>
+                          </m:dPr>
+                          <m:e>
+                            <m:sSub>
+                              <m:sSubPr>
+                                <m:ctrlPr>
+                                  <a:rPr lang="en-US" sz="3200" i="1" smtClean="0">
+                                    <a:latin typeface="Cambria Math" panose="02040503050406030204" pitchFamily="18" charset="0"/>
+                                  </a:rPr>
+                                </m:ctrlPr>
+                              </m:sSubPr>
+                              <m:e>
+                                <m:r>
+                                  <a:rPr lang="en-US" sz="3200" i="1" smtClean="0">
+                                    <a:latin typeface="Cambria Math" panose="02040503050406030204" pitchFamily="18" charset="0"/>
+                                  </a:rPr>
+                                  <m:t>𝑧</m:t>
+                                </m:r>
+                              </m:e>
+                              <m:sub>
+                                <m:r>
+                                  <a:rPr lang="en-US" sz="3200" b="0" i="1" smtClean="0">
+                                    <a:latin typeface="Cambria Math" panose="02040503050406030204" pitchFamily="18" charset="0"/>
+                                  </a:rPr>
+                                  <m:t>𝑖𝑗</m:t>
+                                </m:r>
+                              </m:sub>
+                            </m:sSub>
+                          </m:e>
+                        </m:d>
+                      </m:oMath>
+                    </m:oMathPara>
+                  </a14:m>
+                  <a:endParaRPr lang="en-US" sz="3200" dirty="0"/>
+                </a:p>
+              </p:txBody>
+            </p:sp>
+          </mc:Choice>
+          <mc:Fallback>
+            <p:sp>
+              <p:nvSpPr>
+                <p:cNvPr id="122" name="TextBox 121">
+                  <a:extLst>
+                    <a:ext uri="{FF2B5EF4-FFF2-40B4-BE49-F238E27FC236}">
+                      <a16:creationId xmlns:a16="http://schemas.microsoft.com/office/drawing/2014/main" id="{038151CC-C4D8-EF8A-333B-BF1A5A66236B}"/>
+                    </a:ext>
+                  </a:extLst>
+                </p:cNvPr>
+                <p:cNvSpPr txBox="1">
+                  <a:spLocks noRot="1" noChangeAspect="1" noMove="1" noResize="1" noEditPoints="1" noAdjustHandles="1" noChangeArrowheads="1" noChangeShapeType="1" noTextEdit="1"/>
+                </p:cNvSpPr>
+                <p:nvPr/>
+              </p:nvSpPr>
+              <p:spPr>
+                <a:xfrm>
+                  <a:off x="5157936" y="4685365"/>
+                  <a:ext cx="1681356" cy="677878"/>
+                </a:xfrm>
+                <a:prstGeom prst="rect">
+                  <a:avLst/>
+                </a:prstGeom>
+                <a:blipFill>
+                  <a:blip r:embed="rId21"/>
+                  <a:stretch>
+                    <a:fillRect b="-9259"/>
+                  </a:stretch>
+                </a:blipFill>
+                <a:effectLst>
+                  <a:softEdge rad="25400"/>
+                </a:effectLst>
+              </p:spPr>
+              <p:txBody>
+                <a:bodyPr/>
+                <a:lstStyle/>
+                <a:p>
+                  <a:r>
+                    <a:rPr lang="en-US">
+                      <a:noFill/>
+                    </a:rPr>
+                    <a:t> </a:t>
+                  </a:r>
+                </a:p>
+              </p:txBody>
+            </p:sp>
+          </mc:Fallback>
+        </mc:AlternateContent>
+        <p:cxnSp>
+          <p:nvCxnSpPr>
+            <p:cNvPr id="129" name="Curved Connector 128">
+              <a:extLst>
+                <a:ext uri="{FF2B5EF4-FFF2-40B4-BE49-F238E27FC236}">
+                  <a16:creationId xmlns:a16="http://schemas.microsoft.com/office/drawing/2014/main" id="{98A425A1-B7D1-D5C7-D465-CF9A3C1D886A}"/>
+                </a:ext>
+              </a:extLst>
+            </p:cNvPr>
+            <p:cNvCxnSpPr>
+              <a:cxnSpLocks/>
+              <a:stCxn id="18" idx="4"/>
+              <a:endCxn id="122" idx="0"/>
+            </p:cNvCxnSpPr>
+            <p:nvPr/>
+          </p:nvCxnSpPr>
+          <p:spPr>
+            <a:xfrm rot="16200000" flipH="1">
+              <a:off x="3521898" y="2208649"/>
+              <a:ext cx="650860" cy="4302572"/>
+            </a:xfrm>
+            <a:prstGeom prst="curvedConnector3">
+              <a:avLst>
+                <a:gd name="adj1" fmla="val 50000"/>
+              </a:avLst>
+            </a:prstGeom>
+            <a:ln>
+              <a:solidFill>
+                <a:schemeClr val="bg2">
+                  <a:lumMod val="25000"/>
+                  <a:alpha val="32838"/>
+                </a:schemeClr>
+              </a:solidFill>
+              <a:prstDash val="solid"/>
+              <a:tailEnd type="triangle"/>
+            </a:ln>
+          </p:spPr>
+          <p:style>
+            <a:lnRef idx="2">
+              <a:schemeClr val="accent1"/>
+            </a:lnRef>
+            <a:fillRef idx="0">
+              <a:schemeClr val="accent1"/>
+            </a:fillRef>
+            <a:effectRef idx="1">
+              <a:schemeClr val="accent1"/>
+            </a:effectRef>
+            <a:fontRef idx="minor">
+              <a:schemeClr val="tx1"/>
+            </a:fontRef>
+          </p:style>
+        </p:cxnSp>
+        <p:cxnSp>
+          <p:nvCxnSpPr>
+            <p:cNvPr id="135" name="Curved Connector 134">
+              <a:extLst>
+                <a:ext uri="{FF2B5EF4-FFF2-40B4-BE49-F238E27FC236}">
+                  <a16:creationId xmlns:a16="http://schemas.microsoft.com/office/drawing/2014/main" id="{A12B3EF9-9A94-1992-C400-BB5BE5CB3873}"/>
+                </a:ext>
+              </a:extLst>
+            </p:cNvPr>
+            <p:cNvCxnSpPr>
+              <a:cxnSpLocks/>
+              <a:stCxn id="21" idx="4"/>
+              <a:endCxn id="122" idx="0"/>
+            </p:cNvCxnSpPr>
+            <p:nvPr/>
+          </p:nvCxnSpPr>
+          <p:spPr>
+            <a:xfrm rot="16200000" flipH="1">
+              <a:off x="4391216" y="3077967"/>
+              <a:ext cx="650860" cy="2563935"/>
+            </a:xfrm>
+            <a:prstGeom prst="curvedConnector3">
+              <a:avLst>
+                <a:gd name="adj1" fmla="val 50000"/>
+              </a:avLst>
+            </a:prstGeom>
+            <a:ln>
+              <a:solidFill>
+                <a:schemeClr val="bg2">
+                  <a:lumMod val="25000"/>
+                  <a:alpha val="32838"/>
+                </a:schemeClr>
+              </a:solidFill>
+              <a:prstDash val="solid"/>
+              <a:tailEnd type="triangle"/>
+            </a:ln>
+          </p:spPr>
+          <p:style>
+            <a:lnRef idx="2">
+              <a:schemeClr val="accent1"/>
+            </a:lnRef>
+            <a:fillRef idx="0">
+              <a:schemeClr val="accent1"/>
+            </a:fillRef>
+            <a:effectRef idx="1">
+              <a:schemeClr val="accent1"/>
+            </a:effectRef>
+            <a:fontRef idx="minor">
+              <a:schemeClr val="tx1"/>
+            </a:fontRef>
+          </p:style>
+        </p:cxnSp>
+        <p:cxnSp>
+          <p:nvCxnSpPr>
+            <p:cNvPr id="138" name="Curved Connector 137">
+              <a:extLst>
+                <a:ext uri="{FF2B5EF4-FFF2-40B4-BE49-F238E27FC236}">
+                  <a16:creationId xmlns:a16="http://schemas.microsoft.com/office/drawing/2014/main" id="{DEA50284-5A97-296E-9CD2-B6A83A177227}"/>
+                </a:ext>
+              </a:extLst>
+            </p:cNvPr>
+            <p:cNvCxnSpPr>
+              <a:cxnSpLocks/>
+              <a:stCxn id="24" idx="4"/>
+              <a:endCxn id="122" idx="0"/>
+            </p:cNvCxnSpPr>
+            <p:nvPr/>
+          </p:nvCxnSpPr>
+          <p:spPr>
+            <a:xfrm rot="16200000" flipH="1">
+              <a:off x="5260535" y="3947286"/>
+              <a:ext cx="650860" cy="825298"/>
+            </a:xfrm>
+            <a:prstGeom prst="curvedConnector3">
+              <a:avLst>
+                <a:gd name="adj1" fmla="val 50000"/>
+              </a:avLst>
+            </a:prstGeom>
+            <a:ln>
+              <a:solidFill>
+                <a:schemeClr val="bg2">
+                  <a:lumMod val="25000"/>
+                  <a:alpha val="32838"/>
+                </a:schemeClr>
+              </a:solidFill>
+              <a:prstDash val="solid"/>
+              <a:tailEnd type="triangle"/>
+            </a:ln>
+          </p:spPr>
+          <p:style>
+            <a:lnRef idx="2">
+              <a:schemeClr val="accent1"/>
+            </a:lnRef>
+            <a:fillRef idx="0">
+              <a:schemeClr val="accent1"/>
+            </a:fillRef>
+            <a:effectRef idx="1">
+              <a:schemeClr val="accent1"/>
+            </a:effectRef>
+            <a:fontRef idx="minor">
+              <a:schemeClr val="tx1"/>
+            </a:fontRef>
+          </p:style>
+        </p:cxnSp>
+        <p:cxnSp>
+          <p:nvCxnSpPr>
+            <p:cNvPr id="141" name="Curved Connector 140">
+              <a:extLst>
+                <a:ext uri="{FF2B5EF4-FFF2-40B4-BE49-F238E27FC236}">
+                  <a16:creationId xmlns:a16="http://schemas.microsoft.com/office/drawing/2014/main" id="{AD5D0E67-7E37-D24F-DFF7-C6D12F9E7E41}"/>
+                </a:ext>
+              </a:extLst>
+            </p:cNvPr>
+            <p:cNvCxnSpPr>
+              <a:cxnSpLocks/>
+              <a:stCxn id="27" idx="4"/>
+              <a:endCxn id="122" idx="0"/>
+            </p:cNvCxnSpPr>
+            <p:nvPr/>
+          </p:nvCxnSpPr>
+          <p:spPr>
+            <a:xfrm rot="5400000">
+              <a:off x="6117265" y="3890677"/>
+              <a:ext cx="676038" cy="913339"/>
+            </a:xfrm>
+            <a:prstGeom prst="curvedConnector3">
+              <a:avLst>
+                <a:gd name="adj1" fmla="val 50000"/>
+              </a:avLst>
+            </a:prstGeom>
+            <a:ln>
+              <a:solidFill>
+                <a:schemeClr val="bg2">
+                  <a:lumMod val="25000"/>
+                  <a:alpha val="32838"/>
+                </a:schemeClr>
+              </a:solidFill>
+              <a:prstDash val="solid"/>
+              <a:tailEnd type="triangle"/>
+            </a:ln>
+          </p:spPr>
+          <p:style>
+            <a:lnRef idx="2">
+              <a:schemeClr val="accent1"/>
+            </a:lnRef>
+            <a:fillRef idx="0">
+              <a:schemeClr val="accent1"/>
+            </a:fillRef>
+            <a:effectRef idx="1">
+              <a:schemeClr val="accent1"/>
+            </a:effectRef>
+            <a:fontRef idx="minor">
+              <a:schemeClr val="tx1"/>
+            </a:fontRef>
+          </p:style>
+        </p:cxnSp>
+        <p:cxnSp>
+          <p:nvCxnSpPr>
+            <p:cNvPr id="144" name="Curved Connector 143">
+              <a:extLst>
+                <a:ext uri="{FF2B5EF4-FFF2-40B4-BE49-F238E27FC236}">
+                  <a16:creationId xmlns:a16="http://schemas.microsoft.com/office/drawing/2014/main" id="{C6D5ED67-977B-1E62-3C4C-1236808A3F91}"/>
+                </a:ext>
+              </a:extLst>
+            </p:cNvPr>
+            <p:cNvCxnSpPr>
+              <a:cxnSpLocks/>
+              <a:stCxn id="30" idx="4"/>
+              <a:endCxn id="122" idx="0"/>
+            </p:cNvCxnSpPr>
+            <p:nvPr/>
+          </p:nvCxnSpPr>
+          <p:spPr>
+            <a:xfrm rot="5400000">
+              <a:off x="6999172" y="3033947"/>
+              <a:ext cx="650860" cy="2651976"/>
+            </a:xfrm>
+            <a:prstGeom prst="curvedConnector3">
+              <a:avLst>
+                <a:gd name="adj1" fmla="val 50000"/>
+              </a:avLst>
+            </a:prstGeom>
+            <a:ln>
+              <a:solidFill>
+                <a:schemeClr val="bg2">
+                  <a:lumMod val="25000"/>
+                  <a:alpha val="32838"/>
+                </a:schemeClr>
+              </a:solidFill>
+              <a:prstDash val="solid"/>
+              <a:tailEnd type="triangle"/>
+            </a:ln>
+          </p:spPr>
+          <p:style>
+            <a:lnRef idx="2">
+              <a:schemeClr val="accent1"/>
+            </a:lnRef>
+            <a:fillRef idx="0">
+              <a:schemeClr val="accent1"/>
+            </a:fillRef>
+            <a:effectRef idx="1">
+              <a:schemeClr val="accent1"/>
+            </a:effectRef>
+            <a:fontRef idx="minor">
+              <a:schemeClr val="tx1"/>
+            </a:fontRef>
+          </p:style>
+        </p:cxnSp>
+        <p:cxnSp>
+          <p:nvCxnSpPr>
+            <p:cNvPr id="147" name="Curved Connector 146">
+              <a:extLst>
+                <a:ext uri="{FF2B5EF4-FFF2-40B4-BE49-F238E27FC236}">
+                  <a16:creationId xmlns:a16="http://schemas.microsoft.com/office/drawing/2014/main" id="{18DB1D3E-8552-6542-5C7C-93E2BA5D348B}"/>
+                </a:ext>
+              </a:extLst>
+            </p:cNvPr>
+            <p:cNvCxnSpPr>
+              <a:cxnSpLocks/>
+              <a:stCxn id="33" idx="4"/>
+              <a:endCxn id="122" idx="0"/>
+            </p:cNvCxnSpPr>
+            <p:nvPr/>
+          </p:nvCxnSpPr>
+          <p:spPr>
+            <a:xfrm rot="5400000">
+              <a:off x="7868491" y="2164629"/>
+              <a:ext cx="650860" cy="4390613"/>
+            </a:xfrm>
+            <a:prstGeom prst="curvedConnector3">
+              <a:avLst>
+                <a:gd name="adj1" fmla="val 50000"/>
+              </a:avLst>
+            </a:prstGeom>
+            <a:ln>
+              <a:solidFill>
+                <a:schemeClr val="bg2">
+                  <a:lumMod val="25000"/>
+                  <a:alpha val="32838"/>
+                </a:schemeClr>
+              </a:solidFill>
+              <a:prstDash val="solid"/>
+              <a:tailEnd type="triangle"/>
+            </a:ln>
+          </p:spPr>
+          <p:style>
+            <a:lnRef idx="2">
+              <a:schemeClr val="accent1"/>
+            </a:lnRef>
+            <a:fillRef idx="0">
+              <a:schemeClr val="accent1"/>
+            </a:fillRef>
+            <a:effectRef idx="1">
+              <a:schemeClr val="accent1"/>
+            </a:effectRef>
+            <a:fontRef idx="minor">
+              <a:schemeClr val="tx1"/>
+            </a:fontRef>
+          </p:style>
+        </p:cxnSp>
+        <p:cxnSp>
+          <p:nvCxnSpPr>
+            <p:cNvPr id="150" name="Curved Connector 149">
+              <a:extLst>
+                <a:ext uri="{FF2B5EF4-FFF2-40B4-BE49-F238E27FC236}">
+                  <a16:creationId xmlns:a16="http://schemas.microsoft.com/office/drawing/2014/main" id="{BE31EA2A-7E12-738A-55B4-F8141105CE7B}"/>
+                </a:ext>
+              </a:extLst>
+            </p:cNvPr>
+            <p:cNvCxnSpPr>
+              <a:cxnSpLocks/>
+              <a:stCxn id="122" idx="2"/>
+              <a:endCxn id="100" idx="0"/>
+            </p:cNvCxnSpPr>
+            <p:nvPr/>
+          </p:nvCxnSpPr>
+          <p:spPr>
+            <a:xfrm rot="5400000">
+              <a:off x="3586701" y="3511274"/>
+              <a:ext cx="559944" cy="4263882"/>
+            </a:xfrm>
+            <a:prstGeom prst="curvedConnector3">
+              <a:avLst>
+                <a:gd name="adj1" fmla="val 50000"/>
+              </a:avLst>
+            </a:prstGeom>
+            <a:ln>
+              <a:solidFill>
+                <a:schemeClr val="bg2">
+                  <a:lumMod val="25000"/>
+                  <a:alpha val="32838"/>
+                </a:schemeClr>
+              </a:solidFill>
+              <a:prstDash val="solid"/>
+              <a:tailEnd type="triangle"/>
+            </a:ln>
+          </p:spPr>
+          <p:style>
+            <a:lnRef idx="2">
+              <a:schemeClr val="accent1"/>
+            </a:lnRef>
+            <a:fillRef idx="0">
+              <a:schemeClr val="accent1"/>
+            </a:fillRef>
+            <a:effectRef idx="1">
+              <a:schemeClr val="accent1"/>
+            </a:effectRef>
+            <a:fontRef idx="minor">
+              <a:schemeClr val="tx1"/>
+            </a:fontRef>
+          </p:style>
+        </p:cxnSp>
+        <p:cxnSp>
+          <p:nvCxnSpPr>
+            <p:cNvPr id="153" name="Curved Connector 152">
+              <a:extLst>
+                <a:ext uri="{FF2B5EF4-FFF2-40B4-BE49-F238E27FC236}">
+                  <a16:creationId xmlns:a16="http://schemas.microsoft.com/office/drawing/2014/main" id="{5553348C-81C9-6DE0-55AA-B991A029CC8D}"/>
+                </a:ext>
+              </a:extLst>
+            </p:cNvPr>
+            <p:cNvCxnSpPr>
+              <a:cxnSpLocks/>
+              <a:stCxn id="122" idx="2"/>
+              <a:endCxn id="117" idx="0"/>
+            </p:cNvCxnSpPr>
+            <p:nvPr/>
+          </p:nvCxnSpPr>
+          <p:spPr>
+            <a:xfrm rot="5400000">
+              <a:off x="4439363" y="4362832"/>
+              <a:ext cx="558841" cy="2559662"/>
+            </a:xfrm>
+            <a:prstGeom prst="curvedConnector3">
+              <a:avLst>
+                <a:gd name="adj1" fmla="val 50000"/>
+              </a:avLst>
+            </a:prstGeom>
+            <a:ln>
+              <a:solidFill>
+                <a:schemeClr val="bg2">
+                  <a:lumMod val="25000"/>
+                  <a:alpha val="32838"/>
+                </a:schemeClr>
+              </a:solidFill>
+              <a:prstDash val="solid"/>
+              <a:tailEnd type="triangle"/>
+            </a:ln>
+          </p:spPr>
+          <p:style>
+            <a:lnRef idx="2">
+              <a:schemeClr val="accent1"/>
+            </a:lnRef>
+            <a:fillRef idx="0">
+              <a:schemeClr val="accent1"/>
+            </a:fillRef>
+            <a:effectRef idx="1">
+              <a:schemeClr val="accent1"/>
+            </a:effectRef>
+            <a:fontRef idx="minor">
+              <a:schemeClr val="tx1"/>
+            </a:fontRef>
+          </p:style>
+        </p:cxnSp>
+        <p:cxnSp>
+          <p:nvCxnSpPr>
+            <p:cNvPr id="156" name="Curved Connector 155">
+              <a:extLst>
+                <a:ext uri="{FF2B5EF4-FFF2-40B4-BE49-F238E27FC236}">
+                  <a16:creationId xmlns:a16="http://schemas.microsoft.com/office/drawing/2014/main" id="{8A3790C2-53A1-F64C-A391-B9B5FF087458}"/>
+                </a:ext>
+              </a:extLst>
+            </p:cNvPr>
+            <p:cNvCxnSpPr>
+              <a:cxnSpLocks/>
+              <a:stCxn id="122" idx="2"/>
+              <a:endCxn id="118" idx="0"/>
+            </p:cNvCxnSpPr>
+            <p:nvPr/>
+          </p:nvCxnSpPr>
+          <p:spPr>
+            <a:xfrm rot="5400000">
+              <a:off x="5291473" y="5214942"/>
+              <a:ext cx="558841" cy="855442"/>
+            </a:xfrm>
+            <a:prstGeom prst="curvedConnector3">
+              <a:avLst>
+                <a:gd name="adj1" fmla="val 50000"/>
+              </a:avLst>
+            </a:prstGeom>
+            <a:ln>
+              <a:solidFill>
+                <a:schemeClr val="bg2">
+                  <a:lumMod val="25000"/>
+                  <a:alpha val="32838"/>
+                </a:schemeClr>
+              </a:solidFill>
+              <a:prstDash val="solid"/>
+              <a:tailEnd type="triangle"/>
+            </a:ln>
+          </p:spPr>
+          <p:style>
+            <a:lnRef idx="2">
+              <a:schemeClr val="accent1"/>
+            </a:lnRef>
+            <a:fillRef idx="0">
+              <a:schemeClr val="accent1"/>
+            </a:fillRef>
+            <a:effectRef idx="1">
+              <a:schemeClr val="accent1"/>
+            </a:effectRef>
+            <a:fontRef idx="minor">
+              <a:schemeClr val="tx1"/>
+            </a:fontRef>
+          </p:style>
+        </p:cxnSp>
+        <p:cxnSp>
+          <p:nvCxnSpPr>
+            <p:cNvPr id="159" name="Curved Connector 158">
+              <a:extLst>
+                <a:ext uri="{FF2B5EF4-FFF2-40B4-BE49-F238E27FC236}">
+                  <a16:creationId xmlns:a16="http://schemas.microsoft.com/office/drawing/2014/main" id="{01F83BBB-AFF0-FA39-8BB6-191BC9A5B455}"/>
+                </a:ext>
+              </a:extLst>
+            </p:cNvPr>
+            <p:cNvCxnSpPr>
+              <a:cxnSpLocks/>
+              <a:stCxn id="122" idx="2"/>
+              <a:endCxn id="119" idx="0"/>
+            </p:cNvCxnSpPr>
+            <p:nvPr/>
+          </p:nvCxnSpPr>
+          <p:spPr>
+            <a:xfrm rot="16200000" flipH="1">
+              <a:off x="6185309" y="5176548"/>
+              <a:ext cx="558841" cy="932230"/>
+            </a:xfrm>
+            <a:prstGeom prst="curvedConnector3">
+              <a:avLst>
+                <a:gd name="adj1" fmla="val 50000"/>
+              </a:avLst>
+            </a:prstGeom>
+            <a:ln>
+              <a:solidFill>
+                <a:schemeClr val="bg2">
+                  <a:lumMod val="25000"/>
+                  <a:alpha val="32838"/>
+                </a:schemeClr>
+              </a:solidFill>
+              <a:prstDash val="solid"/>
+              <a:tailEnd type="triangle"/>
+            </a:ln>
+          </p:spPr>
+          <p:style>
+            <a:lnRef idx="2">
+              <a:schemeClr val="accent1"/>
+            </a:lnRef>
+            <a:fillRef idx="0">
+              <a:schemeClr val="accent1"/>
+            </a:fillRef>
+            <a:effectRef idx="1">
+              <a:schemeClr val="accent1"/>
+            </a:effectRef>
+            <a:fontRef idx="minor">
+              <a:schemeClr val="tx1"/>
+            </a:fontRef>
+          </p:style>
+        </p:cxnSp>
+        <p:cxnSp>
+          <p:nvCxnSpPr>
+            <p:cNvPr id="162" name="Curved Connector 161">
+              <a:extLst>
+                <a:ext uri="{FF2B5EF4-FFF2-40B4-BE49-F238E27FC236}">
+                  <a16:creationId xmlns:a16="http://schemas.microsoft.com/office/drawing/2014/main" id="{8E2ACD6B-06B2-4964-8337-94ADF0AF993F}"/>
+                </a:ext>
+              </a:extLst>
+            </p:cNvPr>
+            <p:cNvCxnSpPr>
+              <a:cxnSpLocks/>
+              <a:stCxn id="122" idx="2"/>
+              <a:endCxn id="120" idx="0"/>
+            </p:cNvCxnSpPr>
+            <p:nvPr/>
+          </p:nvCxnSpPr>
+          <p:spPr>
+            <a:xfrm rot="16200000" flipH="1">
+              <a:off x="7054495" y="4307361"/>
+              <a:ext cx="528220" cy="2639983"/>
+            </a:xfrm>
+            <a:prstGeom prst="curvedConnector3">
+              <a:avLst>
+                <a:gd name="adj1" fmla="val 50000"/>
+              </a:avLst>
+            </a:prstGeom>
+            <a:ln>
+              <a:solidFill>
+                <a:schemeClr val="bg2">
+                  <a:lumMod val="25000"/>
+                  <a:alpha val="32838"/>
+                </a:schemeClr>
+              </a:solidFill>
+              <a:prstDash val="solid"/>
+              <a:tailEnd type="triangle"/>
+            </a:ln>
+          </p:spPr>
+          <p:style>
+            <a:lnRef idx="2">
+              <a:schemeClr val="accent1"/>
+            </a:lnRef>
+            <a:fillRef idx="0">
+              <a:schemeClr val="accent1"/>
+            </a:fillRef>
+            <a:effectRef idx="1">
+              <a:schemeClr val="accent1"/>
+            </a:effectRef>
+            <a:fontRef idx="minor">
+              <a:schemeClr val="tx1"/>
+            </a:fontRef>
+          </p:style>
+        </p:cxnSp>
+        <p:cxnSp>
+          <p:nvCxnSpPr>
+            <p:cNvPr id="165" name="Curved Connector 164">
+              <a:extLst>
+                <a:ext uri="{FF2B5EF4-FFF2-40B4-BE49-F238E27FC236}">
+                  <a16:creationId xmlns:a16="http://schemas.microsoft.com/office/drawing/2014/main" id="{E92089A8-0097-94C8-6BB3-BFB25588AC65}"/>
+                </a:ext>
+              </a:extLst>
+            </p:cNvPr>
+            <p:cNvCxnSpPr>
+              <a:cxnSpLocks/>
+              <a:stCxn id="122" idx="2"/>
+              <a:endCxn id="121" idx="0"/>
+            </p:cNvCxnSpPr>
+            <p:nvPr/>
+          </p:nvCxnSpPr>
+          <p:spPr>
+            <a:xfrm rot="16200000" flipH="1">
+              <a:off x="7923681" y="3438175"/>
+              <a:ext cx="541561" cy="4391695"/>
+            </a:xfrm>
+            <a:prstGeom prst="curvedConnector3">
+              <a:avLst>
+                <a:gd name="adj1" fmla="val 50000"/>
+              </a:avLst>
+            </a:prstGeom>
+            <a:ln>
+              <a:solidFill>
+                <a:schemeClr val="bg2">
+                  <a:lumMod val="25000"/>
+                  <a:alpha val="32838"/>
+                </a:schemeClr>
+              </a:solidFill>
+              <a:prstDash val="solid"/>
+              <a:tailEnd type="triangle"/>
+            </a:ln>
+          </p:spPr>
+          <p:style>
+            <a:lnRef idx="2">
+              <a:schemeClr val="accent1"/>
+            </a:lnRef>
+            <a:fillRef idx="0">
+              <a:schemeClr val="accent1"/>
+            </a:fillRef>
+            <a:effectRef idx="1">
+              <a:schemeClr val="accent1"/>
+            </a:effectRef>
+            <a:fontRef idx="minor">
+              <a:schemeClr val="tx1"/>
+            </a:fontRef>
+          </p:style>
+        </p:cxnSp>
+      </p:grpSp>
+    </p:spTree>
+    <p:extLst>
+      <p:ext uri="{BB962C8B-B14F-4D97-AF65-F5344CB8AC3E}">
+        <p14:creationId xmlns:p14="http://schemas.microsoft.com/office/powerpoint/2010/main" val="321419561"/>
       </p:ext>
     </p:extLst>
   </p:cSld>

</xml_diff>

<commit_message>
through fitting, now on to interpretation and finally editing
</commit_message>
<xml_diff>
--- a/_site/assets/images/thurstone_blog/densities_editable.pptx
+++ b/_site/assets/images/thurstone_blog/densities_editable.pptx
@@ -271,7 +271,7 @@
           <a:p>
             <a:fld id="{E6F6D8E5-6BA1-2B4B-963D-F2E25306724E}" type="datetimeFigureOut">
               <a:rPr lang="en-US" smtClean="0"/>
-              <a:t>8/6/24</a:t>
+              <a:t>8/7/24</a:t>
             </a:fld>
             <a:endParaRPr lang="en-US"/>
           </a:p>
@@ -469,7 +469,7 @@
           <a:p>
             <a:fld id="{E6F6D8E5-6BA1-2B4B-963D-F2E25306724E}" type="datetimeFigureOut">
               <a:rPr lang="en-US" smtClean="0"/>
-              <a:t>8/6/24</a:t>
+              <a:t>8/7/24</a:t>
             </a:fld>
             <a:endParaRPr lang="en-US"/>
           </a:p>
@@ -677,7 +677,7 @@
           <a:p>
             <a:fld id="{E6F6D8E5-6BA1-2B4B-963D-F2E25306724E}" type="datetimeFigureOut">
               <a:rPr lang="en-US" smtClean="0"/>
-              <a:t>8/6/24</a:t>
+              <a:t>8/7/24</a:t>
             </a:fld>
             <a:endParaRPr lang="en-US"/>
           </a:p>
@@ -875,7 +875,7 @@
           <a:p>
             <a:fld id="{E6F6D8E5-6BA1-2B4B-963D-F2E25306724E}" type="datetimeFigureOut">
               <a:rPr lang="en-US" smtClean="0"/>
-              <a:t>8/6/24</a:t>
+              <a:t>8/7/24</a:t>
             </a:fld>
             <a:endParaRPr lang="en-US"/>
           </a:p>
@@ -1150,7 +1150,7 @@
           <a:p>
             <a:fld id="{E6F6D8E5-6BA1-2B4B-963D-F2E25306724E}" type="datetimeFigureOut">
               <a:rPr lang="en-US" smtClean="0"/>
-              <a:t>8/6/24</a:t>
+              <a:t>8/7/24</a:t>
             </a:fld>
             <a:endParaRPr lang="en-US"/>
           </a:p>
@@ -1415,7 +1415,7 @@
           <a:p>
             <a:fld id="{E6F6D8E5-6BA1-2B4B-963D-F2E25306724E}" type="datetimeFigureOut">
               <a:rPr lang="en-US" smtClean="0"/>
-              <a:t>8/6/24</a:t>
+              <a:t>8/7/24</a:t>
             </a:fld>
             <a:endParaRPr lang="en-US"/>
           </a:p>
@@ -1827,7 +1827,7 @@
           <a:p>
             <a:fld id="{E6F6D8E5-6BA1-2B4B-963D-F2E25306724E}" type="datetimeFigureOut">
               <a:rPr lang="en-US" smtClean="0"/>
-              <a:t>8/6/24</a:t>
+              <a:t>8/7/24</a:t>
             </a:fld>
             <a:endParaRPr lang="en-US"/>
           </a:p>
@@ -1968,7 +1968,7 @@
           <a:p>
             <a:fld id="{E6F6D8E5-6BA1-2B4B-963D-F2E25306724E}" type="datetimeFigureOut">
               <a:rPr lang="en-US" smtClean="0"/>
-              <a:t>8/6/24</a:t>
+              <a:t>8/7/24</a:t>
             </a:fld>
             <a:endParaRPr lang="en-US"/>
           </a:p>
@@ -2081,7 +2081,7 @@
           <a:p>
             <a:fld id="{E6F6D8E5-6BA1-2B4B-963D-F2E25306724E}" type="datetimeFigureOut">
               <a:rPr lang="en-US" smtClean="0"/>
-              <a:t>8/6/24</a:t>
+              <a:t>8/7/24</a:t>
             </a:fld>
             <a:endParaRPr lang="en-US"/>
           </a:p>
@@ -2392,7 +2392,7 @@
           <a:p>
             <a:fld id="{E6F6D8E5-6BA1-2B4B-963D-F2E25306724E}" type="datetimeFigureOut">
               <a:rPr lang="en-US" smtClean="0"/>
-              <a:t>8/6/24</a:t>
+              <a:t>8/7/24</a:t>
             </a:fld>
             <a:endParaRPr lang="en-US"/>
           </a:p>
@@ -2680,7 +2680,7 @@
           <a:p>
             <a:fld id="{E6F6D8E5-6BA1-2B4B-963D-F2E25306724E}" type="datetimeFigureOut">
               <a:rPr lang="en-US" smtClean="0"/>
-              <a:t>8/6/24</a:t>
+              <a:t>8/7/24</a:t>
             </a:fld>
             <a:endParaRPr lang="en-US"/>
           </a:p>
@@ -2921,7 +2921,7 @@
           <a:p>
             <a:fld id="{E6F6D8E5-6BA1-2B4B-963D-F2E25306724E}" type="datetimeFigureOut">
               <a:rPr lang="en-US" smtClean="0"/>
-              <a:t>8/6/24</a:t>
+              <a:t>8/7/24</a:t>
             </a:fld>
             <a:endParaRPr lang="en-US"/>
           </a:p>
@@ -4798,10 +4798,10 @@
                             </m:sSubPr>
                             <m:e>
                               <m:r>
-                                <a:rPr lang="en-US" sz="3600" i="1" smtClean="0">
+                                <a:rPr lang="en-US" sz="3600" b="0" i="1" smtClean="0">
                                   <a:latin typeface="Cambria Math" panose="02040503050406030204" pitchFamily="18" charset="0"/>
                                 </a:rPr>
-                                <m:t>𝜇</m:t>
+                                <m:t>𝑈</m:t>
                               </m:r>
                             </m:e>
                             <m:sub>
@@ -4847,7 +4847,7 @@
                   <a:blipFill>
                     <a:blip r:embed="rId2"/>
                     <a:stretch>
-                      <a:fillRect b="-11765"/>
+                      <a:fillRect l="-1639" b="-3922"/>
                     </a:stretch>
                   </a:blipFill>
                 </p:spPr>
@@ -4986,10 +4986,10 @@
                             </m:sSubPr>
                             <m:e>
                               <m:r>
-                                <a:rPr lang="en-US" sz="3600" i="1" smtClean="0">
+                                <a:rPr lang="en-US" sz="3600" b="0" i="1" smtClean="0">
                                   <a:latin typeface="Cambria Math" panose="02040503050406030204" pitchFamily="18" charset="0"/>
                                 </a:rPr>
-                                <m:t>𝜇</m:t>
+                                <m:t>𝑈</m:t>
                               </m:r>
                             </m:e>
                             <m:sub>
@@ -5035,7 +5035,7 @@
                   <a:blipFill>
                     <a:blip r:embed="rId3"/>
                     <a:stretch>
-                      <a:fillRect l="-1639" b="-11765"/>
+                      <a:fillRect l="-3279" b="-3922"/>
                     </a:stretch>
                   </a:blipFill>
                 </p:spPr>
@@ -5174,10 +5174,10 @@
                             </m:sSubPr>
                             <m:e>
                               <m:r>
-                                <a:rPr lang="en-US" sz="3600" i="1" smtClean="0">
+                                <a:rPr lang="en-US" sz="3600" b="0" i="1" smtClean="0">
                                   <a:latin typeface="Cambria Math" panose="02040503050406030204" pitchFamily="18" charset="0"/>
                                 </a:rPr>
-                                <m:t>𝜇</m:t>
+                                <m:t>𝑈</m:t>
                               </m:r>
                             </m:e>
                             <m:sub>
@@ -5223,7 +5223,7 @@
                   <a:blipFill>
                     <a:blip r:embed="rId4"/>
                     <a:stretch>
-                      <a:fillRect b="-9615"/>
+                      <a:fillRect l="-1613" b="-1923"/>
                     </a:stretch>
                   </a:blipFill>
                 </p:spPr>
@@ -5362,10 +5362,10 @@
                             </m:sSubPr>
                             <m:e>
                               <m:r>
-                                <a:rPr lang="en-US" sz="3600" i="1" smtClean="0">
+                                <a:rPr lang="en-US" sz="3600" b="0" i="1" smtClean="0">
                                   <a:latin typeface="Cambria Math" panose="02040503050406030204" pitchFamily="18" charset="0"/>
                                 </a:rPr>
-                                <m:t>𝜇</m:t>
+                                <m:t>𝑈</m:t>
                               </m:r>
                             </m:e>
                             <m:sub>
@@ -5411,7 +5411,7 @@
                   <a:blipFill>
                     <a:blip r:embed="rId5"/>
                     <a:stretch>
-                      <a:fillRect b="-9615"/>
+                      <a:fillRect l="-3279" b="-1923"/>
                     </a:stretch>
                   </a:blipFill>
                 </p:spPr>
@@ -5503,8 +5503,8 @@
               <a:chExt cx="914400" cy="914400"/>
             </a:xfrm>
           </p:grpSpPr>
-          <mc:AlternateContent xmlns:mc="http://schemas.openxmlformats.org/markup-compatibility/2006">
-            <mc:Choice xmlns:a14="http://schemas.microsoft.com/office/drawing/2010/main" Requires="a14">
+          <mc:AlternateContent xmlns:mc="http://schemas.openxmlformats.org/markup-compatibility/2006" xmlns:a14="http://schemas.microsoft.com/office/drawing/2010/main">
+            <mc:Choice Requires="a14">
               <p:sp>
                 <p:nvSpPr>
                   <p:cNvPr id="17" name="TextBox 16">
@@ -5573,7 +5573,7 @@
                 </p:txBody>
               </p:sp>
             </mc:Choice>
-            <mc:Fallback>
+            <mc:Fallback xmlns="">
               <p:sp>
                 <p:nvSpPr>
                   <p:cNvPr id="17" name="TextBox 16">
@@ -5691,8 +5691,8 @@
               <a:chExt cx="914400" cy="914400"/>
             </a:xfrm>
           </p:grpSpPr>
-          <mc:AlternateContent xmlns:mc="http://schemas.openxmlformats.org/markup-compatibility/2006">
-            <mc:Choice xmlns:a14="http://schemas.microsoft.com/office/drawing/2010/main" Requires="a14">
+          <mc:AlternateContent xmlns:mc="http://schemas.openxmlformats.org/markup-compatibility/2006" xmlns:a14="http://schemas.microsoft.com/office/drawing/2010/main">
+            <mc:Choice Requires="a14">
               <p:sp>
                 <p:nvSpPr>
                   <p:cNvPr id="20" name="TextBox 19">
@@ -5761,7 +5761,7 @@
                 </p:txBody>
               </p:sp>
             </mc:Choice>
-            <mc:Fallback>
+            <mc:Fallback xmlns="">
               <p:sp>
                 <p:nvSpPr>
                   <p:cNvPr id="20" name="TextBox 19">
@@ -5879,8 +5879,8 @@
               <a:chExt cx="914400" cy="914400"/>
             </a:xfrm>
           </p:grpSpPr>
-          <mc:AlternateContent xmlns:mc="http://schemas.openxmlformats.org/markup-compatibility/2006">
-            <mc:Choice xmlns:a14="http://schemas.microsoft.com/office/drawing/2010/main" Requires="a14">
+          <mc:AlternateContent xmlns:mc="http://schemas.openxmlformats.org/markup-compatibility/2006" xmlns:a14="http://schemas.microsoft.com/office/drawing/2010/main">
+            <mc:Choice Requires="a14">
               <p:sp>
                 <p:nvSpPr>
                   <p:cNvPr id="23" name="TextBox 22">
@@ -5949,7 +5949,7 @@
                 </p:txBody>
               </p:sp>
             </mc:Choice>
-            <mc:Fallback>
+            <mc:Fallback xmlns="">
               <p:sp>
                 <p:nvSpPr>
                   <p:cNvPr id="23" name="TextBox 22">
@@ -6067,8 +6067,8 @@
               <a:chExt cx="914400" cy="914400"/>
             </a:xfrm>
           </p:grpSpPr>
-          <mc:AlternateContent xmlns:mc="http://schemas.openxmlformats.org/markup-compatibility/2006">
-            <mc:Choice xmlns:a14="http://schemas.microsoft.com/office/drawing/2010/main" Requires="a14">
+          <mc:AlternateContent xmlns:mc="http://schemas.openxmlformats.org/markup-compatibility/2006" xmlns:a14="http://schemas.microsoft.com/office/drawing/2010/main">
+            <mc:Choice Requires="a14">
               <p:sp>
                 <p:nvSpPr>
                   <p:cNvPr id="26" name="TextBox 25">
@@ -6137,7 +6137,7 @@
                 </p:txBody>
               </p:sp>
             </mc:Choice>
-            <mc:Fallback>
+            <mc:Fallback xmlns="">
               <p:sp>
                 <p:nvSpPr>
                   <p:cNvPr id="26" name="TextBox 25">
@@ -6255,8 +6255,8 @@
               <a:chExt cx="914400" cy="914400"/>
             </a:xfrm>
           </p:grpSpPr>
-          <mc:AlternateContent xmlns:mc="http://schemas.openxmlformats.org/markup-compatibility/2006">
-            <mc:Choice xmlns:a14="http://schemas.microsoft.com/office/drawing/2010/main" Requires="a14">
+          <mc:AlternateContent xmlns:mc="http://schemas.openxmlformats.org/markup-compatibility/2006" xmlns:a14="http://schemas.microsoft.com/office/drawing/2010/main">
+            <mc:Choice Requires="a14">
               <p:sp>
                 <p:nvSpPr>
                   <p:cNvPr id="29" name="TextBox 28">
@@ -6325,7 +6325,7 @@
                 </p:txBody>
               </p:sp>
             </mc:Choice>
-            <mc:Fallback>
+            <mc:Fallback xmlns="">
               <p:sp>
                 <p:nvSpPr>
                   <p:cNvPr id="29" name="TextBox 28">
@@ -6443,8 +6443,8 @@
               <a:chExt cx="914400" cy="914400"/>
             </a:xfrm>
           </p:grpSpPr>
-          <mc:AlternateContent xmlns:mc="http://schemas.openxmlformats.org/markup-compatibility/2006">
-            <mc:Choice xmlns:a14="http://schemas.microsoft.com/office/drawing/2010/main" Requires="a14">
+          <mc:AlternateContent xmlns:mc="http://schemas.openxmlformats.org/markup-compatibility/2006" xmlns:a14="http://schemas.microsoft.com/office/drawing/2010/main">
+            <mc:Choice Requires="a14">
               <p:sp>
                 <p:nvSpPr>
                   <p:cNvPr id="32" name="TextBox 31">
@@ -6513,7 +6513,7 @@
                 </p:txBody>
               </p:sp>
             </mc:Choice>
-            <mc:Fallback>
+            <mc:Fallback xmlns="">
               <p:sp>
                 <p:nvSpPr>
                   <p:cNvPr id="32" name="TextBox 31">
@@ -7317,8 +7317,8 @@
             </a:fontRef>
           </p:style>
         </p:cxnSp>
-        <mc:AlternateContent xmlns:mc="http://schemas.openxmlformats.org/markup-compatibility/2006">
-          <mc:Choice xmlns:a14="http://schemas.microsoft.com/office/drawing/2010/main" Requires="a14">
+        <mc:AlternateContent xmlns:mc="http://schemas.openxmlformats.org/markup-compatibility/2006" xmlns:a14="http://schemas.microsoft.com/office/drawing/2010/main">
+          <mc:Choice Requires="a14">
             <p:sp>
               <p:nvSpPr>
                 <p:cNvPr id="93" name="TextBox 92">
@@ -7347,6 +7347,7 @@
                 </a:bodyPr>
                 <a:lstStyle/>
                 <a:p>
+                  <a:pPr/>
                   <a14:m>
                     <m:oMathPara xmlns:m="http://schemas.openxmlformats.org/officeDocument/2006/math">
                       <m:oMathParaPr>
@@ -7386,7 +7387,7 @@
               </p:txBody>
             </p:sp>
           </mc:Choice>
-          <mc:Fallback>
+          <mc:Fallback xmlns="">
             <p:sp>
               <p:nvSpPr>
                 <p:cNvPr id="93" name="TextBox 92">
@@ -7431,8 +7432,8 @@
             </p:sp>
           </mc:Fallback>
         </mc:AlternateContent>
-        <mc:AlternateContent xmlns:mc="http://schemas.openxmlformats.org/markup-compatibility/2006">
-          <mc:Choice xmlns:a14="http://schemas.microsoft.com/office/drawing/2010/main" Requires="a14">
+        <mc:AlternateContent xmlns:mc="http://schemas.openxmlformats.org/markup-compatibility/2006" xmlns:a14="http://schemas.microsoft.com/office/drawing/2010/main">
+          <mc:Choice Requires="a14">
             <p:sp>
               <p:nvSpPr>
                 <p:cNvPr id="94" name="TextBox 93">
@@ -7461,6 +7462,7 @@
                 </a:bodyPr>
                 <a:lstStyle/>
                 <a:p>
+                  <a:pPr/>
                   <a14:m>
                     <m:oMathPara xmlns:m="http://schemas.openxmlformats.org/officeDocument/2006/math">
                       <m:oMathParaPr>
@@ -7500,7 +7502,7 @@
               </p:txBody>
             </p:sp>
           </mc:Choice>
-          <mc:Fallback>
+          <mc:Fallback xmlns="">
             <p:sp>
               <p:nvSpPr>
                 <p:cNvPr id="94" name="TextBox 93">
@@ -7545,8 +7547,8 @@
             </p:sp>
           </mc:Fallback>
         </mc:AlternateContent>
-        <mc:AlternateContent xmlns:mc="http://schemas.openxmlformats.org/markup-compatibility/2006">
-          <mc:Choice xmlns:a14="http://schemas.microsoft.com/office/drawing/2010/main" Requires="a14">
+        <mc:AlternateContent xmlns:mc="http://schemas.openxmlformats.org/markup-compatibility/2006" xmlns:a14="http://schemas.microsoft.com/office/drawing/2010/main">
+          <mc:Choice Requires="a14">
             <p:sp>
               <p:nvSpPr>
                 <p:cNvPr id="95" name="TextBox 94">
@@ -7575,6 +7577,7 @@
                 </a:bodyPr>
                 <a:lstStyle/>
                 <a:p>
+                  <a:pPr/>
                   <a14:m>
                     <m:oMathPara xmlns:m="http://schemas.openxmlformats.org/officeDocument/2006/math">
                       <m:oMathParaPr>
@@ -7614,7 +7617,7 @@
               </p:txBody>
             </p:sp>
           </mc:Choice>
-          <mc:Fallback>
+          <mc:Fallback xmlns="">
             <p:sp>
               <p:nvSpPr>
                 <p:cNvPr id="95" name="TextBox 94">
@@ -7659,8 +7662,8 @@
             </p:sp>
           </mc:Fallback>
         </mc:AlternateContent>
-        <mc:AlternateContent xmlns:mc="http://schemas.openxmlformats.org/markup-compatibility/2006">
-          <mc:Choice xmlns:a14="http://schemas.microsoft.com/office/drawing/2010/main" Requires="a14">
+        <mc:AlternateContent xmlns:mc="http://schemas.openxmlformats.org/markup-compatibility/2006" xmlns:a14="http://schemas.microsoft.com/office/drawing/2010/main">
+          <mc:Choice Requires="a14">
             <p:sp>
               <p:nvSpPr>
                 <p:cNvPr id="100" name="TextBox 99">
@@ -7694,6 +7697,7 @@
                 </a:bodyPr>
                 <a:lstStyle/>
                 <a:p>
+                  <a:pPr/>
                   <a14:m>
                     <m:oMathPara xmlns:m="http://schemas.openxmlformats.org/officeDocument/2006/math">
                       <m:oMathParaPr>
@@ -7733,7 +7737,7 @@
               </p:txBody>
             </p:sp>
           </mc:Choice>
-          <mc:Fallback>
+          <mc:Fallback xmlns="">
             <p:sp>
               <p:nvSpPr>
                 <p:cNvPr id="100" name="TextBox 99">
@@ -7783,8 +7787,8 @@
             </p:sp>
           </mc:Fallback>
         </mc:AlternateContent>
-        <mc:AlternateContent xmlns:mc="http://schemas.openxmlformats.org/markup-compatibility/2006">
-          <mc:Choice xmlns:a14="http://schemas.microsoft.com/office/drawing/2010/main" Requires="a14">
+        <mc:AlternateContent xmlns:mc="http://schemas.openxmlformats.org/markup-compatibility/2006" xmlns:a14="http://schemas.microsoft.com/office/drawing/2010/main">
+          <mc:Choice Requires="a14">
             <p:sp>
               <p:nvSpPr>
                 <p:cNvPr id="117" name="TextBox 116">
@@ -7818,6 +7822,7 @@
                 </a:bodyPr>
                 <a:lstStyle/>
                 <a:p>
+                  <a:pPr/>
                   <a14:m>
                     <m:oMathPara xmlns:m="http://schemas.openxmlformats.org/officeDocument/2006/math">
                       <m:oMathParaPr>
@@ -7863,7 +7868,7 @@
               </p:txBody>
             </p:sp>
           </mc:Choice>
-          <mc:Fallback>
+          <mc:Fallback xmlns="">
             <p:sp>
               <p:nvSpPr>
                 <p:cNvPr id="117" name="TextBox 116">
@@ -7913,8 +7918,8 @@
             </p:sp>
           </mc:Fallback>
         </mc:AlternateContent>
-        <mc:AlternateContent xmlns:mc="http://schemas.openxmlformats.org/markup-compatibility/2006">
-          <mc:Choice xmlns:a14="http://schemas.microsoft.com/office/drawing/2010/main" Requires="a14">
+        <mc:AlternateContent xmlns:mc="http://schemas.openxmlformats.org/markup-compatibility/2006" xmlns:a14="http://schemas.microsoft.com/office/drawing/2010/main">
+          <mc:Choice Requires="a14">
             <p:sp>
               <p:nvSpPr>
                 <p:cNvPr id="118" name="TextBox 117">
@@ -7948,6 +7953,7 @@
                 </a:bodyPr>
                 <a:lstStyle/>
                 <a:p>
+                  <a:pPr/>
                   <a14:m>
                     <m:oMathPara xmlns:m="http://schemas.openxmlformats.org/officeDocument/2006/math">
                       <m:oMathParaPr>
@@ -7993,7 +7999,7 @@
               </p:txBody>
             </p:sp>
           </mc:Choice>
-          <mc:Fallback>
+          <mc:Fallback xmlns="">
             <p:sp>
               <p:nvSpPr>
                 <p:cNvPr id="118" name="TextBox 117">
@@ -8043,8 +8049,8 @@
             </p:sp>
           </mc:Fallback>
         </mc:AlternateContent>
-        <mc:AlternateContent xmlns:mc="http://schemas.openxmlformats.org/markup-compatibility/2006">
-          <mc:Choice xmlns:a14="http://schemas.microsoft.com/office/drawing/2010/main" Requires="a14">
+        <mc:AlternateContent xmlns:mc="http://schemas.openxmlformats.org/markup-compatibility/2006" xmlns:a14="http://schemas.microsoft.com/office/drawing/2010/main">
+          <mc:Choice Requires="a14">
             <p:sp>
               <p:nvSpPr>
                 <p:cNvPr id="119" name="TextBox 118">
@@ -8078,6 +8084,7 @@
                 </a:bodyPr>
                 <a:lstStyle/>
                 <a:p>
+                  <a:pPr/>
                   <a14:m>
                     <m:oMathPara xmlns:m="http://schemas.openxmlformats.org/officeDocument/2006/math">
                       <m:oMathParaPr>
@@ -8117,7 +8124,7 @@
               </p:txBody>
             </p:sp>
           </mc:Choice>
-          <mc:Fallback>
+          <mc:Fallback xmlns="">
             <p:sp>
               <p:nvSpPr>
                 <p:cNvPr id="119" name="TextBox 118">
@@ -8167,8 +8174,8 @@
             </p:sp>
           </mc:Fallback>
         </mc:AlternateContent>
-        <mc:AlternateContent xmlns:mc="http://schemas.openxmlformats.org/markup-compatibility/2006">
-          <mc:Choice xmlns:a14="http://schemas.microsoft.com/office/drawing/2010/main" Requires="a14">
+        <mc:AlternateContent xmlns:mc="http://schemas.openxmlformats.org/markup-compatibility/2006" xmlns:a14="http://schemas.microsoft.com/office/drawing/2010/main">
+          <mc:Choice Requires="a14">
             <p:sp>
               <p:nvSpPr>
                 <p:cNvPr id="120" name="TextBox 119">
@@ -8202,6 +8209,7 @@
                 </a:bodyPr>
                 <a:lstStyle/>
                 <a:p>
+                  <a:pPr/>
                   <a14:m>
                     <m:oMathPara xmlns:m="http://schemas.openxmlformats.org/officeDocument/2006/math">
                       <m:oMathParaPr>
@@ -8241,7 +8249,7 @@
               </p:txBody>
             </p:sp>
           </mc:Choice>
-          <mc:Fallback>
+          <mc:Fallback xmlns="">
             <p:sp>
               <p:nvSpPr>
                 <p:cNvPr id="120" name="TextBox 119">
@@ -8291,8 +8299,8 @@
             </p:sp>
           </mc:Fallback>
         </mc:AlternateContent>
-        <mc:AlternateContent xmlns:mc="http://schemas.openxmlformats.org/markup-compatibility/2006">
-          <mc:Choice xmlns:a14="http://schemas.microsoft.com/office/drawing/2010/main" Requires="a14">
+        <mc:AlternateContent xmlns:mc="http://schemas.openxmlformats.org/markup-compatibility/2006" xmlns:a14="http://schemas.microsoft.com/office/drawing/2010/main">
+          <mc:Choice Requires="a14">
             <p:sp>
               <p:nvSpPr>
                 <p:cNvPr id="121" name="TextBox 120">
@@ -8326,6 +8334,7 @@
                 </a:bodyPr>
                 <a:lstStyle/>
                 <a:p>
+                  <a:pPr/>
                   <a14:m>
                     <m:oMathPara xmlns:m="http://schemas.openxmlformats.org/officeDocument/2006/math">
                       <m:oMathParaPr>
@@ -8365,7 +8374,7 @@
               </p:txBody>
             </p:sp>
           </mc:Choice>
-          <mc:Fallback>
+          <mc:Fallback xmlns="">
             <p:sp>
               <p:nvSpPr>
                 <p:cNvPr id="121" name="TextBox 120">
@@ -8415,8 +8424,8 @@
             </p:sp>
           </mc:Fallback>
         </mc:AlternateContent>
-        <mc:AlternateContent xmlns:mc="http://schemas.openxmlformats.org/markup-compatibility/2006">
-          <mc:Choice xmlns:a14="http://schemas.microsoft.com/office/drawing/2010/main" Requires="a14">
+        <mc:AlternateContent xmlns:mc="http://schemas.openxmlformats.org/markup-compatibility/2006" xmlns:a14="http://schemas.microsoft.com/office/drawing/2010/main">
+          <mc:Choice Requires="a14">
             <p:sp>
               <p:nvSpPr>
                 <p:cNvPr id="122" name="TextBox 121">
@@ -8450,6 +8459,7 @@
                 </a:bodyPr>
                 <a:lstStyle/>
                 <a:p>
+                  <a:pPr/>
                   <a14:m>
                     <m:oMathPara xmlns:m="http://schemas.openxmlformats.org/officeDocument/2006/math">
                       <m:oMathParaPr>
@@ -8510,7 +8520,7 @@
               </p:txBody>
             </p:sp>
           </mc:Choice>
-          <mc:Fallback>
+          <mc:Fallback xmlns="">
             <p:sp>
               <p:nvSpPr>
                 <p:cNvPr id="122" name="TextBox 121">

</xml_diff>